<commit_message>
Office interior: rebuilt packed .blend/.glb with rug fix, verify_all.sh, finish swatches in deck, new finals
- delivered .blend/.glb rebuilt from current scripts; verification_results.md regenerated
  (67/67 textures packed in a lone copy, GLB re-import PASS, geometry 75/75)
- room slides 7-12 show key finishes cropped from the material board render
- leftover A-100 labels replaced; legacy phase 1 generators moved to phase1_shell_reference
- final renders so far: CAM_ISO_SE, CAM_04, CAM_01, CAM_09, CAM_07, CAM_11

Co-Authored-By: Claude Opus 5.5 <noreply@anthropic.com>
Claude-Session: https://claude.ai/code/session_019J6nTRSYGkqYLBQiQa9fAH
</commit_message>
<xml_diff>
--- a/GARMENT_OFFICE_FINAL_PRESENTATION/03_PRESENTATION/Garment_Office_Design_Pitch.pptx
+++ b/GARMENT_OFFICE_FINAL_PRESENTATION/03_PRESENTATION/Garment_Office_Design_Pitch.pptx
@@ -3167,7 +3167,7 @@
                 </a:solidFill>
                 <a:latin typeface="Inter"/>
               </a:rPr>
-              <a:t>Experience centre - Blender Cycles render of the project model (preview render)</a:t>
+              <a:t>Experience centre - Blender Cycles render of the project model</a:t>
             </a:r>
           </a:p>
         </p:txBody>
@@ -3604,21 +3604,21 @@
         <p:spPr>
           <a:xfrm>
             <a:off x="508000" y="863600"/>
-            <a:ext cx="3683000" cy="1270000"/>
-          </a:xfrm>
-          <a:prstGeom prst="rect">
-            <a:avLst/>
-          </a:prstGeom>
-          <a:noFill/>
-        </p:spPr>
-        <p:txBody>
-          <a:bodyPr wrap="square">
-            <a:spAutoFit/>
-          </a:bodyPr>
-          <a:lstStyle/>
-          <a:p>
-            <a:r>
-              <a:rPr sz="2600" b="1">
+            <a:ext cx="3683000" cy="1524000"/>
+          </a:xfrm>
+          <a:prstGeom prst="rect">
+            <a:avLst/>
+          </a:prstGeom>
+          <a:noFill/>
+        </p:spPr>
+        <p:txBody>
+          <a:bodyPr wrap="square">
+            <a:spAutoFit/>
+          </a:bodyPr>
+          <a:lstStyle/>
+          <a:p>
+            <a:r>
+              <a:rPr sz="2400" b="1">
                 <a:solidFill>
                   <a:srgbClr val="1E1E1C"/>
                 </a:solidFill>
@@ -3637,8 +3637,8 @@
         </p:nvSpPr>
         <p:spPr>
           <a:xfrm>
-            <a:off x="508000" y="2286000"/>
-            <a:ext cx="3683000" cy="4191000"/>
+            <a:off x="508000" y="2540000"/>
+            <a:ext cx="3683000" cy="2349500"/>
           </a:xfrm>
           <a:prstGeom prst="rect">
             <a:avLst/>
@@ -3714,13 +3714,47 @@
                 <a:latin typeface="Inter"/>
               </a:rPr>
               <a:t>- Power/data trough in the table; privacy curtains recommended on the glass</a:t>
+            </a:r>
+          </a:p>
+        </p:txBody>
+      </p:sp>
+      <p:sp>
+        <p:nvSpPr>
+          <p:cNvPr id="5" name="TextBox 4"/>
+          <p:cNvSpPr txBox="1"/>
+          <p:nvPr/>
+        </p:nvSpPr>
+        <p:spPr>
+          <a:xfrm>
+            <a:off x="508000" y="5016500"/>
+            <a:ext cx="3683000" cy="190500"/>
+          </a:xfrm>
+          <a:prstGeom prst="rect">
+            <a:avLst/>
+          </a:prstGeom>
+          <a:noFill/>
+        </p:spPr>
+        <p:txBody>
+          <a:bodyPr wrap="square">
+            <a:spAutoFit/>
+          </a:bodyPr>
+          <a:lstStyle/>
+          <a:p>
+            <a:r>
+              <a:rPr sz="1000" b="1">
+                <a:solidFill>
+                  <a:srgbClr val="26673D"/>
+                </a:solidFill>
+                <a:latin typeface="Inter"/>
+              </a:rPr>
+              <a:t>KEY FINISHES</a:t>
             </a:r>
           </a:p>
         </p:txBody>
       </p:sp>
       <p:pic>
         <p:nvPicPr>
-          <p:cNvPr id="5" name="Picture 4" descr="CAM_09_Boardroom_A.jpg"/>
+          <p:cNvPr id="6" name="Picture 5" descr="swatch_WD-01.jpg"/>
           <p:cNvPicPr>
             <a:picLocks noChangeAspect="1"/>
           </p:cNvPicPr>
@@ -3728,6 +3762,374 @@
         </p:nvPicPr>
         <p:blipFill>
           <a:blip r:embed="rId2"/>
+          <a:stretch>
+            <a:fillRect/>
+          </a:stretch>
+        </p:blipFill>
+        <p:spPr>
+          <a:xfrm>
+            <a:off x="508000" y="5245100"/>
+            <a:ext cx="793750" cy="660400"/>
+          </a:xfrm>
+          <a:prstGeom prst="rect">
+            <a:avLst/>
+          </a:prstGeom>
+        </p:spPr>
+      </p:pic>
+      <p:sp>
+        <p:nvSpPr>
+          <p:cNvPr id="7" name="TextBox 6"/>
+          <p:cNvSpPr txBox="1"/>
+          <p:nvPr/>
+        </p:nvSpPr>
+        <p:spPr>
+          <a:xfrm>
+            <a:off x="469900" y="5930900"/>
+            <a:ext cx="889000" cy="190500"/>
+          </a:xfrm>
+          <a:prstGeom prst="rect">
+            <a:avLst/>
+          </a:prstGeom>
+          <a:noFill/>
+        </p:spPr>
+        <p:txBody>
+          <a:bodyPr wrap="square">
+            <a:spAutoFit/>
+          </a:bodyPr>
+          <a:lstStyle/>
+          <a:p>
+            <a:r>
+              <a:rPr sz="1000" b="1">
+                <a:solidFill>
+                  <a:srgbClr val="26673D"/>
+                </a:solidFill>
+                <a:latin typeface="Inter"/>
+              </a:rPr>
+              <a:t>WD-01</a:t>
+            </a:r>
+          </a:p>
+        </p:txBody>
+      </p:sp>
+      <p:sp>
+        <p:nvSpPr>
+          <p:cNvPr id="8" name="TextBox 7"/>
+          <p:cNvSpPr txBox="1"/>
+          <p:nvPr/>
+        </p:nvSpPr>
+        <p:spPr>
+          <a:xfrm>
+            <a:off x="469900" y="6096000"/>
+            <a:ext cx="889000" cy="317500"/>
+          </a:xfrm>
+          <a:prstGeom prst="rect">
+            <a:avLst/>
+          </a:prstGeom>
+          <a:noFill/>
+        </p:spPr>
+        <p:txBody>
+          <a:bodyPr wrap="square">
+            <a:spAutoFit/>
+          </a:bodyPr>
+          <a:lstStyle/>
+          <a:p>
+            <a:r>
+              <a:rPr sz="900" b="0">
+                <a:solidFill>
+                  <a:srgbClr val="5A5750"/>
+                </a:solidFill>
+                <a:latin typeface="Inter"/>
+              </a:rPr>
+              <a:t>Oak herringbone</a:t>
+            </a:r>
+          </a:p>
+        </p:txBody>
+      </p:sp>
+      <p:pic>
+        <p:nvPicPr>
+          <p:cNvPr id="9" name="Picture 8" descr="swatch_WO-02.jpg"/>
+          <p:cNvPicPr>
+            <a:picLocks noChangeAspect="1"/>
+          </p:cNvPicPr>
+          <p:nvPr/>
+        </p:nvPicPr>
+        <p:blipFill>
+          <a:blip r:embed="rId3"/>
+          <a:stretch>
+            <a:fillRect/>
+          </a:stretch>
+        </p:blipFill>
+        <p:spPr>
+          <a:xfrm>
+            <a:off x="1428750" y="5245100"/>
+            <a:ext cx="793750" cy="660400"/>
+          </a:xfrm>
+          <a:prstGeom prst="rect">
+            <a:avLst/>
+          </a:prstGeom>
+        </p:spPr>
+      </p:pic>
+      <p:sp>
+        <p:nvSpPr>
+          <p:cNvPr id="10" name="TextBox 9"/>
+          <p:cNvSpPr txBox="1"/>
+          <p:nvPr/>
+        </p:nvSpPr>
+        <p:spPr>
+          <a:xfrm>
+            <a:off x="1390650" y="5930900"/>
+            <a:ext cx="889000" cy="190500"/>
+          </a:xfrm>
+          <a:prstGeom prst="rect">
+            <a:avLst/>
+          </a:prstGeom>
+          <a:noFill/>
+        </p:spPr>
+        <p:txBody>
+          <a:bodyPr wrap="square">
+            <a:spAutoFit/>
+          </a:bodyPr>
+          <a:lstStyle/>
+          <a:p>
+            <a:r>
+              <a:rPr sz="1000" b="1">
+                <a:solidFill>
+                  <a:srgbClr val="26673D"/>
+                </a:solidFill>
+                <a:latin typeface="Inter"/>
+              </a:rPr>
+              <a:t>WO-02</a:t>
+            </a:r>
+          </a:p>
+        </p:txBody>
+      </p:sp>
+      <p:sp>
+        <p:nvSpPr>
+          <p:cNvPr id="11" name="TextBox 10"/>
+          <p:cNvSpPr txBox="1"/>
+          <p:nvPr/>
+        </p:nvSpPr>
+        <p:spPr>
+          <a:xfrm>
+            <a:off x="1390650" y="6096000"/>
+            <a:ext cx="889000" cy="317500"/>
+          </a:xfrm>
+          <a:prstGeom prst="rect">
+            <a:avLst/>
+          </a:prstGeom>
+          <a:noFill/>
+        </p:spPr>
+        <p:txBody>
+          <a:bodyPr wrap="square">
+            <a:spAutoFit/>
+          </a:bodyPr>
+          <a:lstStyle/>
+          <a:p>
+            <a:r>
+              <a:rPr sz="900" b="0">
+                <a:solidFill>
+                  <a:srgbClr val="5A5750"/>
+                </a:solidFill>
+                <a:latin typeface="Inter"/>
+              </a:rPr>
+              <a:t>Smoked walnut</a:t>
+            </a:r>
+          </a:p>
+        </p:txBody>
+      </p:sp>
+      <p:pic>
+        <p:nvPicPr>
+          <p:cNvPr id="12" name="Picture 11" descr="swatch_AC-01.jpg"/>
+          <p:cNvPicPr>
+            <a:picLocks noChangeAspect="1"/>
+          </p:cNvPicPr>
+          <p:nvPr/>
+        </p:nvPicPr>
+        <p:blipFill>
+          <a:blip r:embed="rId4"/>
+          <a:stretch>
+            <a:fillRect/>
+          </a:stretch>
+        </p:blipFill>
+        <p:spPr>
+          <a:xfrm>
+            <a:off x="2349500" y="5245100"/>
+            <a:ext cx="793750" cy="660400"/>
+          </a:xfrm>
+          <a:prstGeom prst="rect">
+            <a:avLst/>
+          </a:prstGeom>
+        </p:spPr>
+      </p:pic>
+      <p:sp>
+        <p:nvSpPr>
+          <p:cNvPr id="13" name="TextBox 12"/>
+          <p:cNvSpPr txBox="1"/>
+          <p:nvPr/>
+        </p:nvSpPr>
+        <p:spPr>
+          <a:xfrm>
+            <a:off x="2311400" y="5930900"/>
+            <a:ext cx="889000" cy="190500"/>
+          </a:xfrm>
+          <a:prstGeom prst="rect">
+            <a:avLst/>
+          </a:prstGeom>
+          <a:noFill/>
+        </p:spPr>
+        <p:txBody>
+          <a:bodyPr wrap="square">
+            <a:spAutoFit/>
+          </a:bodyPr>
+          <a:lstStyle/>
+          <a:p>
+            <a:r>
+              <a:rPr sz="1000" b="1">
+                <a:solidFill>
+                  <a:srgbClr val="26673D"/>
+                </a:solidFill>
+                <a:latin typeface="Inter"/>
+              </a:rPr>
+              <a:t>AC-01</a:t>
+            </a:r>
+          </a:p>
+        </p:txBody>
+      </p:sp>
+      <p:sp>
+        <p:nvSpPr>
+          <p:cNvPr id="14" name="TextBox 13"/>
+          <p:cNvSpPr txBox="1"/>
+          <p:nvPr/>
+        </p:nvSpPr>
+        <p:spPr>
+          <a:xfrm>
+            <a:off x="2311400" y="6096000"/>
+            <a:ext cx="889000" cy="317500"/>
+          </a:xfrm>
+          <a:prstGeom prst="rect">
+            <a:avLst/>
+          </a:prstGeom>
+          <a:noFill/>
+        </p:spPr>
+        <p:txBody>
+          <a:bodyPr wrap="square">
+            <a:spAutoFit/>
+          </a:bodyPr>
+          <a:lstStyle/>
+          <a:p>
+            <a:r>
+              <a:rPr sz="900" b="0">
+                <a:solidFill>
+                  <a:srgbClr val="5A5750"/>
+                </a:solidFill>
+                <a:latin typeface="Inter"/>
+              </a:rPr>
+              <a:t>Acoustic felt</a:t>
+            </a:r>
+          </a:p>
+        </p:txBody>
+      </p:sp>
+      <p:pic>
+        <p:nvPicPr>
+          <p:cNvPr id="15" name="Picture 14" descr="swatch_WO-01.jpg"/>
+          <p:cNvPicPr>
+            <a:picLocks noChangeAspect="1"/>
+          </p:cNvPicPr>
+          <p:nvPr/>
+        </p:nvPicPr>
+        <p:blipFill>
+          <a:blip r:embed="rId5"/>
+          <a:stretch>
+            <a:fillRect/>
+          </a:stretch>
+        </p:blipFill>
+        <p:spPr>
+          <a:xfrm>
+            <a:off x="3270250" y="5245100"/>
+            <a:ext cx="793750" cy="660400"/>
+          </a:xfrm>
+          <a:prstGeom prst="rect">
+            <a:avLst/>
+          </a:prstGeom>
+        </p:spPr>
+      </p:pic>
+      <p:sp>
+        <p:nvSpPr>
+          <p:cNvPr id="16" name="TextBox 15"/>
+          <p:cNvSpPr txBox="1"/>
+          <p:nvPr/>
+        </p:nvSpPr>
+        <p:spPr>
+          <a:xfrm>
+            <a:off x="3232150" y="5930900"/>
+            <a:ext cx="889000" cy="190500"/>
+          </a:xfrm>
+          <a:prstGeom prst="rect">
+            <a:avLst/>
+          </a:prstGeom>
+          <a:noFill/>
+        </p:spPr>
+        <p:txBody>
+          <a:bodyPr wrap="square">
+            <a:spAutoFit/>
+          </a:bodyPr>
+          <a:lstStyle/>
+          <a:p>
+            <a:r>
+              <a:rPr sz="1000" b="1">
+                <a:solidFill>
+                  <a:srgbClr val="26673D"/>
+                </a:solidFill>
+                <a:latin typeface="Inter"/>
+              </a:rPr>
+              <a:t>WO-01</a:t>
+            </a:r>
+          </a:p>
+        </p:txBody>
+      </p:sp>
+      <p:sp>
+        <p:nvSpPr>
+          <p:cNvPr id="17" name="TextBox 16"/>
+          <p:cNvSpPr txBox="1"/>
+          <p:nvPr/>
+        </p:nvSpPr>
+        <p:spPr>
+          <a:xfrm>
+            <a:off x="3232150" y="6096000"/>
+            <a:ext cx="889000" cy="317500"/>
+          </a:xfrm>
+          <a:prstGeom prst="rect">
+            <a:avLst/>
+          </a:prstGeom>
+          <a:noFill/>
+        </p:spPr>
+        <p:txBody>
+          <a:bodyPr wrap="square">
+            <a:spAutoFit/>
+          </a:bodyPr>
+          <a:lstStyle/>
+          <a:p>
+            <a:r>
+              <a:rPr sz="900" b="0">
+                <a:solidFill>
+                  <a:srgbClr val="5A5750"/>
+                </a:solidFill>
+                <a:latin typeface="Inter"/>
+              </a:rPr>
+              <a:t>White-oak slats</a:t>
+            </a:r>
+          </a:p>
+        </p:txBody>
+      </p:sp>
+      <p:pic>
+        <p:nvPicPr>
+          <p:cNvPr id="18" name="Picture 17" descr="CAM_09_Boardroom_A.jpg"/>
+          <p:cNvPicPr>
+            <a:picLocks noChangeAspect="1"/>
+          </p:cNvPicPr>
+          <p:nvPr/>
+        </p:nvPicPr>
+        <p:blipFill>
+          <a:blip r:embed="rId6"/>
           <a:srcRect t="15692" b="15692"/>
           <a:stretch>
             <a:fillRect/>
@@ -3745,7 +4147,7 @@
       </p:pic>
       <p:sp>
         <p:nvSpPr>
-          <p:cNvPr id="6" name="TextBox 5"/>
+          <p:cNvPr id="19" name="TextBox 18"/>
           <p:cNvSpPr txBox="1"/>
           <p:nvPr/>
         </p:nvSpPr>
@@ -3772,21 +4174,21 @@
                 </a:solidFill>
                 <a:latin typeface="Inter"/>
               </a:rPr>
-              <a:t>Boardroom (preview render)</a:t>
+              <a:t>Boardroom</a:t>
             </a:r>
           </a:p>
         </p:txBody>
       </p:sp>
       <p:pic>
         <p:nvPicPr>
-          <p:cNvPr id="7" name="Picture 6" descr="CAM_10_Boardroom_B.jpg"/>
+          <p:cNvPr id="20" name="Picture 19" descr="CAM_10_Boardroom_B.jpg"/>
           <p:cNvPicPr>
             <a:picLocks noChangeAspect="1"/>
           </p:cNvPicPr>
           <p:nvPr/>
         </p:nvPicPr>
         <p:blipFill>
-          <a:blip r:embed="rId3"/>
+          <a:blip r:embed="rId7"/>
           <a:srcRect t="15692" b="15692"/>
           <a:stretch>
             <a:fillRect/>
@@ -3804,7 +4206,7 @@
       </p:pic>
       <p:sp>
         <p:nvSpPr>
-          <p:cNvPr id="8" name="TextBox 7"/>
+          <p:cNvPr id="21" name="TextBox 20"/>
           <p:cNvSpPr txBox="1"/>
           <p:nvPr/>
         </p:nvSpPr>
@@ -3838,7 +4240,7 @@
       </p:sp>
       <p:sp>
         <p:nvSpPr>
-          <p:cNvPr id="9" name="TextBox 8"/>
+          <p:cNvPr id="22" name="TextBox 21"/>
           <p:cNvSpPr txBox="1"/>
           <p:nvPr/>
         </p:nvSpPr>
@@ -3872,7 +4274,7 @@
       </p:sp>
       <p:sp>
         <p:nvSpPr>
-          <p:cNvPr id="10" name="TextBox 9"/>
+          <p:cNvPr id="23" name="TextBox 22"/>
           <p:cNvSpPr txBox="1"/>
           <p:nvPr/>
         </p:nvSpPr>
@@ -3973,21 +4375,21 @@
         <p:spPr>
           <a:xfrm>
             <a:off x="508000" y="863600"/>
-            <a:ext cx="3683000" cy="1270000"/>
-          </a:xfrm>
-          <a:prstGeom prst="rect">
-            <a:avLst/>
-          </a:prstGeom>
-          <a:noFill/>
-        </p:spPr>
-        <p:txBody>
-          <a:bodyPr wrap="square">
-            <a:spAutoFit/>
-          </a:bodyPr>
-          <a:lstStyle/>
-          <a:p>
-            <a:r>
-              <a:rPr sz="2600" b="1">
+            <a:ext cx="3683000" cy="1524000"/>
+          </a:xfrm>
+          <a:prstGeom prst="rect">
+            <a:avLst/>
+          </a:prstGeom>
+          <a:noFill/>
+        </p:spPr>
+        <p:txBody>
+          <a:bodyPr wrap="square">
+            <a:spAutoFit/>
+          </a:bodyPr>
+          <a:lstStyle/>
+          <a:p>
+            <a:r>
+              <a:rPr sz="2400" b="1">
                 <a:solidFill>
                   <a:srgbClr val="1E1E1C"/>
                 </a:solidFill>
@@ -4006,8 +4408,8 @@
         </p:nvSpPr>
         <p:spPr>
           <a:xfrm>
-            <a:off x="508000" y="2286000"/>
-            <a:ext cx="3683000" cy="4191000"/>
+            <a:off x="508000" y="2540000"/>
+            <a:ext cx="3683000" cy="2349500"/>
           </a:xfrm>
           <a:prstGeom prst="rect">
             <a:avLst/>
@@ -4083,13 +4485,47 @@
                 <a:latin typeface="Inter"/>
               </a:rPr>
               <a:t>- Felt baffles between the beams, 4000 K linear light</a:t>
+            </a:r>
+          </a:p>
+        </p:txBody>
+      </p:sp>
+      <p:sp>
+        <p:nvSpPr>
+          <p:cNvPr id="5" name="TextBox 4"/>
+          <p:cNvSpPr txBox="1"/>
+          <p:nvPr/>
+        </p:nvSpPr>
+        <p:spPr>
+          <a:xfrm>
+            <a:off x="508000" y="5016500"/>
+            <a:ext cx="3683000" cy="190500"/>
+          </a:xfrm>
+          <a:prstGeom prst="rect">
+            <a:avLst/>
+          </a:prstGeom>
+          <a:noFill/>
+        </p:spPr>
+        <p:txBody>
+          <a:bodyPr wrap="square">
+            <a:spAutoFit/>
+          </a:bodyPr>
+          <a:lstStyle/>
+          <a:p>
+            <a:r>
+              <a:rPr sz="1000" b="1">
+                <a:solidFill>
+                  <a:srgbClr val="26673D"/>
+                </a:solidFill>
+                <a:latin typeface="Inter"/>
+              </a:rPr>
+              <a:t>KEY FINISHES</a:t>
             </a:r>
           </a:p>
         </p:txBody>
       </p:sp>
       <p:pic>
         <p:nvPicPr>
-          <p:cNvPr id="5" name="Picture 4" descr="CAM_11_Merchandising_A.jpg"/>
+          <p:cNvPr id="6" name="Picture 5" descr="swatch_CP-01.jpg"/>
           <p:cNvPicPr>
             <a:picLocks noChangeAspect="1"/>
           </p:cNvPicPr>
@@ -4097,6 +4533,374 @@
         </p:nvPicPr>
         <p:blipFill>
           <a:blip r:embed="rId2"/>
+          <a:stretch>
+            <a:fillRect/>
+          </a:stretch>
+        </p:blipFill>
+        <p:spPr>
+          <a:xfrm>
+            <a:off x="508000" y="5245100"/>
+            <a:ext cx="793750" cy="660400"/>
+          </a:xfrm>
+          <a:prstGeom prst="rect">
+            <a:avLst/>
+          </a:prstGeom>
+        </p:spPr>
+      </p:pic>
+      <p:sp>
+        <p:nvSpPr>
+          <p:cNvPr id="7" name="TextBox 6"/>
+          <p:cNvSpPr txBox="1"/>
+          <p:nvPr/>
+        </p:nvSpPr>
+        <p:spPr>
+          <a:xfrm>
+            <a:off x="469900" y="5930900"/>
+            <a:ext cx="889000" cy="190500"/>
+          </a:xfrm>
+          <a:prstGeom prst="rect">
+            <a:avLst/>
+          </a:prstGeom>
+          <a:noFill/>
+        </p:spPr>
+        <p:txBody>
+          <a:bodyPr wrap="square">
+            <a:spAutoFit/>
+          </a:bodyPr>
+          <a:lstStyle/>
+          <a:p>
+            <a:r>
+              <a:rPr sz="1000" b="1">
+                <a:solidFill>
+                  <a:srgbClr val="26673D"/>
+                </a:solidFill>
+                <a:latin typeface="Inter"/>
+              </a:rPr>
+              <a:t>CP-01</a:t>
+            </a:r>
+          </a:p>
+        </p:txBody>
+      </p:sp>
+      <p:sp>
+        <p:nvSpPr>
+          <p:cNvPr id="8" name="TextBox 7"/>
+          <p:cNvSpPr txBox="1"/>
+          <p:nvPr/>
+        </p:nvSpPr>
+        <p:spPr>
+          <a:xfrm>
+            <a:off x="469900" y="6096000"/>
+            <a:ext cx="889000" cy="317500"/>
+          </a:xfrm>
+          <a:prstGeom prst="rect">
+            <a:avLst/>
+          </a:prstGeom>
+          <a:noFill/>
+        </p:spPr>
+        <p:txBody>
+          <a:bodyPr wrap="square">
+            <a:spAutoFit/>
+          </a:bodyPr>
+          <a:lstStyle/>
+          <a:p>
+            <a:r>
+              <a:rPr sz="900" b="0">
+                <a:solidFill>
+                  <a:srgbClr val="5A5750"/>
+                </a:solidFill>
+                <a:latin typeface="Inter"/>
+              </a:rPr>
+              <a:t>Carpet tile</a:t>
+            </a:r>
+          </a:p>
+        </p:txBody>
+      </p:sp>
+      <p:pic>
+        <p:nvPicPr>
+          <p:cNvPr id="9" name="Picture 8" descr="swatch_AC-01.jpg"/>
+          <p:cNvPicPr>
+            <a:picLocks noChangeAspect="1"/>
+          </p:cNvPicPr>
+          <p:nvPr/>
+        </p:nvPicPr>
+        <p:blipFill>
+          <a:blip r:embed="rId3"/>
+          <a:stretch>
+            <a:fillRect/>
+          </a:stretch>
+        </p:blipFill>
+        <p:spPr>
+          <a:xfrm>
+            <a:off x="1428750" y="5245100"/>
+            <a:ext cx="793750" cy="660400"/>
+          </a:xfrm>
+          <a:prstGeom prst="rect">
+            <a:avLst/>
+          </a:prstGeom>
+        </p:spPr>
+      </p:pic>
+      <p:sp>
+        <p:nvSpPr>
+          <p:cNvPr id="10" name="TextBox 9"/>
+          <p:cNvSpPr txBox="1"/>
+          <p:nvPr/>
+        </p:nvSpPr>
+        <p:spPr>
+          <a:xfrm>
+            <a:off x="1390650" y="5930900"/>
+            <a:ext cx="889000" cy="190500"/>
+          </a:xfrm>
+          <a:prstGeom prst="rect">
+            <a:avLst/>
+          </a:prstGeom>
+          <a:noFill/>
+        </p:spPr>
+        <p:txBody>
+          <a:bodyPr wrap="square">
+            <a:spAutoFit/>
+          </a:bodyPr>
+          <a:lstStyle/>
+          <a:p>
+            <a:r>
+              <a:rPr sz="1000" b="1">
+                <a:solidFill>
+                  <a:srgbClr val="26673D"/>
+                </a:solidFill>
+                <a:latin typeface="Inter"/>
+              </a:rPr>
+              <a:t>AC-01</a:t>
+            </a:r>
+          </a:p>
+        </p:txBody>
+      </p:sp>
+      <p:sp>
+        <p:nvSpPr>
+          <p:cNvPr id="11" name="TextBox 10"/>
+          <p:cNvSpPr txBox="1"/>
+          <p:nvPr/>
+        </p:nvSpPr>
+        <p:spPr>
+          <a:xfrm>
+            <a:off x="1390650" y="6096000"/>
+            <a:ext cx="889000" cy="317500"/>
+          </a:xfrm>
+          <a:prstGeom prst="rect">
+            <a:avLst/>
+          </a:prstGeom>
+          <a:noFill/>
+        </p:spPr>
+        <p:txBody>
+          <a:bodyPr wrap="square">
+            <a:spAutoFit/>
+          </a:bodyPr>
+          <a:lstStyle/>
+          <a:p>
+            <a:r>
+              <a:rPr sz="900" b="0">
+                <a:solidFill>
+                  <a:srgbClr val="5A5750"/>
+                </a:solidFill>
+                <a:latin typeface="Inter"/>
+              </a:rPr>
+              <a:t>Acoustic felt</a:t>
+            </a:r>
+          </a:p>
+        </p:txBody>
+      </p:sp>
+      <p:pic>
+        <p:nvPicPr>
+          <p:cNvPr id="12" name="Picture 11" descr="swatch_UP-01g.jpg"/>
+          <p:cNvPicPr>
+            <a:picLocks noChangeAspect="1"/>
+          </p:cNvPicPr>
+          <p:nvPr/>
+        </p:nvPicPr>
+        <p:blipFill>
+          <a:blip r:embed="rId4"/>
+          <a:stretch>
+            <a:fillRect/>
+          </a:stretch>
+        </p:blipFill>
+        <p:spPr>
+          <a:xfrm>
+            <a:off x="2349500" y="5245100"/>
+            <a:ext cx="793750" cy="660400"/>
+          </a:xfrm>
+          <a:prstGeom prst="rect">
+            <a:avLst/>
+          </a:prstGeom>
+        </p:spPr>
+      </p:pic>
+      <p:sp>
+        <p:nvSpPr>
+          <p:cNvPr id="13" name="TextBox 12"/>
+          <p:cNvSpPr txBox="1"/>
+          <p:nvPr/>
+        </p:nvSpPr>
+        <p:spPr>
+          <a:xfrm>
+            <a:off x="2311400" y="5930900"/>
+            <a:ext cx="889000" cy="190500"/>
+          </a:xfrm>
+          <a:prstGeom prst="rect">
+            <a:avLst/>
+          </a:prstGeom>
+          <a:noFill/>
+        </p:spPr>
+        <p:txBody>
+          <a:bodyPr wrap="square">
+            <a:spAutoFit/>
+          </a:bodyPr>
+          <a:lstStyle/>
+          <a:p>
+            <a:r>
+              <a:rPr sz="1000" b="1">
+                <a:solidFill>
+                  <a:srgbClr val="26673D"/>
+                </a:solidFill>
+                <a:latin typeface="Inter"/>
+              </a:rPr>
+              <a:t>UP-01</a:t>
+            </a:r>
+          </a:p>
+        </p:txBody>
+      </p:sp>
+      <p:sp>
+        <p:nvSpPr>
+          <p:cNvPr id="14" name="TextBox 13"/>
+          <p:cNvSpPr txBox="1"/>
+          <p:nvPr/>
+        </p:nvSpPr>
+        <p:spPr>
+          <a:xfrm>
+            <a:off x="2311400" y="6096000"/>
+            <a:ext cx="889000" cy="317500"/>
+          </a:xfrm>
+          <a:prstGeom prst="rect">
+            <a:avLst/>
+          </a:prstGeom>
+          <a:noFill/>
+        </p:spPr>
+        <p:txBody>
+          <a:bodyPr wrap="square">
+            <a:spAutoFit/>
+          </a:bodyPr>
+          <a:lstStyle/>
+          <a:p>
+            <a:r>
+              <a:rPr sz="900" b="0">
+                <a:solidFill>
+                  <a:srgbClr val="5A5750"/>
+                </a:solidFill>
+                <a:latin typeface="Inter"/>
+              </a:rPr>
+              <a:t>Green fabric</a:t>
+            </a:r>
+          </a:p>
+        </p:txBody>
+      </p:sp>
+      <p:pic>
+        <p:nvPicPr>
+          <p:cNvPr id="15" name="Picture 14" descr="swatch_PA-01.jpg"/>
+          <p:cNvPicPr>
+            <a:picLocks noChangeAspect="1"/>
+          </p:cNvPicPr>
+          <p:nvPr/>
+        </p:nvPicPr>
+        <p:blipFill>
+          <a:blip r:embed="rId5"/>
+          <a:stretch>
+            <a:fillRect/>
+          </a:stretch>
+        </p:blipFill>
+        <p:spPr>
+          <a:xfrm>
+            <a:off x="3270250" y="5245100"/>
+            <a:ext cx="793750" cy="660400"/>
+          </a:xfrm>
+          <a:prstGeom prst="rect">
+            <a:avLst/>
+          </a:prstGeom>
+        </p:spPr>
+      </p:pic>
+      <p:sp>
+        <p:nvSpPr>
+          <p:cNvPr id="16" name="TextBox 15"/>
+          <p:cNvSpPr txBox="1"/>
+          <p:nvPr/>
+        </p:nvSpPr>
+        <p:spPr>
+          <a:xfrm>
+            <a:off x="3232150" y="5930900"/>
+            <a:ext cx="889000" cy="190500"/>
+          </a:xfrm>
+          <a:prstGeom prst="rect">
+            <a:avLst/>
+          </a:prstGeom>
+          <a:noFill/>
+        </p:spPr>
+        <p:txBody>
+          <a:bodyPr wrap="square">
+            <a:spAutoFit/>
+          </a:bodyPr>
+          <a:lstStyle/>
+          <a:p>
+            <a:r>
+              <a:rPr sz="1000" b="1">
+                <a:solidFill>
+                  <a:srgbClr val="26673D"/>
+                </a:solidFill>
+                <a:latin typeface="Inter"/>
+              </a:rPr>
+              <a:t>PA-01</a:t>
+            </a:r>
+          </a:p>
+        </p:txBody>
+      </p:sp>
+      <p:sp>
+        <p:nvSpPr>
+          <p:cNvPr id="17" name="TextBox 16"/>
+          <p:cNvSpPr txBox="1"/>
+          <p:nvPr/>
+        </p:nvSpPr>
+        <p:spPr>
+          <a:xfrm>
+            <a:off x="3232150" y="6096000"/>
+            <a:ext cx="889000" cy="317500"/>
+          </a:xfrm>
+          <a:prstGeom prst="rect">
+            <a:avLst/>
+          </a:prstGeom>
+          <a:noFill/>
+        </p:spPr>
+        <p:txBody>
+          <a:bodyPr wrap="square">
+            <a:spAutoFit/>
+          </a:bodyPr>
+          <a:lstStyle/>
+          <a:p>
+            <a:r>
+              <a:rPr sz="900" b="0">
+                <a:solidFill>
+                  <a:srgbClr val="5A5750"/>
+                </a:solidFill>
+                <a:latin typeface="Inter"/>
+              </a:rPr>
+              <a:t>Warm white paint</a:t>
+            </a:r>
+          </a:p>
+        </p:txBody>
+      </p:sp>
+      <p:pic>
+        <p:nvPicPr>
+          <p:cNvPr id="18" name="Picture 17" descr="CAM_11_Merchandising_A.jpg"/>
+          <p:cNvPicPr>
+            <a:picLocks noChangeAspect="1"/>
+          </p:cNvPicPr>
+          <p:nvPr/>
+        </p:nvPicPr>
+        <p:blipFill>
+          <a:blip r:embed="rId6"/>
           <a:srcRect t="6335" b="6335"/>
           <a:stretch>
             <a:fillRect/>
@@ -4114,7 +4918,7 @@
       </p:pic>
       <p:sp>
         <p:nvSpPr>
-          <p:cNvPr id="6" name="TextBox 5"/>
+          <p:cNvPr id="19" name="TextBox 18"/>
           <p:cNvSpPr txBox="1"/>
           <p:nvPr/>
         </p:nvSpPr>
@@ -4141,21 +4945,21 @@
                 </a:solidFill>
                 <a:latin typeface="Inter"/>
               </a:rPr>
-              <a:t>Merchandising open office (preview render)</a:t>
+              <a:t>Merchandising open office</a:t>
             </a:r>
           </a:p>
         </p:txBody>
       </p:sp>
       <p:pic>
         <p:nvPicPr>
-          <p:cNvPr id="7" name="Picture 6" descr="CAM_12_Merchandising_B.jpg"/>
+          <p:cNvPr id="20" name="Picture 19" descr="CAM_12_Merchandising_B.jpg"/>
           <p:cNvPicPr>
             <a:picLocks noChangeAspect="1"/>
           </p:cNvPicPr>
           <p:nvPr/>
         </p:nvPicPr>
         <p:blipFill>
-          <a:blip r:embed="rId3"/>
+          <a:blip r:embed="rId7"/>
           <a:srcRect l="605" r="605"/>
           <a:stretch>
             <a:fillRect/>
@@ -4173,7 +4977,7 @@
       </p:pic>
       <p:sp>
         <p:nvSpPr>
-          <p:cNvPr id="8" name="TextBox 7"/>
+          <p:cNvPr id="21" name="TextBox 20"/>
           <p:cNvSpPr txBox="1"/>
           <p:nvPr/>
         </p:nvSpPr>
@@ -4207,14 +5011,14 @@
       </p:sp>
       <p:pic>
         <p:nvPicPr>
-          <p:cNvPr id="9" name="Picture 8" descr="CAM_16_Commercial_Accounts.jpg"/>
+          <p:cNvPr id="22" name="Picture 21" descr="CAM_16_Commercial_Accounts.jpg"/>
           <p:cNvPicPr>
             <a:picLocks noChangeAspect="1"/>
           </p:cNvPicPr>
           <p:nvPr/>
         </p:nvPicPr>
         <p:blipFill>
-          <a:blip r:embed="rId4"/>
+          <a:blip r:embed="rId8"/>
           <a:srcRect l="605" r="605"/>
           <a:stretch>
             <a:fillRect/>
@@ -4232,7 +5036,7 @@
       </p:pic>
       <p:sp>
         <p:nvSpPr>
-          <p:cNvPr id="10" name="TextBox 9"/>
+          <p:cNvPr id="23" name="TextBox 22"/>
           <p:cNvSpPr txBox="1"/>
           <p:nvPr/>
         </p:nvSpPr>
@@ -4266,7 +5070,7 @@
       </p:sp>
       <p:sp>
         <p:nvSpPr>
-          <p:cNvPr id="11" name="TextBox 10"/>
+          <p:cNvPr id="24" name="TextBox 23"/>
           <p:cNvSpPr txBox="1"/>
           <p:nvPr/>
         </p:nvSpPr>
@@ -4300,7 +5104,7 @@
       </p:sp>
       <p:sp>
         <p:nvSpPr>
-          <p:cNvPr id="12" name="TextBox 11"/>
+          <p:cNvPr id="25" name="TextBox 24"/>
           <p:cNvSpPr txBox="1"/>
           <p:nvPr/>
         </p:nvSpPr>
@@ -4401,21 +5205,21 @@
         <p:spPr>
           <a:xfrm>
             <a:off x="508000" y="863600"/>
-            <a:ext cx="3683000" cy="1270000"/>
-          </a:xfrm>
-          <a:prstGeom prst="rect">
-            <a:avLst/>
-          </a:prstGeom>
-          <a:noFill/>
-        </p:spPr>
-        <p:txBody>
-          <a:bodyPr wrap="square">
-            <a:spAutoFit/>
-          </a:bodyPr>
-          <a:lstStyle/>
-          <a:p>
-            <a:r>
-              <a:rPr sz="2600" b="1">
+            <a:ext cx="3683000" cy="1524000"/>
+          </a:xfrm>
+          <a:prstGeom prst="rect">
+            <a:avLst/>
+          </a:prstGeom>
+          <a:noFill/>
+        </p:spPr>
+        <p:txBody>
+          <a:bodyPr wrap="square">
+            <a:spAutoFit/>
+          </a:bodyPr>
+          <a:lstStyle/>
+          <a:p>
+            <a:r>
+              <a:rPr sz="2400" b="1">
                 <a:solidFill>
                   <a:srgbClr val="1E1E1C"/>
                 </a:solidFill>
@@ -4434,8 +5238,8 @@
         </p:nvSpPr>
         <p:spPr>
           <a:xfrm>
-            <a:off x="508000" y="2286000"/>
-            <a:ext cx="3683000" cy="4191000"/>
+            <a:off x="508000" y="2540000"/>
+            <a:ext cx="3683000" cy="2349500"/>
           </a:xfrm>
           <a:prstGeom prst="rect">
             <a:avLst/>
@@ -4522,13 +5326,47 @@
                 <a:latin typeface="Inter"/>
               </a:rPr>
               <a:t>- 3D printing lab and sample room as office-grade support</a:t>
+            </a:r>
+          </a:p>
+        </p:txBody>
+      </p:sp>
+      <p:sp>
+        <p:nvSpPr>
+          <p:cNvPr id="5" name="TextBox 4"/>
+          <p:cNvSpPr txBox="1"/>
+          <p:nvPr/>
+        </p:nvSpPr>
+        <p:spPr>
+          <a:xfrm>
+            <a:off x="508000" y="5016500"/>
+            <a:ext cx="3683000" cy="190500"/>
+          </a:xfrm>
+          <a:prstGeom prst="rect">
+            <a:avLst/>
+          </a:prstGeom>
+          <a:noFill/>
+        </p:spPr>
+        <p:txBody>
+          <a:bodyPr wrap="square">
+            <a:spAutoFit/>
+          </a:bodyPr>
+          <a:lstStyle/>
+          <a:p>
+            <a:r>
+              <a:rPr sz="1000" b="1">
+                <a:solidFill>
+                  <a:srgbClr val="26673D"/>
+                </a:solidFill>
+                <a:latin typeface="Inter"/>
+              </a:rPr>
+              <a:t>KEY FINISHES</a:t>
             </a:r>
           </a:p>
         </p:txBody>
       </p:sp>
       <p:pic>
         <p:nvPicPr>
-          <p:cNvPr id="5" name="Picture 4" descr="CAM_13_Design_Studio_A.jpg"/>
+          <p:cNvPr id="6" name="Picture 5" descr="swatch_WD-02.jpg"/>
           <p:cNvPicPr>
             <a:picLocks noChangeAspect="1"/>
           </p:cNvPicPr>
@@ -4536,6 +5374,374 @@
         </p:nvPicPr>
         <p:blipFill>
           <a:blip r:embed="rId2"/>
+          <a:stretch>
+            <a:fillRect/>
+          </a:stretch>
+        </p:blipFill>
+        <p:spPr>
+          <a:xfrm>
+            <a:off x="508000" y="5245100"/>
+            <a:ext cx="793750" cy="660400"/>
+          </a:xfrm>
+          <a:prstGeom prst="rect">
+            <a:avLst/>
+          </a:prstGeom>
+        </p:spPr>
+      </p:pic>
+      <p:sp>
+        <p:nvSpPr>
+          <p:cNvPr id="7" name="TextBox 6"/>
+          <p:cNvSpPr txBox="1"/>
+          <p:nvPr/>
+        </p:nvSpPr>
+        <p:spPr>
+          <a:xfrm>
+            <a:off x="469900" y="5930900"/>
+            <a:ext cx="889000" cy="190500"/>
+          </a:xfrm>
+          <a:prstGeom prst="rect">
+            <a:avLst/>
+          </a:prstGeom>
+          <a:noFill/>
+        </p:spPr>
+        <p:txBody>
+          <a:bodyPr wrap="square">
+            <a:spAutoFit/>
+          </a:bodyPr>
+          <a:lstStyle/>
+          <a:p>
+            <a:r>
+              <a:rPr sz="1000" b="1">
+                <a:solidFill>
+                  <a:srgbClr val="26673D"/>
+                </a:solidFill>
+                <a:latin typeface="Inter"/>
+              </a:rPr>
+              <a:t>WD-02</a:t>
+            </a:r>
+          </a:p>
+        </p:txBody>
+      </p:sp>
+      <p:sp>
+        <p:nvSpPr>
+          <p:cNvPr id="8" name="TextBox 7"/>
+          <p:cNvSpPr txBox="1"/>
+          <p:nvPr/>
+        </p:nvSpPr>
+        <p:spPr>
+          <a:xfrm>
+            <a:off x="469900" y="6096000"/>
+            <a:ext cx="889000" cy="317500"/>
+          </a:xfrm>
+          <a:prstGeom prst="rect">
+            <a:avLst/>
+          </a:prstGeom>
+          <a:noFill/>
+        </p:spPr>
+        <p:txBody>
+          <a:bodyPr wrap="square">
+            <a:spAutoFit/>
+          </a:bodyPr>
+          <a:lstStyle/>
+          <a:p>
+            <a:r>
+              <a:rPr sz="900" b="0">
+                <a:solidFill>
+                  <a:srgbClr val="5A5750"/>
+                </a:solidFill>
+                <a:latin typeface="Inter"/>
+              </a:rPr>
+              <a:t>Oak-look plank</a:t>
+            </a:r>
+          </a:p>
+        </p:txBody>
+      </p:sp>
+      <p:pic>
+        <p:nvPicPr>
+          <p:cNvPr id="9" name="Picture 8" descr="swatch_UP-01g.jpg"/>
+          <p:cNvPicPr>
+            <a:picLocks noChangeAspect="1"/>
+          </p:cNvPicPr>
+          <p:nvPr/>
+        </p:nvPicPr>
+        <p:blipFill>
+          <a:blip r:embed="rId3"/>
+          <a:stretch>
+            <a:fillRect/>
+          </a:stretch>
+        </p:blipFill>
+        <p:spPr>
+          <a:xfrm>
+            <a:off x="1428750" y="5245100"/>
+            <a:ext cx="793750" cy="660400"/>
+          </a:xfrm>
+          <a:prstGeom prst="rect">
+            <a:avLst/>
+          </a:prstGeom>
+        </p:spPr>
+      </p:pic>
+      <p:sp>
+        <p:nvSpPr>
+          <p:cNvPr id="10" name="TextBox 9"/>
+          <p:cNvSpPr txBox="1"/>
+          <p:nvPr/>
+        </p:nvSpPr>
+        <p:spPr>
+          <a:xfrm>
+            <a:off x="1390650" y="5930900"/>
+            <a:ext cx="889000" cy="190500"/>
+          </a:xfrm>
+          <a:prstGeom prst="rect">
+            <a:avLst/>
+          </a:prstGeom>
+          <a:noFill/>
+        </p:spPr>
+        <p:txBody>
+          <a:bodyPr wrap="square">
+            <a:spAutoFit/>
+          </a:bodyPr>
+          <a:lstStyle/>
+          <a:p>
+            <a:r>
+              <a:rPr sz="1000" b="1">
+                <a:solidFill>
+                  <a:srgbClr val="26673D"/>
+                </a:solidFill>
+                <a:latin typeface="Inter"/>
+              </a:rPr>
+              <a:t>UP-01</a:t>
+            </a:r>
+          </a:p>
+        </p:txBody>
+      </p:sp>
+      <p:sp>
+        <p:nvSpPr>
+          <p:cNvPr id="11" name="TextBox 10"/>
+          <p:cNvSpPr txBox="1"/>
+          <p:nvPr/>
+        </p:nvSpPr>
+        <p:spPr>
+          <a:xfrm>
+            <a:off x="1390650" y="6096000"/>
+            <a:ext cx="889000" cy="317500"/>
+          </a:xfrm>
+          <a:prstGeom prst="rect">
+            <a:avLst/>
+          </a:prstGeom>
+          <a:noFill/>
+        </p:spPr>
+        <p:txBody>
+          <a:bodyPr wrap="square">
+            <a:spAutoFit/>
+          </a:bodyPr>
+          <a:lstStyle/>
+          <a:p>
+            <a:r>
+              <a:rPr sz="900" b="0">
+                <a:solidFill>
+                  <a:srgbClr val="5A5750"/>
+                </a:solidFill>
+                <a:latin typeface="Inter"/>
+              </a:rPr>
+              <a:t>Green fabric</a:t>
+            </a:r>
+          </a:p>
+        </p:txBody>
+      </p:sp>
+      <p:pic>
+        <p:nvPicPr>
+          <p:cNvPr id="12" name="Picture 11" descr="swatch_WO-02.jpg"/>
+          <p:cNvPicPr>
+            <a:picLocks noChangeAspect="1"/>
+          </p:cNvPicPr>
+          <p:nvPr/>
+        </p:nvPicPr>
+        <p:blipFill>
+          <a:blip r:embed="rId4"/>
+          <a:stretch>
+            <a:fillRect/>
+          </a:stretch>
+        </p:blipFill>
+        <p:spPr>
+          <a:xfrm>
+            <a:off x="2349500" y="5245100"/>
+            <a:ext cx="793750" cy="660400"/>
+          </a:xfrm>
+          <a:prstGeom prst="rect">
+            <a:avLst/>
+          </a:prstGeom>
+        </p:spPr>
+      </p:pic>
+      <p:sp>
+        <p:nvSpPr>
+          <p:cNvPr id="13" name="TextBox 12"/>
+          <p:cNvSpPr txBox="1"/>
+          <p:nvPr/>
+        </p:nvSpPr>
+        <p:spPr>
+          <a:xfrm>
+            <a:off x="2311400" y="5930900"/>
+            <a:ext cx="889000" cy="190500"/>
+          </a:xfrm>
+          <a:prstGeom prst="rect">
+            <a:avLst/>
+          </a:prstGeom>
+          <a:noFill/>
+        </p:spPr>
+        <p:txBody>
+          <a:bodyPr wrap="square">
+            <a:spAutoFit/>
+          </a:bodyPr>
+          <a:lstStyle/>
+          <a:p>
+            <a:r>
+              <a:rPr sz="1000" b="1">
+                <a:solidFill>
+                  <a:srgbClr val="26673D"/>
+                </a:solidFill>
+                <a:latin typeface="Inter"/>
+              </a:rPr>
+              <a:t>WO-02</a:t>
+            </a:r>
+          </a:p>
+        </p:txBody>
+      </p:sp>
+      <p:sp>
+        <p:nvSpPr>
+          <p:cNvPr id="14" name="TextBox 13"/>
+          <p:cNvSpPr txBox="1"/>
+          <p:nvPr/>
+        </p:nvSpPr>
+        <p:spPr>
+          <a:xfrm>
+            <a:off x="2311400" y="6096000"/>
+            <a:ext cx="889000" cy="317500"/>
+          </a:xfrm>
+          <a:prstGeom prst="rect">
+            <a:avLst/>
+          </a:prstGeom>
+          <a:noFill/>
+        </p:spPr>
+        <p:txBody>
+          <a:bodyPr wrap="square">
+            <a:spAutoFit/>
+          </a:bodyPr>
+          <a:lstStyle/>
+          <a:p>
+            <a:r>
+              <a:rPr sz="900" b="0">
+                <a:solidFill>
+                  <a:srgbClr val="5A5750"/>
+                </a:solidFill>
+                <a:latin typeface="Inter"/>
+              </a:rPr>
+              <a:t>Smoked walnut</a:t>
+            </a:r>
+          </a:p>
+        </p:txBody>
+      </p:sp>
+      <p:pic>
+        <p:nvPicPr>
+          <p:cNvPr id="15" name="Picture 14" descr="swatch_PA-01.jpg"/>
+          <p:cNvPicPr>
+            <a:picLocks noChangeAspect="1"/>
+          </p:cNvPicPr>
+          <p:nvPr/>
+        </p:nvPicPr>
+        <p:blipFill>
+          <a:blip r:embed="rId5"/>
+          <a:stretch>
+            <a:fillRect/>
+          </a:stretch>
+        </p:blipFill>
+        <p:spPr>
+          <a:xfrm>
+            <a:off x="3270250" y="5245100"/>
+            <a:ext cx="793750" cy="660400"/>
+          </a:xfrm>
+          <a:prstGeom prst="rect">
+            <a:avLst/>
+          </a:prstGeom>
+        </p:spPr>
+      </p:pic>
+      <p:sp>
+        <p:nvSpPr>
+          <p:cNvPr id="16" name="TextBox 15"/>
+          <p:cNvSpPr txBox="1"/>
+          <p:nvPr/>
+        </p:nvSpPr>
+        <p:spPr>
+          <a:xfrm>
+            <a:off x="3232150" y="5930900"/>
+            <a:ext cx="889000" cy="190500"/>
+          </a:xfrm>
+          <a:prstGeom prst="rect">
+            <a:avLst/>
+          </a:prstGeom>
+          <a:noFill/>
+        </p:spPr>
+        <p:txBody>
+          <a:bodyPr wrap="square">
+            <a:spAutoFit/>
+          </a:bodyPr>
+          <a:lstStyle/>
+          <a:p>
+            <a:r>
+              <a:rPr sz="1000" b="1">
+                <a:solidFill>
+                  <a:srgbClr val="26673D"/>
+                </a:solidFill>
+                <a:latin typeface="Inter"/>
+              </a:rPr>
+              <a:t>PA-01</a:t>
+            </a:r>
+          </a:p>
+        </p:txBody>
+      </p:sp>
+      <p:sp>
+        <p:nvSpPr>
+          <p:cNvPr id="17" name="TextBox 16"/>
+          <p:cNvSpPr txBox="1"/>
+          <p:nvPr/>
+        </p:nvSpPr>
+        <p:spPr>
+          <a:xfrm>
+            <a:off x="3232150" y="6096000"/>
+            <a:ext cx="889000" cy="317500"/>
+          </a:xfrm>
+          <a:prstGeom prst="rect">
+            <a:avLst/>
+          </a:prstGeom>
+          <a:noFill/>
+        </p:spPr>
+        <p:txBody>
+          <a:bodyPr wrap="square">
+            <a:spAutoFit/>
+          </a:bodyPr>
+          <a:lstStyle/>
+          <a:p>
+            <a:r>
+              <a:rPr sz="900" b="0">
+                <a:solidFill>
+                  <a:srgbClr val="5A5750"/>
+                </a:solidFill>
+                <a:latin typeface="Inter"/>
+              </a:rPr>
+              <a:t>Warm white paint</a:t>
+            </a:r>
+          </a:p>
+        </p:txBody>
+      </p:sp>
+      <p:pic>
+        <p:nvPicPr>
+          <p:cNvPr id="18" name="Picture 17" descr="CAM_13_Design_Studio_A.jpg"/>
+          <p:cNvPicPr>
+            <a:picLocks noChangeAspect="1"/>
+          </p:cNvPicPr>
+          <p:nvPr/>
+        </p:nvPicPr>
+        <p:blipFill>
+          <a:blip r:embed="rId6"/>
           <a:srcRect t="6335" b="6335"/>
           <a:stretch>
             <a:fillRect/>
@@ -4553,7 +5759,7 @@
       </p:pic>
       <p:sp>
         <p:nvSpPr>
-          <p:cNvPr id="6" name="TextBox 5"/>
+          <p:cNvPr id="19" name="TextBox 18"/>
           <p:cNvSpPr txBox="1"/>
           <p:nvPr/>
         </p:nvSpPr>
@@ -4587,14 +5793,14 @@
       </p:sp>
       <p:pic>
         <p:nvPicPr>
-          <p:cNvPr id="7" name="Picture 6" descr="CAM_14_Design_Studio_B.jpg"/>
+          <p:cNvPr id="20" name="Picture 19" descr="CAM_14_Design_Studio_B.jpg"/>
           <p:cNvPicPr>
             <a:picLocks noChangeAspect="1"/>
           </p:cNvPicPr>
           <p:nvPr/>
         </p:nvPicPr>
         <p:blipFill>
-          <a:blip r:embed="rId3"/>
+          <a:blip r:embed="rId7"/>
           <a:srcRect l="605" r="605"/>
           <a:stretch>
             <a:fillRect/>
@@ -4612,7 +5818,7 @@
       </p:pic>
       <p:sp>
         <p:nvSpPr>
-          <p:cNvPr id="8" name="TextBox 7"/>
+          <p:cNvPr id="21" name="TextBox 20"/>
           <p:cNvSpPr txBox="1"/>
           <p:nvPr/>
         </p:nvSpPr>
@@ -4646,14 +5852,14 @@
       </p:sp>
       <p:pic>
         <p:nvPicPr>
-          <p:cNvPr id="9" name="Picture 8" descr="CAM_15_CAD_Room.jpg"/>
+          <p:cNvPr id="22" name="Picture 21" descr="CAM_15_CAD_Room.jpg"/>
           <p:cNvPicPr>
             <a:picLocks noChangeAspect="1"/>
           </p:cNvPicPr>
           <p:nvPr/>
         </p:nvPicPr>
         <p:blipFill>
-          <a:blip r:embed="rId4"/>
+          <a:blip r:embed="rId8"/>
           <a:srcRect l="605" r="605"/>
           <a:stretch>
             <a:fillRect/>
@@ -4671,7 +5877,7 @@
       </p:pic>
       <p:sp>
         <p:nvSpPr>
-          <p:cNvPr id="10" name="TextBox 9"/>
+          <p:cNvPr id="23" name="TextBox 22"/>
           <p:cNvSpPr txBox="1"/>
           <p:nvPr/>
         </p:nvSpPr>
@@ -4705,7 +5911,7 @@
       </p:sp>
       <p:sp>
         <p:nvSpPr>
-          <p:cNvPr id="11" name="TextBox 10"/>
+          <p:cNvPr id="24" name="TextBox 23"/>
           <p:cNvSpPr txBox="1"/>
           <p:nvPr/>
         </p:nvSpPr>
@@ -4739,7 +5945,7 @@
       </p:sp>
       <p:sp>
         <p:nvSpPr>
-          <p:cNvPr id="12" name="TextBox 11"/>
+          <p:cNvPr id="25" name="TextBox 24"/>
           <p:cNvSpPr txBox="1"/>
           <p:nvPr/>
         </p:nvSpPr>
@@ -6443,7 +7649,7 @@
                 </a:solidFill>
                 <a:latin typeface="Inter"/>
               </a:rPr>
-              <a:t>Felt rafts between the beams - boardroom (preview render)</a:t>
+              <a:t>Felt rafts between the beams - boardroom</a:t>
             </a:r>
           </a:p>
         </p:txBody>
@@ -8203,21 +9409,21 @@
         <p:spPr>
           <a:xfrm>
             <a:off x="508000" y="863600"/>
-            <a:ext cx="3683000" cy="1270000"/>
-          </a:xfrm>
-          <a:prstGeom prst="rect">
-            <a:avLst/>
-          </a:prstGeom>
-          <a:noFill/>
-        </p:spPr>
-        <p:txBody>
-          <a:bodyPr wrap="square">
-            <a:spAutoFit/>
-          </a:bodyPr>
-          <a:lstStyle/>
-          <a:p>
-            <a:r>
-              <a:rPr sz="2600" b="1">
+            <a:ext cx="3683000" cy="1524000"/>
+          </a:xfrm>
+          <a:prstGeom prst="rect">
+            <a:avLst/>
+          </a:prstGeom>
+          <a:noFill/>
+        </p:spPr>
+        <p:txBody>
+          <a:bodyPr wrap="square">
+            <a:spAutoFit/>
+          </a:bodyPr>
+          <a:lstStyle/>
+          <a:p>
+            <a:r>
+              <a:rPr sz="2400" b="1">
                 <a:solidFill>
                   <a:srgbClr val="1E1E1C"/>
                 </a:solidFill>
@@ -8236,8 +9442,8 @@
         </p:nvSpPr>
         <p:spPr>
           <a:xfrm>
-            <a:off x="508000" y="2286000"/>
-            <a:ext cx="3683000" cy="4191000"/>
+            <a:off x="508000" y="2540000"/>
+            <a:ext cx="3683000" cy="3937000"/>
           </a:xfrm>
           <a:prstGeom prst="rect">
             <a:avLst/>
@@ -8257,7 +9463,7 @@
                 </a:solidFill>
                 <a:latin typeface="Inter"/>
               </a:rPr>
-              <a:t>The ground floor becomes the face of the company: a calm, premium headquarters where international buyers meet the brand, management works in comfort and the Global Design Studio turns trends into production-ready products - with no production on this floor.</a:t>
+              <a:t>The face of the company: a calm, premium headquarters where buyers meet the brand, management works in comfort and the design team turns trends into products - with no production on this floor.</a:t>
             </a:r>
           </a:p>
           <a:p>
@@ -8301,25 +9507,286 @@
                 </a:solidFill>
                 <a:latin typeface="Inter"/>
               </a:rPr>
-              <a:t>- Design-development wing: studio, CAD, fabric library, 3D lab, sample room</a:t>
-            </a:r>
-          </a:p>
-          <a:p>
-            <a:r>
-              <a:rPr sz="1400" b="0">
+              <a:t>- Design wing, staff cafe, lounge / training and prayer rooms behind</a:t>
+            </a:r>
+          </a:p>
+        </p:txBody>
+      </p:sp>
+      <p:sp>
+        <p:nvSpPr>
+          <p:cNvPr id="5" name="TextBox 4"/>
+          <p:cNvSpPr txBox="1"/>
+          <p:nvPr/>
+        </p:nvSpPr>
+        <p:spPr>
+          <a:xfrm>
+            <a:off x="508000" y="5016500"/>
+            <a:ext cx="1778000" cy="317500"/>
+          </a:xfrm>
+          <a:prstGeom prst="rect">
+            <a:avLst/>
+          </a:prstGeom>
+          <a:noFill/>
+        </p:spPr>
+        <p:txBody>
+          <a:bodyPr wrap="square">
+            <a:spAutoFit/>
+          </a:bodyPr>
+          <a:lstStyle/>
+          <a:p>
+            <a:r>
+              <a:rPr sz="2400" b="1">
+                <a:solidFill>
+                  <a:srgbClr val="26673D"/>
+                </a:solidFill>
+                <a:latin typeface="Inter"/>
+              </a:rPr>
+              <a:t>34</a:t>
+            </a:r>
+          </a:p>
+        </p:txBody>
+      </p:sp>
+      <p:sp>
+        <p:nvSpPr>
+          <p:cNvPr id="6" name="TextBox 5"/>
+          <p:cNvSpPr txBox="1"/>
+          <p:nvPr/>
+        </p:nvSpPr>
+        <p:spPr>
+          <a:xfrm>
+            <a:off x="508000" y="5334000"/>
+            <a:ext cx="1778000" cy="317500"/>
+          </a:xfrm>
+          <a:prstGeom prst="rect">
+            <a:avLst/>
+          </a:prstGeom>
+          <a:noFill/>
+        </p:spPr>
+        <p:txBody>
+          <a:bodyPr wrap="square">
+            <a:spAutoFit/>
+          </a:bodyPr>
+          <a:lstStyle/>
+          <a:p>
+            <a:r>
+              <a:rPr sz="1100" b="0">
                 <a:solidFill>
                   <a:srgbClr val="5A5750"/>
                 </a:solidFill>
                 <a:latin typeface="Inter"/>
               </a:rPr>
-              <a:t>- Staff cafe, lounge / training, prayer rooms and washrooms</a:t>
+              <a:t>rooms and zones designed</a:t>
+            </a:r>
+          </a:p>
+        </p:txBody>
+      </p:sp>
+      <p:sp>
+        <p:nvSpPr>
+          <p:cNvPr id="7" name="TextBox 6"/>
+          <p:cNvSpPr txBox="1"/>
+          <p:nvPr/>
+        </p:nvSpPr>
+        <p:spPr>
+          <a:xfrm>
+            <a:off x="2349500" y="5016500"/>
+            <a:ext cx="1778000" cy="317500"/>
+          </a:xfrm>
+          <a:prstGeom prst="rect">
+            <a:avLst/>
+          </a:prstGeom>
+          <a:noFill/>
+        </p:spPr>
+        <p:txBody>
+          <a:bodyPr wrap="square">
+            <a:spAutoFit/>
+          </a:bodyPr>
+          <a:lstStyle/>
+          <a:p>
+            <a:r>
+              <a:rPr sz="2400" b="1">
+                <a:solidFill>
+                  <a:srgbClr val="26673D"/>
+                </a:solidFill>
+                <a:latin typeface="Inter"/>
+              </a:rPr>
+              <a:t>54</a:t>
+            </a:r>
+          </a:p>
+        </p:txBody>
+      </p:sp>
+      <p:sp>
+        <p:nvSpPr>
+          <p:cNvPr id="8" name="TextBox 7"/>
+          <p:cNvSpPr txBox="1"/>
+          <p:nvPr/>
+        </p:nvSpPr>
+        <p:spPr>
+          <a:xfrm>
+            <a:off x="2349500" y="5334000"/>
+            <a:ext cx="1778000" cy="317500"/>
+          </a:xfrm>
+          <a:prstGeom prst="rect">
+            <a:avLst/>
+          </a:prstGeom>
+          <a:noFill/>
+        </p:spPr>
+        <p:txBody>
+          <a:bodyPr wrap="square">
+            <a:spAutoFit/>
+          </a:bodyPr>
+          <a:lstStyle/>
+          <a:p>
+            <a:r>
+              <a:rPr sz="1100" b="0">
+                <a:solidFill>
+                  <a:srgbClr val="5A5750"/>
+                </a:solidFill>
+                <a:latin typeface="Inter"/>
+              </a:rPr>
+              <a:t>work seats incl. growth and guests</a:t>
+            </a:r>
+          </a:p>
+        </p:txBody>
+      </p:sp>
+      <p:sp>
+        <p:nvSpPr>
+          <p:cNvPr id="9" name="TextBox 8"/>
+          <p:cNvSpPr txBox="1"/>
+          <p:nvPr/>
+        </p:nvSpPr>
+        <p:spPr>
+          <a:xfrm>
+            <a:off x="508000" y="5715000"/>
+            <a:ext cx="1778000" cy="317500"/>
+          </a:xfrm>
+          <a:prstGeom prst="rect">
+            <a:avLst/>
+          </a:prstGeom>
+          <a:noFill/>
+        </p:spPr>
+        <p:txBody>
+          <a:bodyPr wrap="square">
+            <a:spAutoFit/>
+          </a:bodyPr>
+          <a:lstStyle/>
+          <a:p>
+            <a:r>
+              <a:rPr sz="2400" b="1">
+                <a:solidFill>
+                  <a:srgbClr val="26673D"/>
+                </a:solidFill>
+                <a:latin typeface="Inter"/>
+              </a:rPr>
+              <a:t>707 sft</a:t>
+            </a:r>
+          </a:p>
+        </p:txBody>
+      </p:sp>
+      <p:sp>
+        <p:nvSpPr>
+          <p:cNvPr id="10" name="TextBox 9"/>
+          <p:cNvSpPr txBox="1"/>
+          <p:nvPr/>
+        </p:nvSpPr>
+        <p:spPr>
+          <a:xfrm>
+            <a:off x="508000" y="6032500"/>
+            <a:ext cx="1778000" cy="317500"/>
+          </a:xfrm>
+          <a:prstGeom prst="rect">
+            <a:avLst/>
+          </a:prstGeom>
+          <a:noFill/>
+        </p:spPr>
+        <p:txBody>
+          <a:bodyPr wrap="square">
+            <a:spAutoFit/>
+          </a:bodyPr>
+          <a:lstStyle/>
+          <a:p>
+            <a:r>
+              <a:rPr sz="1100" b="0">
+                <a:solidFill>
+                  <a:srgbClr val="5A5750"/>
+                </a:solidFill>
+                <a:latin typeface="Inter"/>
+              </a:rPr>
+              <a:t>experience centre at the heart</a:t>
+            </a:r>
+          </a:p>
+        </p:txBody>
+      </p:sp>
+      <p:sp>
+        <p:nvSpPr>
+          <p:cNvPr id="11" name="TextBox 10"/>
+          <p:cNvSpPr txBox="1"/>
+          <p:nvPr/>
+        </p:nvSpPr>
+        <p:spPr>
+          <a:xfrm>
+            <a:off x="2349500" y="5715000"/>
+            <a:ext cx="1778000" cy="317500"/>
+          </a:xfrm>
+          <a:prstGeom prst="rect">
+            <a:avLst/>
+          </a:prstGeom>
+          <a:noFill/>
+        </p:spPr>
+        <p:txBody>
+          <a:bodyPr wrap="square">
+            <a:spAutoFit/>
+          </a:bodyPr>
+          <a:lstStyle/>
+          <a:p>
+            <a:r>
+              <a:rPr sz="2400" b="1">
+                <a:solidFill>
+                  <a:srgbClr val="26673D"/>
+                </a:solidFill>
+                <a:latin typeface="Inter"/>
+              </a:rPr>
+              <a:t>75 / 75</a:t>
+            </a:r>
+          </a:p>
+        </p:txBody>
+      </p:sp>
+      <p:sp>
+        <p:nvSpPr>
+          <p:cNvPr id="12" name="TextBox 11"/>
+          <p:cNvSpPr txBox="1"/>
+          <p:nvPr/>
+        </p:nvSpPr>
+        <p:spPr>
+          <a:xfrm>
+            <a:off x="2349500" y="6032500"/>
+            <a:ext cx="1778000" cy="317500"/>
+          </a:xfrm>
+          <a:prstGeom prst="rect">
+            <a:avLst/>
+          </a:prstGeom>
+          <a:noFill/>
+        </p:spPr>
+        <p:txBody>
+          <a:bodyPr wrap="square">
+            <a:spAutoFit/>
+          </a:bodyPr>
+          <a:lstStyle/>
+          <a:p>
+            <a:r>
+              <a:rPr sz="1100" b="0">
+                <a:solidFill>
+                  <a:srgbClr val="5A5750"/>
+                </a:solidFill>
+                <a:latin typeface="Inter"/>
+              </a:rPr>
+              <a:t>survey dimension checks passed</a:t>
             </a:r>
           </a:p>
         </p:txBody>
       </p:sp>
       <p:pic>
         <p:nvPicPr>
-          <p:cNvPr id="5" name="Picture 4" descr="CAM_02_Reception_B.jpg"/>
+          <p:cNvPr id="13" name="Picture 12" descr="CAM_02_Reception_B.jpg"/>
           <p:cNvPicPr>
             <a:picLocks noChangeAspect="1"/>
           </p:cNvPicPr>
@@ -8344,7 +9811,7 @@
       </p:pic>
       <p:sp>
         <p:nvSpPr>
-          <p:cNvPr id="6" name="TextBox 5"/>
+          <p:cNvPr id="14" name="TextBox 13"/>
           <p:cNvSpPr txBox="1"/>
           <p:nvPr/>
         </p:nvSpPr>
@@ -8378,7 +9845,7 @@
       </p:sp>
       <p:sp>
         <p:nvSpPr>
-          <p:cNvPr id="7" name="TextBox 6"/>
+          <p:cNvPr id="15" name="TextBox 14"/>
           <p:cNvSpPr txBox="1"/>
           <p:nvPr/>
         </p:nvSpPr>
@@ -8412,7 +9879,7 @@
       </p:sp>
       <p:sp>
         <p:nvSpPr>
-          <p:cNvPr id="8" name="TextBox 7"/>
+          <p:cNvPr id="16" name="TextBox 15"/>
           <p:cNvSpPr txBox="1"/>
           <p:nvPr/>
         </p:nvSpPr>
@@ -11157,21 +12624,21 @@
         <p:spPr>
           <a:xfrm>
             <a:off x="508000" y="863600"/>
-            <a:ext cx="3683000" cy="1270000"/>
-          </a:xfrm>
-          <a:prstGeom prst="rect">
-            <a:avLst/>
-          </a:prstGeom>
-          <a:noFill/>
-        </p:spPr>
-        <p:txBody>
-          <a:bodyPr wrap="square">
-            <a:spAutoFit/>
-          </a:bodyPr>
-          <a:lstStyle/>
-          <a:p>
-            <a:r>
-              <a:rPr sz="2600" b="1">
+            <a:ext cx="3683000" cy="1524000"/>
+          </a:xfrm>
+          <a:prstGeom prst="rect">
+            <a:avLst/>
+          </a:prstGeom>
+          <a:noFill/>
+        </p:spPr>
+        <p:txBody>
+          <a:bodyPr wrap="square">
+            <a:spAutoFit/>
+          </a:bodyPr>
+          <a:lstStyle/>
+          <a:p>
+            <a:r>
+              <a:rPr sz="2400" b="1">
                 <a:solidFill>
                   <a:srgbClr val="1E1E1C"/>
                 </a:solidFill>
@@ -11190,8 +12657,8 @@
         </p:nvSpPr>
         <p:spPr>
           <a:xfrm>
-            <a:off x="508000" y="2286000"/>
-            <a:ext cx="3683000" cy="4191000"/>
+            <a:off x="508000" y="2540000"/>
+            <a:ext cx="3683000" cy="2349500"/>
           </a:xfrm>
           <a:prstGeom prst="rect">
             <a:avLst/>
@@ -11267,13 +12734,47 @@
                 <a:latin typeface="Inter"/>
               </a:rPr>
               <a:t>- Glass between lobby and reception</a:t>
+            </a:r>
+          </a:p>
+        </p:txBody>
+      </p:sp>
+      <p:sp>
+        <p:nvSpPr>
+          <p:cNvPr id="5" name="TextBox 4"/>
+          <p:cNvSpPr txBox="1"/>
+          <p:nvPr/>
+        </p:nvSpPr>
+        <p:spPr>
+          <a:xfrm>
+            <a:off x="508000" y="5016500"/>
+            <a:ext cx="3683000" cy="190500"/>
+          </a:xfrm>
+          <a:prstGeom prst="rect">
+            <a:avLst/>
+          </a:prstGeom>
+          <a:noFill/>
+        </p:spPr>
+        <p:txBody>
+          <a:bodyPr wrap="square">
+            <a:spAutoFit/>
+          </a:bodyPr>
+          <a:lstStyle/>
+          <a:p>
+            <a:r>
+              <a:rPr sz="1000" b="1">
+                <a:solidFill>
+                  <a:srgbClr val="26673D"/>
+                </a:solidFill>
+                <a:latin typeface="Inter"/>
+              </a:rPr>
+              <a:t>KEY FINISHES</a:t>
             </a:r>
           </a:p>
         </p:txBody>
       </p:sp>
       <p:pic>
         <p:nvPicPr>
-          <p:cNvPr id="5" name="Picture 4" descr="CAM_01_Reception_A.jpg"/>
+          <p:cNvPr id="6" name="Picture 5" descr="swatch_TZ-01.jpg"/>
           <p:cNvPicPr>
             <a:picLocks noChangeAspect="1"/>
           </p:cNvPicPr>
@@ -11281,6 +12782,374 @@
         </p:nvPicPr>
         <p:blipFill>
           <a:blip r:embed="rId2"/>
+          <a:stretch>
+            <a:fillRect/>
+          </a:stretch>
+        </p:blipFill>
+        <p:spPr>
+          <a:xfrm>
+            <a:off x="508000" y="5245100"/>
+            <a:ext cx="793750" cy="660400"/>
+          </a:xfrm>
+          <a:prstGeom prst="rect">
+            <a:avLst/>
+          </a:prstGeom>
+        </p:spPr>
+      </p:pic>
+      <p:sp>
+        <p:nvSpPr>
+          <p:cNvPr id="7" name="TextBox 6"/>
+          <p:cNvSpPr txBox="1"/>
+          <p:nvPr/>
+        </p:nvSpPr>
+        <p:spPr>
+          <a:xfrm>
+            <a:off x="469900" y="5930900"/>
+            <a:ext cx="889000" cy="190500"/>
+          </a:xfrm>
+          <a:prstGeom prst="rect">
+            <a:avLst/>
+          </a:prstGeom>
+          <a:noFill/>
+        </p:spPr>
+        <p:txBody>
+          <a:bodyPr wrap="square">
+            <a:spAutoFit/>
+          </a:bodyPr>
+          <a:lstStyle/>
+          <a:p>
+            <a:r>
+              <a:rPr sz="1000" b="1">
+                <a:solidFill>
+                  <a:srgbClr val="26673D"/>
+                </a:solidFill>
+                <a:latin typeface="Inter"/>
+              </a:rPr>
+              <a:t>TZ-01</a:t>
+            </a:r>
+          </a:p>
+        </p:txBody>
+      </p:sp>
+      <p:sp>
+        <p:nvSpPr>
+          <p:cNvPr id="8" name="TextBox 7"/>
+          <p:cNvSpPr txBox="1"/>
+          <p:nvPr/>
+        </p:nvSpPr>
+        <p:spPr>
+          <a:xfrm>
+            <a:off x="469900" y="6096000"/>
+            <a:ext cx="889000" cy="317500"/>
+          </a:xfrm>
+          <a:prstGeom prst="rect">
+            <a:avLst/>
+          </a:prstGeom>
+          <a:noFill/>
+        </p:spPr>
+        <p:txBody>
+          <a:bodyPr wrap="square">
+            <a:spAutoFit/>
+          </a:bodyPr>
+          <a:lstStyle/>
+          <a:p>
+            <a:r>
+              <a:rPr sz="900" b="0">
+                <a:solidFill>
+                  <a:srgbClr val="5A5750"/>
+                </a:solidFill>
+                <a:latin typeface="Inter"/>
+              </a:rPr>
+              <a:t>Terrazzo floor</a:t>
+            </a:r>
+          </a:p>
+        </p:txBody>
+      </p:sp>
+      <p:pic>
+        <p:nvPicPr>
+          <p:cNvPr id="9" name="Picture 8" descr="swatch_WO-01.jpg"/>
+          <p:cNvPicPr>
+            <a:picLocks noChangeAspect="1"/>
+          </p:cNvPicPr>
+          <p:nvPr/>
+        </p:nvPicPr>
+        <p:blipFill>
+          <a:blip r:embed="rId3"/>
+          <a:stretch>
+            <a:fillRect/>
+          </a:stretch>
+        </p:blipFill>
+        <p:spPr>
+          <a:xfrm>
+            <a:off x="1428750" y="5245100"/>
+            <a:ext cx="793750" cy="660400"/>
+          </a:xfrm>
+          <a:prstGeom prst="rect">
+            <a:avLst/>
+          </a:prstGeom>
+        </p:spPr>
+      </p:pic>
+      <p:sp>
+        <p:nvSpPr>
+          <p:cNvPr id="10" name="TextBox 9"/>
+          <p:cNvSpPr txBox="1"/>
+          <p:nvPr/>
+        </p:nvSpPr>
+        <p:spPr>
+          <a:xfrm>
+            <a:off x="1390650" y="5930900"/>
+            <a:ext cx="889000" cy="190500"/>
+          </a:xfrm>
+          <a:prstGeom prst="rect">
+            <a:avLst/>
+          </a:prstGeom>
+          <a:noFill/>
+        </p:spPr>
+        <p:txBody>
+          <a:bodyPr wrap="square">
+            <a:spAutoFit/>
+          </a:bodyPr>
+          <a:lstStyle/>
+          <a:p>
+            <a:r>
+              <a:rPr sz="1000" b="1">
+                <a:solidFill>
+                  <a:srgbClr val="26673D"/>
+                </a:solidFill>
+                <a:latin typeface="Inter"/>
+              </a:rPr>
+              <a:t>WO-01</a:t>
+            </a:r>
+          </a:p>
+        </p:txBody>
+      </p:sp>
+      <p:sp>
+        <p:nvSpPr>
+          <p:cNvPr id="11" name="TextBox 10"/>
+          <p:cNvSpPr txBox="1"/>
+          <p:nvPr/>
+        </p:nvSpPr>
+        <p:spPr>
+          <a:xfrm>
+            <a:off x="1390650" y="6096000"/>
+            <a:ext cx="889000" cy="317500"/>
+          </a:xfrm>
+          <a:prstGeom prst="rect">
+            <a:avLst/>
+          </a:prstGeom>
+          <a:noFill/>
+        </p:spPr>
+        <p:txBody>
+          <a:bodyPr wrap="square">
+            <a:spAutoFit/>
+          </a:bodyPr>
+          <a:lstStyle/>
+          <a:p>
+            <a:r>
+              <a:rPr sz="900" b="0">
+                <a:solidFill>
+                  <a:srgbClr val="5A5750"/>
+                </a:solidFill>
+                <a:latin typeface="Inter"/>
+              </a:rPr>
+              <a:t>White-oak slats</a:t>
+            </a:r>
+          </a:p>
+        </p:txBody>
+      </p:sp>
+      <p:pic>
+        <p:nvPicPr>
+          <p:cNvPr id="12" name="Picture 11" descr="swatch_SS-01.jpg"/>
+          <p:cNvPicPr>
+            <a:picLocks noChangeAspect="1"/>
+          </p:cNvPicPr>
+          <p:nvPr/>
+        </p:nvPicPr>
+        <p:blipFill>
+          <a:blip r:embed="rId4"/>
+          <a:stretch>
+            <a:fillRect/>
+          </a:stretch>
+        </p:blipFill>
+        <p:spPr>
+          <a:xfrm>
+            <a:off x="2349500" y="5245100"/>
+            <a:ext cx="793750" cy="660400"/>
+          </a:xfrm>
+          <a:prstGeom prst="rect">
+            <a:avLst/>
+          </a:prstGeom>
+        </p:spPr>
+      </p:pic>
+      <p:sp>
+        <p:nvSpPr>
+          <p:cNvPr id="13" name="TextBox 12"/>
+          <p:cNvSpPr txBox="1"/>
+          <p:nvPr/>
+        </p:nvSpPr>
+        <p:spPr>
+          <a:xfrm>
+            <a:off x="2311400" y="5930900"/>
+            <a:ext cx="889000" cy="190500"/>
+          </a:xfrm>
+          <a:prstGeom prst="rect">
+            <a:avLst/>
+          </a:prstGeom>
+          <a:noFill/>
+        </p:spPr>
+        <p:txBody>
+          <a:bodyPr wrap="square">
+            <a:spAutoFit/>
+          </a:bodyPr>
+          <a:lstStyle/>
+          <a:p>
+            <a:r>
+              <a:rPr sz="1000" b="1">
+                <a:solidFill>
+                  <a:srgbClr val="26673D"/>
+                </a:solidFill>
+                <a:latin typeface="Inter"/>
+              </a:rPr>
+              <a:t>SS-01</a:t>
+            </a:r>
+          </a:p>
+        </p:txBody>
+      </p:sp>
+      <p:sp>
+        <p:nvSpPr>
+          <p:cNvPr id="14" name="TextBox 13"/>
+          <p:cNvSpPr txBox="1"/>
+          <p:nvPr/>
+        </p:nvSpPr>
+        <p:spPr>
+          <a:xfrm>
+            <a:off x="2311400" y="6096000"/>
+            <a:ext cx="889000" cy="317500"/>
+          </a:xfrm>
+          <a:prstGeom prst="rect">
+            <a:avLst/>
+          </a:prstGeom>
+          <a:noFill/>
+        </p:spPr>
+        <p:txBody>
+          <a:bodyPr wrap="square">
+            <a:spAutoFit/>
+          </a:bodyPr>
+          <a:lstStyle/>
+          <a:p>
+            <a:r>
+              <a:rPr sz="900" b="0">
+                <a:solidFill>
+                  <a:srgbClr val="5A5750"/>
+                </a:solidFill>
+                <a:latin typeface="Inter"/>
+              </a:rPr>
+              <a:t>Quartz / terrazzo top</a:t>
+            </a:r>
+          </a:p>
+        </p:txBody>
+      </p:sp>
+      <p:pic>
+        <p:nvPicPr>
+          <p:cNvPr id="15" name="Picture 14" descr="swatch_MT-02.jpg"/>
+          <p:cNvPicPr>
+            <a:picLocks noChangeAspect="1"/>
+          </p:cNvPicPr>
+          <p:nvPr/>
+        </p:nvPicPr>
+        <p:blipFill>
+          <a:blip r:embed="rId5"/>
+          <a:stretch>
+            <a:fillRect/>
+          </a:stretch>
+        </p:blipFill>
+        <p:spPr>
+          <a:xfrm>
+            <a:off x="3270250" y="5245100"/>
+            <a:ext cx="793750" cy="660400"/>
+          </a:xfrm>
+          <a:prstGeom prst="rect">
+            <a:avLst/>
+          </a:prstGeom>
+        </p:spPr>
+      </p:pic>
+      <p:sp>
+        <p:nvSpPr>
+          <p:cNvPr id="16" name="TextBox 15"/>
+          <p:cNvSpPr txBox="1"/>
+          <p:nvPr/>
+        </p:nvSpPr>
+        <p:spPr>
+          <a:xfrm>
+            <a:off x="3232150" y="5930900"/>
+            <a:ext cx="889000" cy="190500"/>
+          </a:xfrm>
+          <a:prstGeom prst="rect">
+            <a:avLst/>
+          </a:prstGeom>
+          <a:noFill/>
+        </p:spPr>
+        <p:txBody>
+          <a:bodyPr wrap="square">
+            <a:spAutoFit/>
+          </a:bodyPr>
+          <a:lstStyle/>
+          <a:p>
+            <a:r>
+              <a:rPr sz="1000" b="1">
+                <a:solidFill>
+                  <a:srgbClr val="26673D"/>
+                </a:solidFill>
+                <a:latin typeface="Inter"/>
+              </a:rPr>
+              <a:t>MT-02</a:t>
+            </a:r>
+          </a:p>
+        </p:txBody>
+      </p:sp>
+      <p:sp>
+        <p:nvSpPr>
+          <p:cNvPr id="17" name="TextBox 16"/>
+          <p:cNvSpPr txBox="1"/>
+          <p:nvPr/>
+        </p:nvSpPr>
+        <p:spPr>
+          <a:xfrm>
+            <a:off x="3232150" y="6096000"/>
+            <a:ext cx="889000" cy="317500"/>
+          </a:xfrm>
+          <a:prstGeom prst="rect">
+            <a:avLst/>
+          </a:prstGeom>
+          <a:noFill/>
+        </p:spPr>
+        <p:txBody>
+          <a:bodyPr wrap="square">
+            <a:spAutoFit/>
+          </a:bodyPr>
+          <a:lstStyle/>
+          <a:p>
+            <a:r>
+              <a:rPr sz="900" b="0">
+                <a:solidFill>
+                  <a:srgbClr val="5A5750"/>
+                </a:solidFill>
+                <a:latin typeface="Inter"/>
+              </a:rPr>
+              <a:t>Brushed brass</a:t>
+            </a:r>
+          </a:p>
+        </p:txBody>
+      </p:sp>
+      <p:pic>
+        <p:nvPicPr>
+          <p:cNvPr id="18" name="Picture 17" descr="CAM_01_Reception_A.jpg"/>
+          <p:cNvPicPr>
+            <a:picLocks noChangeAspect="1"/>
+          </p:cNvPicPr>
+          <p:nvPr/>
+        </p:nvPicPr>
+        <p:blipFill>
+          <a:blip r:embed="rId6"/>
           <a:srcRect t="6335" b="6335"/>
           <a:stretch>
             <a:fillRect/>
@@ -11298,7 +13167,7 @@
       </p:pic>
       <p:sp>
         <p:nvSpPr>
-          <p:cNvPr id="6" name="TextBox 5"/>
+          <p:cNvPr id="19" name="TextBox 18"/>
           <p:cNvSpPr txBox="1"/>
           <p:nvPr/>
         </p:nvSpPr>
@@ -11325,21 +13194,21 @@
                 </a:solidFill>
                 <a:latin typeface="Inter"/>
               </a:rPr>
-              <a:t>Reception (preview render)</a:t>
+              <a:t>Reception</a:t>
             </a:r>
           </a:p>
         </p:txBody>
       </p:sp>
       <p:pic>
         <p:nvPicPr>
-          <p:cNvPr id="7" name="Picture 6" descr="CAM_02_Reception_B.jpg"/>
+          <p:cNvPr id="20" name="Picture 19" descr="CAM_02_Reception_B.jpg"/>
           <p:cNvPicPr>
             <a:picLocks noChangeAspect="1"/>
           </p:cNvPicPr>
           <p:nvPr/>
         </p:nvPicPr>
         <p:blipFill>
-          <a:blip r:embed="rId3"/>
+          <a:blip r:embed="rId7"/>
           <a:srcRect l="605" r="605"/>
           <a:stretch>
             <a:fillRect/>
@@ -11357,7 +13226,7 @@
       </p:pic>
       <p:sp>
         <p:nvSpPr>
-          <p:cNvPr id="8" name="TextBox 7"/>
+          <p:cNvPr id="21" name="TextBox 20"/>
           <p:cNvSpPr txBox="1"/>
           <p:nvPr/>
         </p:nvSpPr>
@@ -11391,14 +13260,14 @@
       </p:sp>
       <p:pic>
         <p:nvPicPr>
-          <p:cNvPr id="9" name="Picture 8" descr="CAM_03_Entrance_Lobby.jpg"/>
+          <p:cNvPr id="22" name="Picture 21" descr="CAM_03_Entrance_Lobby.jpg"/>
           <p:cNvPicPr>
             <a:picLocks noChangeAspect="1"/>
           </p:cNvPicPr>
           <p:nvPr/>
         </p:nvPicPr>
         <p:blipFill>
-          <a:blip r:embed="rId4"/>
+          <a:blip r:embed="rId8"/>
           <a:srcRect l="605" r="605"/>
           <a:stretch>
             <a:fillRect/>
@@ -11416,7 +13285,7 @@
       </p:pic>
       <p:sp>
         <p:nvSpPr>
-          <p:cNvPr id="10" name="TextBox 9"/>
+          <p:cNvPr id="23" name="TextBox 22"/>
           <p:cNvSpPr txBox="1"/>
           <p:nvPr/>
         </p:nvSpPr>
@@ -11450,7 +13319,7 @@
       </p:sp>
       <p:sp>
         <p:nvSpPr>
-          <p:cNvPr id="11" name="TextBox 10"/>
+          <p:cNvPr id="24" name="TextBox 23"/>
           <p:cNvSpPr txBox="1"/>
           <p:nvPr/>
         </p:nvSpPr>
@@ -11484,7 +13353,7 @@
       </p:sp>
       <p:sp>
         <p:nvSpPr>
-          <p:cNvPr id="12" name="TextBox 11"/>
+          <p:cNvPr id="25" name="TextBox 24"/>
           <p:cNvSpPr txBox="1"/>
           <p:nvPr/>
         </p:nvSpPr>
@@ -11585,21 +13454,21 @@
         <p:spPr>
           <a:xfrm>
             <a:off x="508000" y="863600"/>
-            <a:ext cx="3683000" cy="1270000"/>
-          </a:xfrm>
-          <a:prstGeom prst="rect">
-            <a:avLst/>
-          </a:prstGeom>
-          <a:noFill/>
-        </p:spPr>
-        <p:txBody>
-          <a:bodyPr wrap="square">
-            <a:spAutoFit/>
-          </a:bodyPr>
-          <a:lstStyle/>
-          <a:p>
-            <a:r>
-              <a:rPr sz="2600" b="1">
+            <a:ext cx="3683000" cy="1524000"/>
+          </a:xfrm>
+          <a:prstGeom prst="rect">
+            <a:avLst/>
+          </a:prstGeom>
+          <a:noFill/>
+        </p:spPr>
+        <p:txBody>
+          <a:bodyPr wrap="square">
+            <a:spAutoFit/>
+          </a:bodyPr>
+          <a:lstStyle/>
+          <a:p>
+            <a:r>
+              <a:rPr sz="2400" b="1">
                 <a:solidFill>
                   <a:srgbClr val="1E1E1C"/>
                 </a:solidFill>
@@ -11618,8 +13487,8 @@
         </p:nvSpPr>
         <p:spPr>
           <a:xfrm>
-            <a:off x="508000" y="2286000"/>
-            <a:ext cx="3683000" cy="4191000"/>
+            <a:off x="508000" y="2540000"/>
+            <a:ext cx="3683000" cy="2349500"/>
           </a:xfrm>
           <a:prstGeom prst="rect">
             <a:avLst/>
@@ -11706,13 +13575,47 @@
                 <a:latin typeface="Inter"/>
               </a:rPr>
               <a:t>- Glass views into boardroom and fabric library</a:t>
+            </a:r>
+          </a:p>
+        </p:txBody>
+      </p:sp>
+      <p:sp>
+        <p:nvSpPr>
+          <p:cNvPr id="5" name="TextBox 4"/>
+          <p:cNvSpPr txBox="1"/>
+          <p:nvPr/>
+        </p:nvSpPr>
+        <p:spPr>
+          <a:xfrm>
+            <a:off x="508000" y="5016500"/>
+            <a:ext cx="3683000" cy="190500"/>
+          </a:xfrm>
+          <a:prstGeom prst="rect">
+            <a:avLst/>
+          </a:prstGeom>
+          <a:noFill/>
+        </p:spPr>
+        <p:txBody>
+          <a:bodyPr wrap="square">
+            <a:spAutoFit/>
+          </a:bodyPr>
+          <a:lstStyle/>
+          <a:p>
+            <a:r>
+              <a:rPr sz="1000" b="1">
+                <a:solidFill>
+                  <a:srgbClr val="26673D"/>
+                </a:solidFill>
+                <a:latin typeface="Inter"/>
+              </a:rPr>
+              <a:t>KEY FINISHES</a:t>
             </a:r>
           </a:p>
         </p:txBody>
       </p:sp>
       <p:pic>
         <p:nvPicPr>
-          <p:cNvPr id="5" name="Picture 4" descr="CAM_04_Experience_Centre_A.jpg"/>
+          <p:cNvPr id="6" name="Picture 5" descr="swatch_TZ-01.jpg"/>
           <p:cNvPicPr>
             <a:picLocks noChangeAspect="1"/>
           </p:cNvPicPr>
@@ -11720,6 +13623,374 @@
         </p:nvPicPr>
         <p:blipFill>
           <a:blip r:embed="rId2"/>
+          <a:stretch>
+            <a:fillRect/>
+          </a:stretch>
+        </p:blipFill>
+        <p:spPr>
+          <a:xfrm>
+            <a:off x="508000" y="5245100"/>
+            <a:ext cx="793750" cy="660400"/>
+          </a:xfrm>
+          <a:prstGeom prst="rect">
+            <a:avLst/>
+          </a:prstGeom>
+        </p:spPr>
+      </p:pic>
+      <p:sp>
+        <p:nvSpPr>
+          <p:cNvPr id="7" name="TextBox 6"/>
+          <p:cNvSpPr txBox="1"/>
+          <p:nvPr/>
+        </p:nvSpPr>
+        <p:spPr>
+          <a:xfrm>
+            <a:off x="469900" y="5930900"/>
+            <a:ext cx="889000" cy="190500"/>
+          </a:xfrm>
+          <a:prstGeom prst="rect">
+            <a:avLst/>
+          </a:prstGeom>
+          <a:noFill/>
+        </p:spPr>
+        <p:txBody>
+          <a:bodyPr wrap="square">
+            <a:spAutoFit/>
+          </a:bodyPr>
+          <a:lstStyle/>
+          <a:p>
+            <a:r>
+              <a:rPr sz="1000" b="1">
+                <a:solidFill>
+                  <a:srgbClr val="26673D"/>
+                </a:solidFill>
+                <a:latin typeface="Inter"/>
+              </a:rPr>
+              <a:t>TZ-01</a:t>
+            </a:r>
+          </a:p>
+        </p:txBody>
+      </p:sp>
+      <p:sp>
+        <p:nvSpPr>
+          <p:cNvPr id="8" name="TextBox 7"/>
+          <p:cNvSpPr txBox="1"/>
+          <p:nvPr/>
+        </p:nvSpPr>
+        <p:spPr>
+          <a:xfrm>
+            <a:off x="469900" y="6096000"/>
+            <a:ext cx="889000" cy="317500"/>
+          </a:xfrm>
+          <a:prstGeom prst="rect">
+            <a:avLst/>
+          </a:prstGeom>
+          <a:noFill/>
+        </p:spPr>
+        <p:txBody>
+          <a:bodyPr wrap="square">
+            <a:spAutoFit/>
+          </a:bodyPr>
+          <a:lstStyle/>
+          <a:p>
+            <a:r>
+              <a:rPr sz="900" b="0">
+                <a:solidFill>
+                  <a:srgbClr val="5A5750"/>
+                </a:solidFill>
+                <a:latin typeface="Inter"/>
+              </a:rPr>
+              <a:t>Terrazzo floor</a:t>
+            </a:r>
+          </a:p>
+        </p:txBody>
+      </p:sp>
+      <p:pic>
+        <p:nvPicPr>
+          <p:cNvPr id="9" name="Picture 8" descr="swatch_PA-02.jpg"/>
+          <p:cNvPicPr>
+            <a:picLocks noChangeAspect="1"/>
+          </p:cNvPicPr>
+          <p:nvPr/>
+        </p:nvPicPr>
+        <p:blipFill>
+          <a:blip r:embed="rId3"/>
+          <a:stretch>
+            <a:fillRect/>
+          </a:stretch>
+        </p:blipFill>
+        <p:spPr>
+          <a:xfrm>
+            <a:off x="1428750" y="5245100"/>
+            <a:ext cx="793750" cy="660400"/>
+          </a:xfrm>
+          <a:prstGeom prst="rect">
+            <a:avLst/>
+          </a:prstGeom>
+        </p:spPr>
+      </p:pic>
+      <p:sp>
+        <p:nvSpPr>
+          <p:cNvPr id="10" name="TextBox 9"/>
+          <p:cNvSpPr txBox="1"/>
+          <p:nvPr/>
+        </p:nvSpPr>
+        <p:spPr>
+          <a:xfrm>
+            <a:off x="1390650" y="5930900"/>
+            <a:ext cx="889000" cy="190500"/>
+          </a:xfrm>
+          <a:prstGeom prst="rect">
+            <a:avLst/>
+          </a:prstGeom>
+          <a:noFill/>
+        </p:spPr>
+        <p:txBody>
+          <a:bodyPr wrap="square">
+            <a:spAutoFit/>
+          </a:bodyPr>
+          <a:lstStyle/>
+          <a:p>
+            <a:r>
+              <a:rPr sz="1000" b="1">
+                <a:solidFill>
+                  <a:srgbClr val="26673D"/>
+                </a:solidFill>
+                <a:latin typeface="Inter"/>
+              </a:rPr>
+              <a:t>PA-02</a:t>
+            </a:r>
+          </a:p>
+        </p:txBody>
+      </p:sp>
+      <p:sp>
+        <p:nvSpPr>
+          <p:cNvPr id="11" name="TextBox 10"/>
+          <p:cNvSpPr txBox="1"/>
+          <p:nvPr/>
+        </p:nvSpPr>
+        <p:spPr>
+          <a:xfrm>
+            <a:off x="1390650" y="6096000"/>
+            <a:ext cx="889000" cy="317500"/>
+          </a:xfrm>
+          <a:prstGeom prst="rect">
+            <a:avLst/>
+          </a:prstGeom>
+          <a:noFill/>
+        </p:spPr>
+        <p:txBody>
+          <a:bodyPr wrap="square">
+            <a:spAutoFit/>
+          </a:bodyPr>
+          <a:lstStyle/>
+          <a:p>
+            <a:r>
+              <a:rPr sz="900" b="0">
+                <a:solidFill>
+                  <a:srgbClr val="5A5750"/>
+                </a:solidFill>
+                <a:latin typeface="Inter"/>
+              </a:rPr>
+              <a:t>Brand green</a:t>
+            </a:r>
+          </a:p>
+        </p:txBody>
+      </p:sp>
+      <p:pic>
+        <p:nvPicPr>
+          <p:cNvPr id="12" name="Picture 11" descr="swatch_WO-01.jpg"/>
+          <p:cNvPicPr>
+            <a:picLocks noChangeAspect="1"/>
+          </p:cNvPicPr>
+          <p:nvPr/>
+        </p:nvPicPr>
+        <p:blipFill>
+          <a:blip r:embed="rId4"/>
+          <a:stretch>
+            <a:fillRect/>
+          </a:stretch>
+        </p:blipFill>
+        <p:spPr>
+          <a:xfrm>
+            <a:off x="2349500" y="5245100"/>
+            <a:ext cx="793750" cy="660400"/>
+          </a:xfrm>
+          <a:prstGeom prst="rect">
+            <a:avLst/>
+          </a:prstGeom>
+        </p:spPr>
+      </p:pic>
+      <p:sp>
+        <p:nvSpPr>
+          <p:cNvPr id="13" name="TextBox 12"/>
+          <p:cNvSpPr txBox="1"/>
+          <p:nvPr/>
+        </p:nvSpPr>
+        <p:spPr>
+          <a:xfrm>
+            <a:off x="2311400" y="5930900"/>
+            <a:ext cx="889000" cy="190500"/>
+          </a:xfrm>
+          <a:prstGeom prst="rect">
+            <a:avLst/>
+          </a:prstGeom>
+          <a:noFill/>
+        </p:spPr>
+        <p:txBody>
+          <a:bodyPr wrap="square">
+            <a:spAutoFit/>
+          </a:bodyPr>
+          <a:lstStyle/>
+          <a:p>
+            <a:r>
+              <a:rPr sz="1000" b="1">
+                <a:solidFill>
+                  <a:srgbClr val="26673D"/>
+                </a:solidFill>
+                <a:latin typeface="Inter"/>
+              </a:rPr>
+              <a:t>WO-01</a:t>
+            </a:r>
+          </a:p>
+        </p:txBody>
+      </p:sp>
+      <p:sp>
+        <p:nvSpPr>
+          <p:cNvPr id="14" name="TextBox 13"/>
+          <p:cNvSpPr txBox="1"/>
+          <p:nvPr/>
+        </p:nvSpPr>
+        <p:spPr>
+          <a:xfrm>
+            <a:off x="2311400" y="6096000"/>
+            <a:ext cx="889000" cy="317500"/>
+          </a:xfrm>
+          <a:prstGeom prst="rect">
+            <a:avLst/>
+          </a:prstGeom>
+          <a:noFill/>
+        </p:spPr>
+        <p:txBody>
+          <a:bodyPr wrap="square">
+            <a:spAutoFit/>
+          </a:bodyPr>
+          <a:lstStyle/>
+          <a:p>
+            <a:r>
+              <a:rPr sz="900" b="0">
+                <a:solidFill>
+                  <a:srgbClr val="5A5750"/>
+                </a:solidFill>
+                <a:latin typeface="Inter"/>
+              </a:rPr>
+              <a:t>White-oak slats</a:t>
+            </a:r>
+          </a:p>
+        </p:txBody>
+      </p:sp>
+      <p:pic>
+        <p:nvPicPr>
+          <p:cNvPr id="15" name="Picture 14" descr="swatch_MT-02.jpg"/>
+          <p:cNvPicPr>
+            <a:picLocks noChangeAspect="1"/>
+          </p:cNvPicPr>
+          <p:nvPr/>
+        </p:nvPicPr>
+        <p:blipFill>
+          <a:blip r:embed="rId5"/>
+          <a:stretch>
+            <a:fillRect/>
+          </a:stretch>
+        </p:blipFill>
+        <p:spPr>
+          <a:xfrm>
+            <a:off x="3270250" y="5245100"/>
+            <a:ext cx="793750" cy="660400"/>
+          </a:xfrm>
+          <a:prstGeom prst="rect">
+            <a:avLst/>
+          </a:prstGeom>
+        </p:spPr>
+      </p:pic>
+      <p:sp>
+        <p:nvSpPr>
+          <p:cNvPr id="16" name="TextBox 15"/>
+          <p:cNvSpPr txBox="1"/>
+          <p:nvPr/>
+        </p:nvSpPr>
+        <p:spPr>
+          <a:xfrm>
+            <a:off x="3232150" y="5930900"/>
+            <a:ext cx="889000" cy="190500"/>
+          </a:xfrm>
+          <a:prstGeom prst="rect">
+            <a:avLst/>
+          </a:prstGeom>
+          <a:noFill/>
+        </p:spPr>
+        <p:txBody>
+          <a:bodyPr wrap="square">
+            <a:spAutoFit/>
+          </a:bodyPr>
+          <a:lstStyle/>
+          <a:p>
+            <a:r>
+              <a:rPr sz="1000" b="1">
+                <a:solidFill>
+                  <a:srgbClr val="26673D"/>
+                </a:solidFill>
+                <a:latin typeface="Inter"/>
+              </a:rPr>
+              <a:t>MT-02</a:t>
+            </a:r>
+          </a:p>
+        </p:txBody>
+      </p:sp>
+      <p:sp>
+        <p:nvSpPr>
+          <p:cNvPr id="17" name="TextBox 16"/>
+          <p:cNvSpPr txBox="1"/>
+          <p:nvPr/>
+        </p:nvSpPr>
+        <p:spPr>
+          <a:xfrm>
+            <a:off x="3232150" y="6096000"/>
+            <a:ext cx="889000" cy="317500"/>
+          </a:xfrm>
+          <a:prstGeom prst="rect">
+            <a:avLst/>
+          </a:prstGeom>
+          <a:noFill/>
+        </p:spPr>
+        <p:txBody>
+          <a:bodyPr wrap="square">
+            <a:spAutoFit/>
+          </a:bodyPr>
+          <a:lstStyle/>
+          <a:p>
+            <a:r>
+              <a:rPr sz="900" b="0">
+                <a:solidFill>
+                  <a:srgbClr val="5A5750"/>
+                </a:solidFill>
+                <a:latin typeface="Inter"/>
+              </a:rPr>
+              <a:t>Brushed brass</a:t>
+            </a:r>
+          </a:p>
+        </p:txBody>
+      </p:sp>
+      <p:pic>
+        <p:nvPicPr>
+          <p:cNvPr id="18" name="Picture 17" descr="CAM_04_Experience_Centre_A.jpg"/>
+          <p:cNvPicPr>
+            <a:picLocks noChangeAspect="1"/>
+          </p:cNvPicPr>
+          <p:nvPr/>
+        </p:nvPicPr>
+        <p:blipFill>
+          <a:blip r:embed="rId6"/>
           <a:srcRect t="6335" b="6335"/>
           <a:stretch>
             <a:fillRect/>
@@ -11737,7 +14008,7 @@
       </p:pic>
       <p:sp>
         <p:nvSpPr>
-          <p:cNvPr id="6" name="TextBox 5"/>
+          <p:cNvPr id="19" name="TextBox 18"/>
           <p:cNvSpPr txBox="1"/>
           <p:nvPr/>
         </p:nvSpPr>
@@ -11764,21 +14035,21 @@
                 </a:solidFill>
                 <a:latin typeface="Inter"/>
               </a:rPr>
-              <a:t>Experience centre (preview render)</a:t>
+              <a:t>Experience centre</a:t>
             </a:r>
           </a:p>
         </p:txBody>
       </p:sp>
       <p:pic>
         <p:nvPicPr>
-          <p:cNvPr id="7" name="Picture 6" descr="CAM_05_Experience_Centre_B.jpg"/>
+          <p:cNvPr id="20" name="Picture 19" descr="CAM_05_Experience_Centre_B.jpg"/>
           <p:cNvPicPr>
             <a:picLocks noChangeAspect="1"/>
           </p:cNvPicPr>
           <p:nvPr/>
         </p:nvPicPr>
         <p:blipFill>
-          <a:blip r:embed="rId3"/>
+          <a:blip r:embed="rId7"/>
           <a:srcRect l="605" r="605"/>
           <a:stretch>
             <a:fillRect/>
@@ -11796,7 +14067,7 @@
       </p:pic>
       <p:sp>
         <p:nvSpPr>
-          <p:cNvPr id="8" name="TextBox 7"/>
+          <p:cNvPr id="21" name="TextBox 20"/>
           <p:cNvSpPr txBox="1"/>
           <p:nvPr/>
         </p:nvSpPr>
@@ -11830,14 +14101,14 @@
       </p:sp>
       <p:pic>
         <p:nvPicPr>
-          <p:cNvPr id="9" name="Picture 8" descr="CAM_06_Experience_Centre_Detail.jpg"/>
+          <p:cNvPr id="22" name="Picture 21" descr="CAM_06_Experience_Centre_Detail.jpg"/>
           <p:cNvPicPr>
             <a:picLocks noChangeAspect="1"/>
           </p:cNvPicPr>
           <p:nvPr/>
         </p:nvPicPr>
         <p:blipFill>
-          <a:blip r:embed="rId4"/>
+          <a:blip r:embed="rId8"/>
           <a:srcRect l="605" r="605"/>
           <a:stretch>
             <a:fillRect/>
@@ -11855,7 +14126,7 @@
       </p:pic>
       <p:sp>
         <p:nvSpPr>
-          <p:cNvPr id="10" name="TextBox 9"/>
+          <p:cNvPr id="23" name="TextBox 22"/>
           <p:cNvSpPr txBox="1"/>
           <p:nvPr/>
         </p:nvSpPr>
@@ -11889,7 +14160,7 @@
       </p:sp>
       <p:sp>
         <p:nvSpPr>
-          <p:cNvPr id="11" name="TextBox 10"/>
+          <p:cNvPr id="24" name="TextBox 23"/>
           <p:cNvSpPr txBox="1"/>
           <p:nvPr/>
         </p:nvSpPr>
@@ -11923,7 +14194,7 @@
       </p:sp>
       <p:sp>
         <p:nvSpPr>
-          <p:cNvPr id="12" name="TextBox 11"/>
+          <p:cNvPr id="25" name="TextBox 24"/>
           <p:cNvSpPr txBox="1"/>
           <p:nvPr/>
         </p:nvSpPr>
@@ -12024,21 +14295,21 @@
         <p:spPr>
           <a:xfrm>
             <a:off x="508000" y="863600"/>
-            <a:ext cx="3683000" cy="1270000"/>
-          </a:xfrm>
-          <a:prstGeom prst="rect">
-            <a:avLst/>
-          </a:prstGeom>
-          <a:noFill/>
-        </p:spPr>
-        <p:txBody>
-          <a:bodyPr wrap="square">
-            <a:spAutoFit/>
-          </a:bodyPr>
-          <a:lstStyle/>
-          <a:p>
-            <a:r>
-              <a:rPr sz="2600" b="1">
+            <a:ext cx="3683000" cy="1524000"/>
+          </a:xfrm>
+          <a:prstGeom prst="rect">
+            <a:avLst/>
+          </a:prstGeom>
+          <a:noFill/>
+        </p:spPr>
+        <p:txBody>
+          <a:bodyPr wrap="square">
+            <a:spAutoFit/>
+          </a:bodyPr>
+          <a:lstStyle/>
+          <a:p>
+            <a:r>
+              <a:rPr sz="2400" b="1">
                 <a:solidFill>
                   <a:srgbClr val="1E1E1C"/>
                 </a:solidFill>
@@ -12057,8 +14328,8 @@
         </p:nvSpPr>
         <p:spPr>
           <a:xfrm>
-            <a:off x="508000" y="2286000"/>
-            <a:ext cx="3683000" cy="4191000"/>
+            <a:off x="508000" y="2540000"/>
+            <a:ext cx="3683000" cy="2349500"/>
           </a:xfrm>
           <a:prstGeom prst="rect">
             <a:avLst/>
@@ -12145,13 +14416,47 @@
                 <a:latin typeface="Inter"/>
               </a:rPr>
               <a:t>- Direct link from the executive suite to the boardroom</a:t>
+            </a:r>
+          </a:p>
+        </p:txBody>
+      </p:sp>
+      <p:sp>
+        <p:nvSpPr>
+          <p:cNvPr id="5" name="TextBox 4"/>
+          <p:cNvSpPr txBox="1"/>
+          <p:nvPr/>
+        </p:nvSpPr>
+        <p:spPr>
+          <a:xfrm>
+            <a:off x="508000" y="5016500"/>
+            <a:ext cx="3683000" cy="190500"/>
+          </a:xfrm>
+          <a:prstGeom prst="rect">
+            <a:avLst/>
+          </a:prstGeom>
+          <a:noFill/>
+        </p:spPr>
+        <p:txBody>
+          <a:bodyPr wrap="square">
+            <a:spAutoFit/>
+          </a:bodyPr>
+          <a:lstStyle/>
+          <a:p>
+            <a:r>
+              <a:rPr sz="1000" b="1">
+                <a:solidFill>
+                  <a:srgbClr val="26673D"/>
+                </a:solidFill>
+                <a:latin typeface="Inter"/>
+              </a:rPr>
+              <a:t>KEY FINISHES</a:t>
             </a:r>
           </a:p>
         </p:txBody>
       </p:sp>
       <p:pic>
         <p:nvPicPr>
-          <p:cNvPr id="5" name="Picture 4" descr="CAM_07_MD_Office_A.jpg"/>
+          <p:cNvPr id="6" name="Picture 5" descr="swatch_WD-01.jpg"/>
           <p:cNvPicPr>
             <a:picLocks noChangeAspect="1"/>
           </p:cNvPicPr>
@@ -12159,6 +14464,374 @@
         </p:nvPicPr>
         <p:blipFill>
           <a:blip r:embed="rId2"/>
+          <a:stretch>
+            <a:fillRect/>
+          </a:stretch>
+        </p:blipFill>
+        <p:spPr>
+          <a:xfrm>
+            <a:off x="508000" y="5245100"/>
+            <a:ext cx="793750" cy="660400"/>
+          </a:xfrm>
+          <a:prstGeom prst="rect">
+            <a:avLst/>
+          </a:prstGeom>
+        </p:spPr>
+      </p:pic>
+      <p:sp>
+        <p:nvSpPr>
+          <p:cNvPr id="7" name="TextBox 6"/>
+          <p:cNvSpPr txBox="1"/>
+          <p:nvPr/>
+        </p:nvSpPr>
+        <p:spPr>
+          <a:xfrm>
+            <a:off x="469900" y="5930900"/>
+            <a:ext cx="889000" cy="190500"/>
+          </a:xfrm>
+          <a:prstGeom prst="rect">
+            <a:avLst/>
+          </a:prstGeom>
+          <a:noFill/>
+        </p:spPr>
+        <p:txBody>
+          <a:bodyPr wrap="square">
+            <a:spAutoFit/>
+          </a:bodyPr>
+          <a:lstStyle/>
+          <a:p>
+            <a:r>
+              <a:rPr sz="1000" b="1">
+                <a:solidFill>
+                  <a:srgbClr val="26673D"/>
+                </a:solidFill>
+                <a:latin typeface="Inter"/>
+              </a:rPr>
+              <a:t>WD-01</a:t>
+            </a:r>
+          </a:p>
+        </p:txBody>
+      </p:sp>
+      <p:sp>
+        <p:nvSpPr>
+          <p:cNvPr id="8" name="TextBox 7"/>
+          <p:cNvSpPr txBox="1"/>
+          <p:nvPr/>
+        </p:nvSpPr>
+        <p:spPr>
+          <a:xfrm>
+            <a:off x="469900" y="6096000"/>
+            <a:ext cx="889000" cy="317500"/>
+          </a:xfrm>
+          <a:prstGeom prst="rect">
+            <a:avLst/>
+          </a:prstGeom>
+          <a:noFill/>
+        </p:spPr>
+        <p:txBody>
+          <a:bodyPr wrap="square">
+            <a:spAutoFit/>
+          </a:bodyPr>
+          <a:lstStyle/>
+          <a:p>
+            <a:r>
+              <a:rPr sz="900" b="0">
+                <a:solidFill>
+                  <a:srgbClr val="5A5750"/>
+                </a:solidFill>
+                <a:latin typeface="Inter"/>
+              </a:rPr>
+              <a:t>Oak herringbone</a:t>
+            </a:r>
+          </a:p>
+        </p:txBody>
+      </p:sp>
+      <p:pic>
+        <p:nvPicPr>
+          <p:cNvPr id="9" name="Picture 8" descr="swatch_WO-02.jpg"/>
+          <p:cNvPicPr>
+            <a:picLocks noChangeAspect="1"/>
+          </p:cNvPicPr>
+          <p:nvPr/>
+        </p:nvPicPr>
+        <p:blipFill>
+          <a:blip r:embed="rId3"/>
+          <a:stretch>
+            <a:fillRect/>
+          </a:stretch>
+        </p:blipFill>
+        <p:spPr>
+          <a:xfrm>
+            <a:off x="1428750" y="5245100"/>
+            <a:ext cx="793750" cy="660400"/>
+          </a:xfrm>
+          <a:prstGeom prst="rect">
+            <a:avLst/>
+          </a:prstGeom>
+        </p:spPr>
+      </p:pic>
+      <p:sp>
+        <p:nvSpPr>
+          <p:cNvPr id="10" name="TextBox 9"/>
+          <p:cNvSpPr txBox="1"/>
+          <p:nvPr/>
+        </p:nvSpPr>
+        <p:spPr>
+          <a:xfrm>
+            <a:off x="1390650" y="5930900"/>
+            <a:ext cx="889000" cy="190500"/>
+          </a:xfrm>
+          <a:prstGeom prst="rect">
+            <a:avLst/>
+          </a:prstGeom>
+          <a:noFill/>
+        </p:spPr>
+        <p:txBody>
+          <a:bodyPr wrap="square">
+            <a:spAutoFit/>
+          </a:bodyPr>
+          <a:lstStyle/>
+          <a:p>
+            <a:r>
+              <a:rPr sz="1000" b="1">
+                <a:solidFill>
+                  <a:srgbClr val="26673D"/>
+                </a:solidFill>
+                <a:latin typeface="Inter"/>
+              </a:rPr>
+              <a:t>WO-02</a:t>
+            </a:r>
+          </a:p>
+        </p:txBody>
+      </p:sp>
+      <p:sp>
+        <p:nvSpPr>
+          <p:cNvPr id="11" name="TextBox 10"/>
+          <p:cNvSpPr txBox="1"/>
+          <p:nvPr/>
+        </p:nvSpPr>
+        <p:spPr>
+          <a:xfrm>
+            <a:off x="1390650" y="6096000"/>
+            <a:ext cx="889000" cy="317500"/>
+          </a:xfrm>
+          <a:prstGeom prst="rect">
+            <a:avLst/>
+          </a:prstGeom>
+          <a:noFill/>
+        </p:spPr>
+        <p:txBody>
+          <a:bodyPr wrap="square">
+            <a:spAutoFit/>
+          </a:bodyPr>
+          <a:lstStyle/>
+          <a:p>
+            <a:r>
+              <a:rPr sz="900" b="0">
+                <a:solidFill>
+                  <a:srgbClr val="5A5750"/>
+                </a:solidFill>
+                <a:latin typeface="Inter"/>
+              </a:rPr>
+              <a:t>Smoked walnut</a:t>
+            </a:r>
+          </a:p>
+        </p:txBody>
+      </p:sp>
+      <p:pic>
+        <p:nvPicPr>
+          <p:cNvPr id="12" name="Picture 11" descr="swatch_UP-02.jpg"/>
+          <p:cNvPicPr>
+            <a:picLocks noChangeAspect="1"/>
+          </p:cNvPicPr>
+          <p:nvPr/>
+        </p:nvPicPr>
+        <p:blipFill>
+          <a:blip r:embed="rId4"/>
+          <a:stretch>
+            <a:fillRect/>
+          </a:stretch>
+        </p:blipFill>
+        <p:spPr>
+          <a:xfrm>
+            <a:off x="2349500" y="5245100"/>
+            <a:ext cx="793750" cy="660400"/>
+          </a:xfrm>
+          <a:prstGeom prst="rect">
+            <a:avLst/>
+          </a:prstGeom>
+        </p:spPr>
+      </p:pic>
+      <p:sp>
+        <p:nvSpPr>
+          <p:cNvPr id="13" name="TextBox 12"/>
+          <p:cNvSpPr txBox="1"/>
+          <p:nvPr/>
+        </p:nvSpPr>
+        <p:spPr>
+          <a:xfrm>
+            <a:off x="2311400" y="5930900"/>
+            <a:ext cx="889000" cy="190500"/>
+          </a:xfrm>
+          <a:prstGeom prst="rect">
+            <a:avLst/>
+          </a:prstGeom>
+          <a:noFill/>
+        </p:spPr>
+        <p:txBody>
+          <a:bodyPr wrap="square">
+            <a:spAutoFit/>
+          </a:bodyPr>
+          <a:lstStyle/>
+          <a:p>
+            <a:r>
+              <a:rPr sz="1000" b="1">
+                <a:solidFill>
+                  <a:srgbClr val="26673D"/>
+                </a:solidFill>
+                <a:latin typeface="Inter"/>
+              </a:rPr>
+              <a:t>UP-02</a:t>
+            </a:r>
+          </a:p>
+        </p:txBody>
+      </p:sp>
+      <p:sp>
+        <p:nvSpPr>
+          <p:cNvPr id="14" name="TextBox 13"/>
+          <p:cNvSpPr txBox="1"/>
+          <p:nvPr/>
+        </p:nvSpPr>
+        <p:spPr>
+          <a:xfrm>
+            <a:off x="2311400" y="6096000"/>
+            <a:ext cx="889000" cy="317500"/>
+          </a:xfrm>
+          <a:prstGeom prst="rect">
+            <a:avLst/>
+          </a:prstGeom>
+          <a:noFill/>
+        </p:spPr>
+        <p:txBody>
+          <a:bodyPr wrap="square">
+            <a:spAutoFit/>
+          </a:bodyPr>
+          <a:lstStyle/>
+          <a:p>
+            <a:r>
+              <a:rPr sz="900" b="0">
+                <a:solidFill>
+                  <a:srgbClr val="5A5750"/>
+                </a:solidFill>
+                <a:latin typeface="Inter"/>
+              </a:rPr>
+              <a:t>Cognac leather</a:t>
+            </a:r>
+          </a:p>
+        </p:txBody>
+      </p:sp>
+      <p:pic>
+        <p:nvPicPr>
+          <p:cNvPr id="15" name="Picture 14" descr="swatch_UP-01s.jpg"/>
+          <p:cNvPicPr>
+            <a:picLocks noChangeAspect="1"/>
+          </p:cNvPicPr>
+          <p:nvPr/>
+        </p:nvPicPr>
+        <p:blipFill>
+          <a:blip r:embed="rId5"/>
+          <a:stretch>
+            <a:fillRect/>
+          </a:stretch>
+        </p:blipFill>
+        <p:spPr>
+          <a:xfrm>
+            <a:off x="3270250" y="5245100"/>
+            <a:ext cx="793750" cy="660400"/>
+          </a:xfrm>
+          <a:prstGeom prst="rect">
+            <a:avLst/>
+          </a:prstGeom>
+        </p:spPr>
+      </p:pic>
+      <p:sp>
+        <p:nvSpPr>
+          <p:cNvPr id="16" name="TextBox 15"/>
+          <p:cNvSpPr txBox="1"/>
+          <p:nvPr/>
+        </p:nvSpPr>
+        <p:spPr>
+          <a:xfrm>
+            <a:off x="3232150" y="5930900"/>
+            <a:ext cx="889000" cy="190500"/>
+          </a:xfrm>
+          <a:prstGeom prst="rect">
+            <a:avLst/>
+          </a:prstGeom>
+          <a:noFill/>
+        </p:spPr>
+        <p:txBody>
+          <a:bodyPr wrap="square">
+            <a:spAutoFit/>
+          </a:bodyPr>
+          <a:lstStyle/>
+          <a:p>
+            <a:r>
+              <a:rPr sz="1000" b="1">
+                <a:solidFill>
+                  <a:srgbClr val="26673D"/>
+                </a:solidFill>
+                <a:latin typeface="Inter"/>
+              </a:rPr>
+              <a:t>UP-01</a:t>
+            </a:r>
+          </a:p>
+        </p:txBody>
+      </p:sp>
+      <p:sp>
+        <p:nvSpPr>
+          <p:cNvPr id="17" name="TextBox 16"/>
+          <p:cNvSpPr txBox="1"/>
+          <p:nvPr/>
+        </p:nvSpPr>
+        <p:spPr>
+          <a:xfrm>
+            <a:off x="3232150" y="6096000"/>
+            <a:ext cx="889000" cy="317500"/>
+          </a:xfrm>
+          <a:prstGeom prst="rect">
+            <a:avLst/>
+          </a:prstGeom>
+          <a:noFill/>
+        </p:spPr>
+        <p:txBody>
+          <a:bodyPr wrap="square">
+            <a:spAutoFit/>
+          </a:bodyPr>
+          <a:lstStyle/>
+          <a:p>
+            <a:r>
+              <a:rPr sz="900" b="0">
+                <a:solidFill>
+                  <a:srgbClr val="5A5750"/>
+                </a:solidFill>
+                <a:latin typeface="Inter"/>
+              </a:rPr>
+              <a:t>Sand fabric</a:t>
+            </a:r>
+          </a:p>
+        </p:txBody>
+      </p:sp>
+      <p:pic>
+        <p:nvPicPr>
+          <p:cNvPr id="18" name="Picture 17" descr="CAM_07_MD_Office_A.jpg"/>
+          <p:cNvPicPr>
+            <a:picLocks noChangeAspect="1"/>
+          </p:cNvPicPr>
+          <p:nvPr/>
+        </p:nvPicPr>
+        <p:blipFill>
+          <a:blip r:embed="rId6"/>
           <a:srcRect t="6335" b="6335"/>
           <a:stretch>
             <a:fillRect/>
@@ -12176,7 +14849,7 @@
       </p:pic>
       <p:sp>
         <p:nvSpPr>
-          <p:cNvPr id="6" name="TextBox 5"/>
+          <p:cNvPr id="19" name="TextBox 18"/>
           <p:cNvSpPr txBox="1"/>
           <p:nvPr/>
         </p:nvSpPr>
@@ -12203,21 +14876,21 @@
                 </a:solidFill>
                 <a:latin typeface="Inter"/>
               </a:rPr>
-              <a:t>MD office (preview render)</a:t>
+              <a:t>MD office</a:t>
             </a:r>
           </a:p>
         </p:txBody>
       </p:sp>
       <p:pic>
         <p:nvPicPr>
-          <p:cNvPr id="7" name="Picture 6" descr="CAM_08_MD_Office_B.jpg"/>
+          <p:cNvPr id="20" name="Picture 19" descr="CAM_08_MD_Office_B.jpg"/>
           <p:cNvPicPr>
             <a:picLocks noChangeAspect="1"/>
           </p:cNvPicPr>
           <p:nvPr/>
         </p:nvPicPr>
         <p:blipFill>
-          <a:blip r:embed="rId3"/>
+          <a:blip r:embed="rId7"/>
           <a:srcRect l="605" r="605"/>
           <a:stretch>
             <a:fillRect/>
@@ -12235,7 +14908,7 @@
       </p:pic>
       <p:sp>
         <p:nvSpPr>
-          <p:cNvPr id="8" name="TextBox 7"/>
+          <p:cNvPr id="21" name="TextBox 20"/>
           <p:cNvSpPr txBox="1"/>
           <p:nvPr/>
         </p:nvSpPr>
@@ -12269,14 +14942,14 @@
       </p:sp>
       <p:pic>
         <p:nvPicPr>
-          <p:cNvPr id="9" name="Picture 8" descr="CAM_17_Executive_Reception.jpg"/>
+          <p:cNvPr id="22" name="Picture 21" descr="CAM_17_Executive_Reception.jpg"/>
           <p:cNvPicPr>
             <a:picLocks noChangeAspect="1"/>
           </p:cNvPicPr>
           <p:nvPr/>
         </p:nvPicPr>
         <p:blipFill>
-          <a:blip r:embed="rId4"/>
+          <a:blip r:embed="rId8"/>
           <a:srcRect l="605" r="605"/>
           <a:stretch>
             <a:fillRect/>
@@ -12294,7 +14967,7 @@
       </p:pic>
       <p:sp>
         <p:nvSpPr>
-          <p:cNvPr id="10" name="TextBox 9"/>
+          <p:cNvPr id="23" name="TextBox 22"/>
           <p:cNvSpPr txBox="1"/>
           <p:nvPr/>
         </p:nvSpPr>
@@ -12328,7 +15001,7 @@
       </p:sp>
       <p:sp>
         <p:nvSpPr>
-          <p:cNvPr id="11" name="TextBox 10"/>
+          <p:cNvPr id="24" name="TextBox 23"/>
           <p:cNvSpPr txBox="1"/>
           <p:nvPr/>
         </p:nvSpPr>
@@ -12362,7 +15035,7 @@
       </p:sp>
       <p:sp>
         <p:nvSpPr>
-          <p:cNvPr id="12" name="TextBox 11"/>
+          <p:cNvPr id="25" name="TextBox 24"/>
           <p:cNvSpPr txBox="1"/>
           <p:nvPr/>
         </p:nvSpPr>

</xml_diff>

<commit_message>
Office interior: deck polish (credits, next steps, PPTX layout), deck/render checks, CAM_02 reframed, new finals
- full-bleed slides: render caption moved to a readable credit line; PPTX footer light on dark slides
- slide 17: recommended next steps (no dates or costs); PPTX table column widths fixed
- verify_deck.py (+ deck_manifest.json): every deck image byte-identical to a project render, previews labelled
- make_render_index.py: 02_RENDERED_IMAGES/README.md + final contact sheet
- CAM_02 reception camera turned so the whole logo is in view; queued for re-render
- finals: CAM_13, CAM_05, CAM_02 (first framing)

Co-Authored-By: Claude Opus 5.5 <noreply@anthropic.com>
Claude-Session: https://claude.ai/code/session_019J6nTRSYGkqYLBQiQa9fAH
</commit_message>
<xml_diff>
--- a/GARMENT_OFFICE_FINAL_PRESENTATION/03_PRESENTATION/Garment_Office_Design_Pitch.pptx
+++ b/GARMENT_OFFICE_FINAL_PRESENTATION/03_PRESENTATION/Garment_Office_Design_Pitch.pptx
@@ -3140,41 +3140,7 @@
       </p:pic>
       <p:sp>
         <p:nvSpPr>
-          <p:cNvPr id="3" name="TextBox 2"/>
-          <p:cNvSpPr txBox="1"/>
-          <p:nvPr/>
-        </p:nvSpPr>
-        <p:spPr>
-          <a:xfrm>
-            <a:off x="63500" y="6642100"/>
-            <a:ext cx="12065000" cy="190500"/>
-          </a:xfrm>
-          <a:prstGeom prst="rect">
-            <a:avLst/>
-          </a:prstGeom>
-          <a:noFill/>
-        </p:spPr>
-        <p:txBody>
-          <a:bodyPr wrap="square">
-            <a:spAutoFit/>
-          </a:bodyPr>
-          <a:lstStyle/>
-          <a:p>
-            <a:r>
-              <a:rPr sz="1100" b="0">
-                <a:solidFill>
-                  <a:srgbClr val="FFFFFF"/>
-                </a:solidFill>
-                <a:latin typeface="Inter"/>
-              </a:rPr>
-              <a:t>Experience centre - Blender Cycles render of the project model</a:t>
-            </a:r>
-          </a:p>
-        </p:txBody>
-      </p:sp>
-      <p:sp>
-        <p:nvSpPr>
-          <p:cNvPr id="4" name="Rectangle 3"/>
+          <p:cNvPr id="3" name="Rectangle 2"/>
           <p:cNvSpPr/>
           <p:nvPr/>
         </p:nvSpPr>
@@ -3217,7 +3183,7 @@
       </p:sp>
       <p:sp>
         <p:nvSpPr>
-          <p:cNvPr id="5" name="Rectangle 4"/>
+          <p:cNvPr id="4" name="Rectangle 3"/>
           <p:cNvSpPr/>
           <p:nvPr/>
         </p:nvSpPr>
@@ -3260,7 +3226,7 @@
       </p:sp>
       <p:pic>
         <p:nvPicPr>
-          <p:cNvPr id="6" name="Picture 5" descr="logo_zara_fashion_profile.png"/>
+          <p:cNvPr id="5" name="Picture 4" descr="logo_zara_fashion_profile.png"/>
           <p:cNvPicPr>
             <a:picLocks noChangeAspect="1"/>
           </p:cNvPicPr>
@@ -3284,7 +3250,7 @@
       </p:pic>
       <p:pic>
         <p:nvPicPr>
-          <p:cNvPr id="7" name="Picture 6" descr="logo_stage2_ltd.png"/>
+          <p:cNvPr id="6" name="Picture 5" descr="logo_stage2_ltd.png"/>
           <p:cNvPicPr>
             <a:picLocks noChangeAspect="1"/>
           </p:cNvPicPr>
@@ -3308,7 +3274,7 @@
       </p:pic>
       <p:pic>
         <p:nvPicPr>
-          <p:cNvPr id="8" name="Picture 7" descr="logo_stage2_unit1.png"/>
+          <p:cNvPr id="7" name="Picture 6" descr="logo_stage2_unit1.png"/>
           <p:cNvPicPr>
             <a:picLocks noChangeAspect="1"/>
           </p:cNvPicPr>
@@ -3332,7 +3298,7 @@
       </p:pic>
       <p:sp>
         <p:nvSpPr>
-          <p:cNvPr id="9" name="TextBox 8"/>
+          <p:cNvPr id="8" name="TextBox 7"/>
           <p:cNvSpPr txBox="1"/>
           <p:nvPr/>
         </p:nvSpPr>
@@ -3366,7 +3332,7 @@
       </p:sp>
       <p:sp>
         <p:nvSpPr>
-          <p:cNvPr id="10" name="TextBox 9"/>
+          <p:cNvPr id="9" name="TextBox 8"/>
           <p:cNvSpPr txBox="1"/>
           <p:nvPr/>
         </p:nvSpPr>
@@ -3400,7 +3366,7 @@
       </p:sp>
       <p:sp>
         <p:nvSpPr>
-          <p:cNvPr id="11" name="TextBox 10"/>
+          <p:cNvPr id="10" name="TextBox 9"/>
           <p:cNvSpPr txBox="1"/>
           <p:nvPr/>
         </p:nvSpPr>
@@ -3445,7 +3411,7 @@
       </p:sp>
       <p:pic>
         <p:nvPicPr>
-          <p:cNvPr id="12" name="Picture 11" descr="tagline_quality_compliance_commitment.png"/>
+          <p:cNvPr id="11" name="Picture 10" descr="tagline_quality_compliance_commitment.png"/>
           <p:cNvPicPr>
             <a:picLocks noChangeAspect="1"/>
           </p:cNvPicPr>
@@ -3469,6 +3435,41 @@
       </p:pic>
       <p:sp>
         <p:nvSpPr>
+          <p:cNvPr id="12" name="TextBox 11"/>
+          <p:cNvSpPr txBox="1"/>
+          <p:nvPr/>
+        </p:nvSpPr>
+        <p:spPr>
+          <a:xfrm>
+            <a:off x="5715000" y="6248400"/>
+            <a:ext cx="5969000" cy="190500"/>
+          </a:xfrm>
+          <a:prstGeom prst="rect">
+            <a:avLst/>
+          </a:prstGeom>
+          <a:noFill/>
+        </p:spPr>
+        <p:txBody>
+          <a:bodyPr wrap="square">
+            <a:spAutoFit/>
+          </a:bodyPr>
+          <a:lstStyle/>
+          <a:p>
+            <a:pPr algn="r"/>
+            <a:r>
+              <a:rPr sz="900" b="0">
+                <a:solidFill>
+                  <a:srgbClr val="C9D3CC"/>
+                </a:solidFill>
+                <a:latin typeface="Inter"/>
+              </a:rPr>
+              <a:t>Experience centre - Blender Cycles render of the project model</a:t>
+            </a:r>
+          </a:p>
+        </p:txBody>
+      </p:sp>
+      <p:sp>
+        <p:nvSpPr>
           <p:cNvPr id="13" name="TextBox 12"/>
           <p:cNvSpPr txBox="1"/>
           <p:nvPr/>
@@ -3492,7 +3493,7 @@
             <a:r>
               <a:rPr sz="900" b="0">
                 <a:solidFill>
-                  <a:srgbClr val="5A5750"/>
+                  <a:srgbClr val="A7B3AB"/>
                 </a:solidFill>
                 <a:latin typeface="Inter"/>
               </a:rPr>
@@ -3526,7 +3527,7 @@
             <a:r>
               <a:rPr sz="900" b="0">
                 <a:solidFill>
-                  <a:srgbClr val="5A5750"/>
+                  <a:srgbClr val="A7B3AB"/>
                 </a:solidFill>
                 <a:latin typeface="Inter"/>
               </a:rPr>
@@ -3604,7 +3605,7 @@
         <p:spPr>
           <a:xfrm>
             <a:off x="508000" y="863600"/>
-            <a:ext cx="3683000" cy="1524000"/>
+            <a:ext cx="3683000" cy="952500"/>
           </a:xfrm>
           <a:prstGeom prst="rect">
             <a:avLst/>
@@ -3637,22 +3638,22 @@
         </p:nvSpPr>
         <p:spPr>
           <a:xfrm>
-            <a:off x="508000" y="2540000"/>
-            <a:ext cx="3683000" cy="2349500"/>
-          </a:xfrm>
-          <a:prstGeom prst="rect">
-            <a:avLst/>
-          </a:prstGeom>
-          <a:noFill/>
-        </p:spPr>
-        <p:txBody>
-          <a:bodyPr wrap="square">
-            <a:spAutoFit/>
-          </a:bodyPr>
-          <a:lstStyle/>
-          <a:p>
-            <a:r>
-              <a:rPr sz="1400" b="0">
+            <a:off x="508000" y="1841500"/>
+            <a:ext cx="3683000" cy="3048000"/>
+          </a:xfrm>
+          <a:prstGeom prst="rect">
+            <a:avLst/>
+          </a:prstGeom>
+          <a:noFill/>
+        </p:spPr>
+        <p:txBody>
+          <a:bodyPr wrap="square">
+            <a:spAutoFit/>
+          </a:bodyPr>
+          <a:lstStyle/>
+          <a:p>
+            <a:r>
+              <a:rPr sz="1300" b="0">
                 <a:solidFill>
                   <a:srgbClr val="5A5750"/>
                 </a:solidFill>
@@ -3663,7 +3664,7 @@
           </a:p>
           <a:p>
             <a:r>
-              <a:rPr sz="1400" b="0">
+              <a:rPr sz="1300" b="0">
                 <a:solidFill>
                   <a:srgbClr val="5A5750"/>
                 </a:solidFill>
@@ -3674,7 +3675,7 @@
           </a:p>
           <a:p>
             <a:r>
-              <a:rPr sz="1400" b="0">
+              <a:rPr sz="1300" b="0">
                 <a:solidFill>
                   <a:srgbClr val="5A5750"/>
                 </a:solidFill>
@@ -3685,7 +3686,7 @@
           </a:p>
           <a:p>
             <a:r>
-              <a:rPr sz="1400" b="0">
+              <a:rPr sz="1300" b="0">
                 <a:solidFill>
                   <a:srgbClr val="5A5750"/>
                 </a:solidFill>
@@ -3696,7 +3697,7 @@
           </a:p>
           <a:p>
             <a:r>
-              <a:rPr sz="1400" b="0">
+              <a:rPr sz="1300" b="0">
                 <a:solidFill>
                   <a:srgbClr val="5A5750"/>
                 </a:solidFill>
@@ -3707,7 +3708,7 @@
           </a:p>
           <a:p>
             <a:r>
-              <a:rPr sz="1400" b="0">
+              <a:rPr sz="1300" b="0">
                 <a:solidFill>
                   <a:srgbClr val="5A5750"/>
                 </a:solidFill>
@@ -4147,14 +4148,59 @@
       </p:pic>
       <p:sp>
         <p:nvSpPr>
-          <p:cNvPr id="19" name="TextBox 18"/>
-          <p:cNvSpPr txBox="1"/>
-          <p:nvPr/>
-        </p:nvSpPr>
-        <p:spPr>
-          <a:xfrm>
-            <a:off x="4508500" y="3238500"/>
-            <a:ext cx="7112000" cy="190500"/>
+          <p:cNvPr id="19" name="Rectangle 18"/>
+          <p:cNvSpPr/>
+          <p:nvPr/>
+        </p:nvSpPr>
+        <p:spPr>
+          <a:xfrm>
+            <a:off x="4445000" y="3200400"/>
+            <a:ext cx="806450" cy="254000"/>
+          </a:xfrm>
+          <a:prstGeom prst="rect">
+            <a:avLst/>
+          </a:prstGeom>
+          <a:solidFill>
+            <a:srgbClr val="141412">
+              <a:alpha val="62000"/>
+            </a:srgbClr>
+          </a:solidFill>
+          <a:ln>
+            <a:noFill/>
+          </a:ln>
+        </p:spPr>
+        <p:style>
+          <a:lnRef idx="1">
+            <a:schemeClr val="accent1"/>
+          </a:lnRef>
+          <a:fillRef idx="3">
+            <a:schemeClr val="accent1"/>
+          </a:fillRef>
+          <a:effectRef idx="2">
+            <a:schemeClr val="accent1"/>
+          </a:effectRef>
+          <a:fontRef idx="minor">
+            <a:schemeClr val="lt1"/>
+          </a:fontRef>
+        </p:style>
+        <p:txBody>
+          <a:bodyPr rtlCol="0" anchor="ctr"/>
+          <a:lstStyle/>
+          <a:p>
+            <a:pPr algn="ctr"/>
+          </a:p>
+        </p:txBody>
+      </p:sp>
+      <p:sp>
+        <p:nvSpPr>
+          <p:cNvPr id="20" name="TextBox 19"/>
+          <p:cNvSpPr txBox="1"/>
+          <p:nvPr/>
+        </p:nvSpPr>
+        <p:spPr>
+          <a:xfrm>
+            <a:off x="4495800" y="3213100"/>
+            <a:ext cx="7137400" cy="215900"/>
           </a:xfrm>
           <a:prstGeom prst="rect">
             <a:avLst/>
@@ -4181,7 +4227,7 @@
       </p:sp>
       <p:pic>
         <p:nvPicPr>
-          <p:cNvPr id="20" name="Picture 19" descr="CAM_10_Boardroom_B.jpg"/>
+          <p:cNvPr id="21" name="Picture 20" descr="CAM_10_Boardroom_B.jpg"/>
           <p:cNvPicPr>
             <a:picLocks noChangeAspect="1"/>
           </p:cNvPicPr>
@@ -4206,14 +4252,59 @@
       </p:pic>
       <p:sp>
         <p:nvSpPr>
-          <p:cNvPr id="21" name="TextBox 20"/>
-          <p:cNvSpPr txBox="1"/>
-          <p:nvPr/>
-        </p:nvSpPr>
-        <p:spPr>
-          <a:xfrm>
-            <a:off x="4508500" y="6134100"/>
-            <a:ext cx="7112000" cy="190500"/>
+          <p:cNvPr id="22" name="Rectangle 21"/>
+          <p:cNvSpPr/>
+          <p:nvPr/>
+        </p:nvSpPr>
+        <p:spPr>
+          <a:xfrm>
+            <a:off x="4445000" y="6096000"/>
+            <a:ext cx="4165600" cy="254000"/>
+          </a:xfrm>
+          <a:prstGeom prst="rect">
+            <a:avLst/>
+          </a:prstGeom>
+          <a:solidFill>
+            <a:srgbClr val="141412">
+              <a:alpha val="62000"/>
+            </a:srgbClr>
+          </a:solidFill>
+          <a:ln>
+            <a:noFill/>
+          </a:ln>
+        </p:spPr>
+        <p:style>
+          <a:lnRef idx="1">
+            <a:schemeClr val="accent1"/>
+          </a:lnRef>
+          <a:fillRef idx="3">
+            <a:schemeClr val="accent1"/>
+          </a:fillRef>
+          <a:effectRef idx="2">
+            <a:schemeClr val="accent1"/>
+          </a:effectRef>
+          <a:fontRef idx="minor">
+            <a:schemeClr val="lt1"/>
+          </a:fontRef>
+        </p:style>
+        <p:txBody>
+          <a:bodyPr rtlCol="0" anchor="ctr"/>
+          <a:lstStyle/>
+          <a:p>
+            <a:pPr algn="ctr"/>
+          </a:p>
+        </p:txBody>
+      </p:sp>
+      <p:sp>
+        <p:nvSpPr>
+          <p:cNvPr id="23" name="TextBox 22"/>
+          <p:cNvSpPr txBox="1"/>
+          <p:nvPr/>
+        </p:nvSpPr>
+        <p:spPr>
+          <a:xfrm>
+            <a:off x="4495800" y="6108700"/>
+            <a:ext cx="7137400" cy="215900"/>
           </a:xfrm>
           <a:prstGeom prst="rect">
             <a:avLst/>
@@ -4240,7 +4331,7 @@
       </p:sp>
       <p:sp>
         <p:nvSpPr>
-          <p:cNvPr id="22" name="TextBox 21"/>
+          <p:cNvPr id="24" name="TextBox 23"/>
           <p:cNvSpPr txBox="1"/>
           <p:nvPr/>
         </p:nvSpPr>
@@ -4274,7 +4365,7 @@
       </p:sp>
       <p:sp>
         <p:nvSpPr>
-          <p:cNvPr id="23" name="TextBox 22"/>
+          <p:cNvPr id="25" name="TextBox 24"/>
           <p:cNvSpPr txBox="1"/>
           <p:nvPr/>
         </p:nvSpPr>
@@ -4375,7 +4466,7 @@
         <p:spPr>
           <a:xfrm>
             <a:off x="508000" y="863600"/>
-            <a:ext cx="3683000" cy="1524000"/>
+            <a:ext cx="3683000" cy="952500"/>
           </a:xfrm>
           <a:prstGeom prst="rect">
             <a:avLst/>
@@ -4408,22 +4499,22 @@
         </p:nvSpPr>
         <p:spPr>
           <a:xfrm>
-            <a:off x="508000" y="2540000"/>
-            <a:ext cx="3683000" cy="2349500"/>
-          </a:xfrm>
-          <a:prstGeom prst="rect">
-            <a:avLst/>
-          </a:prstGeom>
-          <a:noFill/>
-        </p:spPr>
-        <p:txBody>
-          <a:bodyPr wrap="square">
-            <a:spAutoFit/>
-          </a:bodyPr>
-          <a:lstStyle/>
-          <a:p>
-            <a:r>
-              <a:rPr sz="1400" b="0">
+            <a:off x="508000" y="1841500"/>
+            <a:ext cx="3683000" cy="3048000"/>
+          </a:xfrm>
+          <a:prstGeom prst="rect">
+            <a:avLst/>
+          </a:prstGeom>
+          <a:noFill/>
+        </p:spPr>
+        <p:txBody>
+          <a:bodyPr wrap="square">
+            <a:spAutoFit/>
+          </a:bodyPr>
+          <a:lstStyle/>
+          <a:p>
+            <a:r>
+              <a:rPr sz="1300" b="0">
                 <a:solidFill>
                   <a:srgbClr val="5A5750"/>
                 </a:solidFill>
@@ -4434,7 +4525,7 @@
           </a:p>
           <a:p>
             <a:r>
-              <a:rPr sz="1400" b="0">
+              <a:rPr sz="1300" b="0">
                 <a:solidFill>
                   <a:srgbClr val="5A5750"/>
                 </a:solidFill>
@@ -4445,7 +4536,7 @@
           </a:p>
           <a:p>
             <a:r>
-              <a:rPr sz="1400" b="0">
+              <a:rPr sz="1300" b="0">
                 <a:solidFill>
                   <a:srgbClr val="5A5750"/>
                 </a:solidFill>
@@ -4456,7 +4547,7 @@
           </a:p>
           <a:p>
             <a:r>
-              <a:rPr sz="1400" b="0">
+              <a:rPr sz="1300" b="0">
                 <a:solidFill>
                   <a:srgbClr val="5A5750"/>
                 </a:solidFill>
@@ -4467,7 +4558,7 @@
           </a:p>
           <a:p>
             <a:r>
-              <a:rPr sz="1400" b="0">
+              <a:rPr sz="1300" b="0">
                 <a:solidFill>
                   <a:srgbClr val="5A5750"/>
                 </a:solidFill>
@@ -4478,7 +4569,7 @@
           </a:p>
           <a:p>
             <a:r>
-              <a:rPr sz="1400" b="0">
+              <a:rPr sz="1300" b="0">
                 <a:solidFill>
                   <a:srgbClr val="5A5750"/>
                 </a:solidFill>
@@ -4918,14 +5009,59 @@
       </p:pic>
       <p:sp>
         <p:nvSpPr>
-          <p:cNvPr id="19" name="TextBox 18"/>
-          <p:cNvSpPr txBox="1"/>
-          <p:nvPr/>
-        </p:nvSpPr>
-        <p:spPr>
-          <a:xfrm>
-            <a:off x="4508500" y="4000500"/>
-            <a:ext cx="7112000" cy="190500"/>
+          <p:cNvPr id="19" name="Rectangle 18"/>
+          <p:cNvSpPr/>
+          <p:nvPr/>
+        </p:nvSpPr>
+        <p:spPr>
+          <a:xfrm>
+            <a:off x="4445000" y="3962400"/>
+            <a:ext cx="1905000" cy="254000"/>
+          </a:xfrm>
+          <a:prstGeom prst="rect">
+            <a:avLst/>
+          </a:prstGeom>
+          <a:solidFill>
+            <a:srgbClr val="141412">
+              <a:alpha val="62000"/>
+            </a:srgbClr>
+          </a:solidFill>
+          <a:ln>
+            <a:noFill/>
+          </a:ln>
+        </p:spPr>
+        <p:style>
+          <a:lnRef idx="1">
+            <a:schemeClr val="accent1"/>
+          </a:lnRef>
+          <a:fillRef idx="3">
+            <a:schemeClr val="accent1"/>
+          </a:fillRef>
+          <a:effectRef idx="2">
+            <a:schemeClr val="accent1"/>
+          </a:effectRef>
+          <a:fontRef idx="minor">
+            <a:schemeClr val="lt1"/>
+          </a:fontRef>
+        </p:style>
+        <p:txBody>
+          <a:bodyPr rtlCol="0" anchor="ctr"/>
+          <a:lstStyle/>
+          <a:p>
+            <a:pPr algn="ctr"/>
+          </a:p>
+        </p:txBody>
+      </p:sp>
+      <p:sp>
+        <p:nvSpPr>
+          <p:cNvPr id="20" name="TextBox 19"/>
+          <p:cNvSpPr txBox="1"/>
+          <p:nvPr/>
+        </p:nvSpPr>
+        <p:spPr>
+          <a:xfrm>
+            <a:off x="4495800" y="3975100"/>
+            <a:ext cx="7137400" cy="215900"/>
           </a:xfrm>
           <a:prstGeom prst="rect">
             <a:avLst/>
@@ -4952,7 +5088,7 @@
       </p:sp>
       <p:pic>
         <p:nvPicPr>
-          <p:cNvPr id="20" name="Picture 19" descr="CAM_12_Merchandising_B.jpg"/>
+          <p:cNvPr id="21" name="Picture 20" descr="CAM_12_Merchandising_B.jpg"/>
           <p:cNvPicPr>
             <a:picLocks noChangeAspect="1"/>
           </p:cNvPicPr>
@@ -4977,14 +5113,59 @@
       </p:pic>
       <p:sp>
         <p:nvSpPr>
-          <p:cNvPr id="21" name="TextBox 20"/>
-          <p:cNvSpPr txBox="1"/>
-          <p:nvPr/>
-        </p:nvSpPr>
-        <p:spPr>
-          <a:xfrm>
-            <a:off x="4508500" y="6134100"/>
-            <a:ext cx="3441700" cy="190500"/>
+          <p:cNvPr id="22" name="Rectangle 21"/>
+          <p:cNvSpPr/>
+          <p:nvPr/>
+        </p:nvSpPr>
+        <p:spPr>
+          <a:xfrm>
+            <a:off x="4445000" y="6096000"/>
+            <a:ext cx="3136900" cy="254000"/>
+          </a:xfrm>
+          <a:prstGeom prst="rect">
+            <a:avLst/>
+          </a:prstGeom>
+          <a:solidFill>
+            <a:srgbClr val="141412">
+              <a:alpha val="62000"/>
+            </a:srgbClr>
+          </a:solidFill>
+          <a:ln>
+            <a:noFill/>
+          </a:ln>
+        </p:spPr>
+        <p:style>
+          <a:lnRef idx="1">
+            <a:schemeClr val="accent1"/>
+          </a:lnRef>
+          <a:fillRef idx="3">
+            <a:schemeClr val="accent1"/>
+          </a:fillRef>
+          <a:effectRef idx="2">
+            <a:schemeClr val="accent1"/>
+          </a:effectRef>
+          <a:fontRef idx="minor">
+            <a:schemeClr val="lt1"/>
+          </a:fontRef>
+        </p:style>
+        <p:txBody>
+          <a:bodyPr rtlCol="0" anchor="ctr"/>
+          <a:lstStyle/>
+          <a:p>
+            <a:pPr algn="ctr"/>
+          </a:p>
+        </p:txBody>
+      </p:sp>
+      <p:sp>
+        <p:nvSpPr>
+          <p:cNvPr id="23" name="TextBox 22"/>
+          <p:cNvSpPr txBox="1"/>
+          <p:nvPr/>
+        </p:nvSpPr>
+        <p:spPr>
+          <a:xfrm>
+            <a:off x="4495800" y="6108700"/>
+            <a:ext cx="3467100" cy="215900"/>
           </a:xfrm>
           <a:prstGeom prst="rect">
             <a:avLst/>
@@ -5011,7 +5192,7 @@
       </p:sp>
       <p:pic>
         <p:nvPicPr>
-          <p:cNvPr id="22" name="Picture 21" descr="CAM_16_Commercial_Accounts.jpg"/>
+          <p:cNvPr id="24" name="Picture 23" descr="CAM_16_Commercial_Accounts.jpg"/>
           <p:cNvPicPr>
             <a:picLocks noChangeAspect="1"/>
           </p:cNvPicPr>
@@ -5036,14 +5217,59 @@
       </p:pic>
       <p:sp>
         <p:nvSpPr>
-          <p:cNvPr id="23" name="TextBox 22"/>
-          <p:cNvSpPr txBox="1"/>
-          <p:nvPr/>
-        </p:nvSpPr>
-        <p:spPr>
-          <a:xfrm>
-            <a:off x="8178800" y="6134100"/>
-            <a:ext cx="3441700" cy="190500"/>
+          <p:cNvPr id="25" name="Rectangle 24"/>
+          <p:cNvSpPr/>
+          <p:nvPr/>
+        </p:nvSpPr>
+        <p:spPr>
+          <a:xfrm>
+            <a:off x="8115300" y="6096000"/>
+            <a:ext cx="2794000" cy="254000"/>
+          </a:xfrm>
+          <a:prstGeom prst="rect">
+            <a:avLst/>
+          </a:prstGeom>
+          <a:solidFill>
+            <a:srgbClr val="141412">
+              <a:alpha val="62000"/>
+            </a:srgbClr>
+          </a:solidFill>
+          <a:ln>
+            <a:noFill/>
+          </a:ln>
+        </p:spPr>
+        <p:style>
+          <a:lnRef idx="1">
+            <a:schemeClr val="accent1"/>
+          </a:lnRef>
+          <a:fillRef idx="3">
+            <a:schemeClr val="accent1"/>
+          </a:fillRef>
+          <a:effectRef idx="2">
+            <a:schemeClr val="accent1"/>
+          </a:effectRef>
+          <a:fontRef idx="minor">
+            <a:schemeClr val="lt1"/>
+          </a:fontRef>
+        </p:style>
+        <p:txBody>
+          <a:bodyPr rtlCol="0" anchor="ctr"/>
+          <a:lstStyle/>
+          <a:p>
+            <a:pPr algn="ctr"/>
+          </a:p>
+        </p:txBody>
+      </p:sp>
+      <p:sp>
+        <p:nvSpPr>
+          <p:cNvPr id="26" name="TextBox 25"/>
+          <p:cNvSpPr txBox="1"/>
+          <p:nvPr/>
+        </p:nvSpPr>
+        <p:spPr>
+          <a:xfrm>
+            <a:off x="8166100" y="6108700"/>
+            <a:ext cx="3467100" cy="215900"/>
           </a:xfrm>
           <a:prstGeom prst="rect">
             <a:avLst/>
@@ -5070,7 +5296,7 @@
       </p:sp>
       <p:sp>
         <p:nvSpPr>
-          <p:cNvPr id="24" name="TextBox 23"/>
+          <p:cNvPr id="27" name="TextBox 26"/>
           <p:cNvSpPr txBox="1"/>
           <p:nvPr/>
         </p:nvSpPr>
@@ -5104,7 +5330,7 @@
       </p:sp>
       <p:sp>
         <p:nvSpPr>
-          <p:cNvPr id="25" name="TextBox 24"/>
+          <p:cNvPr id="28" name="TextBox 27"/>
           <p:cNvSpPr txBox="1"/>
           <p:nvPr/>
         </p:nvSpPr>
@@ -5205,7 +5431,7 @@
         <p:spPr>
           <a:xfrm>
             <a:off x="508000" y="863600"/>
-            <a:ext cx="3683000" cy="1524000"/>
+            <a:ext cx="3683000" cy="952500"/>
           </a:xfrm>
           <a:prstGeom prst="rect">
             <a:avLst/>
@@ -5238,22 +5464,22 @@
         </p:nvSpPr>
         <p:spPr>
           <a:xfrm>
-            <a:off x="508000" y="2540000"/>
-            <a:ext cx="3683000" cy="2349500"/>
-          </a:xfrm>
-          <a:prstGeom prst="rect">
-            <a:avLst/>
-          </a:prstGeom>
-          <a:noFill/>
-        </p:spPr>
-        <p:txBody>
-          <a:bodyPr wrap="square">
-            <a:spAutoFit/>
-          </a:bodyPr>
-          <a:lstStyle/>
-          <a:p>
-            <a:r>
-              <a:rPr sz="1400" b="0">
+            <a:off x="508000" y="1841500"/>
+            <a:ext cx="3683000" cy="3048000"/>
+          </a:xfrm>
+          <a:prstGeom prst="rect">
+            <a:avLst/>
+          </a:prstGeom>
+          <a:noFill/>
+        </p:spPr>
+        <p:txBody>
+          <a:bodyPr wrap="square">
+            <a:spAutoFit/>
+          </a:bodyPr>
+          <a:lstStyle/>
+          <a:p>
+            <a:r>
+              <a:rPr sz="1300" b="0">
                 <a:solidFill>
                   <a:srgbClr val="5A5750"/>
                 </a:solidFill>
@@ -5264,7 +5490,7 @@
           </a:p>
           <a:p>
             <a:r>
-              <a:rPr sz="1400" b="0">
+              <a:rPr sz="1300" b="0">
                 <a:solidFill>
                   <a:srgbClr val="5A5750"/>
                 </a:solidFill>
@@ -5275,7 +5501,7 @@
           </a:p>
           <a:p>
             <a:r>
-              <a:rPr sz="1400" b="0">
+              <a:rPr sz="1300" b="0">
                 <a:solidFill>
                   <a:srgbClr val="5A5750"/>
                 </a:solidFill>
@@ -5286,7 +5512,7 @@
           </a:p>
           <a:p>
             <a:r>
-              <a:rPr sz="1400" b="0">
+              <a:rPr sz="1300" b="0">
                 <a:solidFill>
                   <a:srgbClr val="5A5750"/>
                 </a:solidFill>
@@ -5297,7 +5523,7 @@
           </a:p>
           <a:p>
             <a:r>
-              <a:rPr sz="1400" b="0">
+              <a:rPr sz="1300" b="0">
                 <a:solidFill>
                   <a:srgbClr val="5A5750"/>
                 </a:solidFill>
@@ -5308,7 +5534,7 @@
           </a:p>
           <a:p>
             <a:r>
-              <a:rPr sz="1400" b="0">
+              <a:rPr sz="1300" b="0">
                 <a:solidFill>
                   <a:srgbClr val="5A5750"/>
                 </a:solidFill>
@@ -5319,7 +5545,7 @@
           </a:p>
           <a:p>
             <a:r>
-              <a:rPr sz="1400" b="0">
+              <a:rPr sz="1300" b="0">
                 <a:solidFill>
                   <a:srgbClr val="5A5750"/>
                 </a:solidFill>
@@ -5759,14 +5985,59 @@
       </p:pic>
       <p:sp>
         <p:nvSpPr>
-          <p:cNvPr id="19" name="TextBox 18"/>
-          <p:cNvSpPr txBox="1"/>
-          <p:nvPr/>
-        </p:nvSpPr>
-        <p:spPr>
-          <a:xfrm>
-            <a:off x="4508500" y="4000500"/>
-            <a:ext cx="7112000" cy="190500"/>
+          <p:cNvPr id="19" name="Rectangle 18"/>
+          <p:cNvSpPr/>
+          <p:nvPr/>
+        </p:nvSpPr>
+        <p:spPr>
+          <a:xfrm>
+            <a:off x="4445000" y="3962400"/>
+            <a:ext cx="1562100" cy="254000"/>
+          </a:xfrm>
+          <a:prstGeom prst="rect">
+            <a:avLst/>
+          </a:prstGeom>
+          <a:solidFill>
+            <a:srgbClr val="141412">
+              <a:alpha val="62000"/>
+            </a:srgbClr>
+          </a:solidFill>
+          <a:ln>
+            <a:noFill/>
+          </a:ln>
+        </p:spPr>
+        <p:style>
+          <a:lnRef idx="1">
+            <a:schemeClr val="accent1"/>
+          </a:lnRef>
+          <a:fillRef idx="3">
+            <a:schemeClr val="accent1"/>
+          </a:fillRef>
+          <a:effectRef idx="2">
+            <a:schemeClr val="accent1"/>
+          </a:effectRef>
+          <a:fontRef idx="minor">
+            <a:schemeClr val="lt1"/>
+          </a:fontRef>
+        </p:style>
+        <p:txBody>
+          <a:bodyPr rtlCol="0" anchor="ctr"/>
+          <a:lstStyle/>
+          <a:p>
+            <a:pPr algn="ctr"/>
+          </a:p>
+        </p:txBody>
+      </p:sp>
+      <p:sp>
+        <p:nvSpPr>
+          <p:cNvPr id="20" name="TextBox 19"/>
+          <p:cNvSpPr txBox="1"/>
+          <p:nvPr/>
+        </p:nvSpPr>
+        <p:spPr>
+          <a:xfrm>
+            <a:off x="4495800" y="3975100"/>
+            <a:ext cx="7137400" cy="215900"/>
           </a:xfrm>
           <a:prstGeom prst="rect">
             <a:avLst/>
@@ -5786,14 +6057,14 @@
                 </a:solidFill>
                 <a:latin typeface="Inter"/>
               </a:rPr>
-              <a:t>Global Design Studio (preview render)</a:t>
+              <a:t>Global Design Studio</a:t>
             </a:r>
           </a:p>
         </p:txBody>
       </p:sp>
       <p:pic>
         <p:nvPicPr>
-          <p:cNvPr id="20" name="Picture 19" descr="CAM_14_Design_Studio_B.jpg"/>
+          <p:cNvPr id="21" name="Picture 20" descr="CAM_14_Design_Studio_B.jpg"/>
           <p:cNvPicPr>
             <a:picLocks noChangeAspect="1"/>
           </p:cNvPicPr>
@@ -5818,14 +6089,59 @@
       </p:pic>
       <p:sp>
         <p:nvSpPr>
-          <p:cNvPr id="21" name="TextBox 20"/>
-          <p:cNvSpPr txBox="1"/>
-          <p:nvPr/>
-        </p:nvSpPr>
-        <p:spPr>
-          <a:xfrm>
-            <a:off x="4508500" y="6134100"/>
-            <a:ext cx="3441700" cy="190500"/>
+          <p:cNvPr id="22" name="Rectangle 21"/>
+          <p:cNvSpPr/>
+          <p:nvPr/>
+        </p:nvSpPr>
+        <p:spPr>
+          <a:xfrm>
+            <a:off x="4445000" y="6096000"/>
+            <a:ext cx="3568700" cy="254000"/>
+          </a:xfrm>
+          <a:prstGeom prst="rect">
+            <a:avLst/>
+          </a:prstGeom>
+          <a:solidFill>
+            <a:srgbClr val="141412">
+              <a:alpha val="62000"/>
+            </a:srgbClr>
+          </a:solidFill>
+          <a:ln>
+            <a:noFill/>
+          </a:ln>
+        </p:spPr>
+        <p:style>
+          <a:lnRef idx="1">
+            <a:schemeClr val="accent1"/>
+          </a:lnRef>
+          <a:fillRef idx="3">
+            <a:schemeClr val="accent1"/>
+          </a:fillRef>
+          <a:effectRef idx="2">
+            <a:schemeClr val="accent1"/>
+          </a:effectRef>
+          <a:fontRef idx="minor">
+            <a:schemeClr val="lt1"/>
+          </a:fontRef>
+        </p:style>
+        <p:txBody>
+          <a:bodyPr rtlCol="0" anchor="ctr"/>
+          <a:lstStyle/>
+          <a:p>
+            <a:pPr algn="ctr"/>
+          </a:p>
+        </p:txBody>
+      </p:sp>
+      <p:sp>
+        <p:nvSpPr>
+          <p:cNvPr id="23" name="TextBox 22"/>
+          <p:cNvSpPr txBox="1"/>
+          <p:nvPr/>
+        </p:nvSpPr>
+        <p:spPr>
+          <a:xfrm>
+            <a:off x="4495800" y="6108700"/>
+            <a:ext cx="3467100" cy="215900"/>
           </a:xfrm>
           <a:prstGeom prst="rect">
             <a:avLst/>
@@ -5852,7 +6168,7 @@
       </p:sp>
       <p:pic>
         <p:nvPicPr>
-          <p:cNvPr id="22" name="Picture 21" descr="CAM_15_CAD_Room.jpg"/>
+          <p:cNvPr id="24" name="Picture 23" descr="CAM_15_CAD_Room.jpg"/>
           <p:cNvPicPr>
             <a:picLocks noChangeAspect="1"/>
           </p:cNvPicPr>
@@ -5877,14 +6193,59 @@
       </p:pic>
       <p:sp>
         <p:nvSpPr>
-          <p:cNvPr id="23" name="TextBox 22"/>
-          <p:cNvSpPr txBox="1"/>
-          <p:nvPr/>
-        </p:nvSpPr>
-        <p:spPr>
-          <a:xfrm>
-            <a:off x="8178800" y="6134100"/>
-            <a:ext cx="3441700" cy="190500"/>
+          <p:cNvPr id="25" name="Rectangle 24"/>
+          <p:cNvSpPr/>
+          <p:nvPr/>
+        </p:nvSpPr>
+        <p:spPr>
+          <a:xfrm>
+            <a:off x="8115300" y="6096000"/>
+            <a:ext cx="2863850" cy="254000"/>
+          </a:xfrm>
+          <a:prstGeom prst="rect">
+            <a:avLst/>
+          </a:prstGeom>
+          <a:solidFill>
+            <a:srgbClr val="141412">
+              <a:alpha val="62000"/>
+            </a:srgbClr>
+          </a:solidFill>
+          <a:ln>
+            <a:noFill/>
+          </a:ln>
+        </p:spPr>
+        <p:style>
+          <a:lnRef idx="1">
+            <a:schemeClr val="accent1"/>
+          </a:lnRef>
+          <a:fillRef idx="3">
+            <a:schemeClr val="accent1"/>
+          </a:fillRef>
+          <a:effectRef idx="2">
+            <a:schemeClr val="accent1"/>
+          </a:effectRef>
+          <a:fontRef idx="minor">
+            <a:schemeClr val="lt1"/>
+          </a:fontRef>
+        </p:style>
+        <p:txBody>
+          <a:bodyPr rtlCol="0" anchor="ctr"/>
+          <a:lstStyle/>
+          <a:p>
+            <a:pPr algn="ctr"/>
+          </a:p>
+        </p:txBody>
+      </p:sp>
+      <p:sp>
+        <p:nvSpPr>
+          <p:cNvPr id="26" name="TextBox 25"/>
+          <p:cNvSpPr txBox="1"/>
+          <p:nvPr/>
+        </p:nvSpPr>
+        <p:spPr>
+          <a:xfrm>
+            <a:off x="8166100" y="6108700"/>
+            <a:ext cx="3467100" cy="215900"/>
           </a:xfrm>
           <a:prstGeom prst="rect">
             <a:avLst/>
@@ -5911,7 +6272,7 @@
       </p:sp>
       <p:sp>
         <p:nvSpPr>
-          <p:cNvPr id="24" name="TextBox 23"/>
+          <p:cNvPr id="27" name="TextBox 26"/>
           <p:cNvSpPr txBox="1"/>
           <p:nvPr/>
         </p:nvSpPr>
@@ -5945,7 +6306,7 @@
       </p:sp>
       <p:sp>
         <p:nvSpPr>
-          <p:cNvPr id="25" name="TextBox 24"/>
+          <p:cNvPr id="28" name="TextBox 27"/>
           <p:cNvSpPr txBox="1"/>
           <p:nvPr/>
         </p:nvSpPr>
@@ -6098,14 +6459,59 @@
       </p:pic>
       <p:sp>
         <p:nvSpPr>
-          <p:cNvPr id="5" name="TextBox 4"/>
-          <p:cNvSpPr txBox="1"/>
-          <p:nvPr/>
-        </p:nvSpPr>
-        <p:spPr>
-          <a:xfrm>
-            <a:off x="571500" y="3733800"/>
-            <a:ext cx="3511550" cy="190500"/>
+          <p:cNvPr id="5" name="Rectangle 4"/>
+          <p:cNvSpPr/>
+          <p:nvPr/>
+        </p:nvSpPr>
+        <p:spPr>
+          <a:xfrm>
+            <a:off x="508000" y="3695700"/>
+            <a:ext cx="2654300" cy="254000"/>
+          </a:xfrm>
+          <a:prstGeom prst="rect">
+            <a:avLst/>
+          </a:prstGeom>
+          <a:solidFill>
+            <a:srgbClr val="141412">
+              <a:alpha val="62000"/>
+            </a:srgbClr>
+          </a:solidFill>
+          <a:ln>
+            <a:noFill/>
+          </a:ln>
+        </p:spPr>
+        <p:style>
+          <a:lnRef idx="1">
+            <a:schemeClr val="accent1"/>
+          </a:lnRef>
+          <a:fillRef idx="3">
+            <a:schemeClr val="accent1"/>
+          </a:fillRef>
+          <a:effectRef idx="2">
+            <a:schemeClr val="accent1"/>
+          </a:effectRef>
+          <a:fontRef idx="minor">
+            <a:schemeClr val="lt1"/>
+          </a:fontRef>
+        </p:style>
+        <p:txBody>
+          <a:bodyPr rtlCol="0" anchor="ctr"/>
+          <a:lstStyle/>
+          <a:p>
+            <a:pPr algn="ctr"/>
+          </a:p>
+        </p:txBody>
+      </p:sp>
+      <p:sp>
+        <p:nvSpPr>
+          <p:cNvPr id="6" name="TextBox 5"/>
+          <p:cNvSpPr txBox="1"/>
+          <p:nvPr/>
+        </p:nvSpPr>
+        <p:spPr>
+          <a:xfrm>
+            <a:off x="558800" y="3708400"/>
+            <a:ext cx="3536950" cy="215900"/>
           </a:xfrm>
           <a:prstGeom prst="rect">
             <a:avLst/>
@@ -6132,7 +6538,7 @@
       </p:sp>
       <p:pic>
         <p:nvPicPr>
-          <p:cNvPr id="6" name="Picture 5" descr="CAM_21_Lounge_Training.jpg"/>
+          <p:cNvPr id="7" name="Picture 6" descr="CAM_21_Lounge_Training.jpg"/>
           <p:cNvPicPr>
             <a:picLocks noChangeAspect="1"/>
           </p:cNvPicPr>
@@ -6157,14 +6563,59 @@
       </p:pic>
       <p:sp>
         <p:nvSpPr>
-          <p:cNvPr id="7" name="TextBox 6"/>
-          <p:cNvSpPr txBox="1"/>
-          <p:nvPr/>
-        </p:nvSpPr>
-        <p:spPr>
-          <a:xfrm>
-            <a:off x="4337050" y="3733800"/>
-            <a:ext cx="3511550" cy="190500"/>
+          <p:cNvPr id="8" name="Rectangle 7"/>
+          <p:cNvSpPr/>
+          <p:nvPr/>
+        </p:nvSpPr>
+        <p:spPr>
+          <a:xfrm>
+            <a:off x="4273550" y="3695700"/>
+            <a:ext cx="3549650" cy="254000"/>
+          </a:xfrm>
+          <a:prstGeom prst="rect">
+            <a:avLst/>
+          </a:prstGeom>
+          <a:solidFill>
+            <a:srgbClr val="141412">
+              <a:alpha val="62000"/>
+            </a:srgbClr>
+          </a:solidFill>
+          <a:ln>
+            <a:noFill/>
+          </a:ln>
+        </p:spPr>
+        <p:style>
+          <a:lnRef idx="1">
+            <a:schemeClr val="accent1"/>
+          </a:lnRef>
+          <a:fillRef idx="3">
+            <a:schemeClr val="accent1"/>
+          </a:fillRef>
+          <a:effectRef idx="2">
+            <a:schemeClr val="accent1"/>
+          </a:effectRef>
+          <a:fontRef idx="minor">
+            <a:schemeClr val="lt1"/>
+          </a:fontRef>
+        </p:style>
+        <p:txBody>
+          <a:bodyPr rtlCol="0" anchor="ctr"/>
+          <a:lstStyle/>
+          <a:p>
+            <a:pPr algn="ctr"/>
+          </a:p>
+        </p:txBody>
+      </p:sp>
+      <p:sp>
+        <p:nvSpPr>
+          <p:cNvPr id="9" name="TextBox 8"/>
+          <p:cNvSpPr txBox="1"/>
+          <p:nvPr/>
+        </p:nvSpPr>
+        <p:spPr>
+          <a:xfrm>
+            <a:off x="4324350" y="3708400"/>
+            <a:ext cx="3536950" cy="215900"/>
           </a:xfrm>
           <a:prstGeom prst="rect">
             <a:avLst/>
@@ -6191,7 +6642,7 @@
       </p:sp>
       <p:pic>
         <p:nvPicPr>
-          <p:cNvPr id="8" name="Picture 7" descr="CAM_22_Prayer_Male.jpg"/>
+          <p:cNvPr id="10" name="Picture 9" descr="CAM_22_Prayer_Male.jpg"/>
           <p:cNvPicPr>
             <a:picLocks noChangeAspect="1"/>
           </p:cNvPicPr>
@@ -6216,14 +6667,59 @@
       </p:pic>
       <p:sp>
         <p:nvSpPr>
-          <p:cNvPr id="9" name="TextBox 8"/>
-          <p:cNvSpPr txBox="1"/>
-          <p:nvPr/>
-        </p:nvSpPr>
-        <p:spPr>
-          <a:xfrm>
-            <a:off x="8102600" y="3733800"/>
-            <a:ext cx="3511550" cy="190500"/>
+          <p:cNvPr id="11" name="Rectangle 10"/>
+          <p:cNvSpPr/>
+          <p:nvPr/>
+        </p:nvSpPr>
+        <p:spPr>
+          <a:xfrm>
+            <a:off x="8039100" y="3695700"/>
+            <a:ext cx="2590800" cy="254000"/>
+          </a:xfrm>
+          <a:prstGeom prst="rect">
+            <a:avLst/>
+          </a:prstGeom>
+          <a:solidFill>
+            <a:srgbClr val="141412">
+              <a:alpha val="62000"/>
+            </a:srgbClr>
+          </a:solidFill>
+          <a:ln>
+            <a:noFill/>
+          </a:ln>
+        </p:spPr>
+        <p:style>
+          <a:lnRef idx="1">
+            <a:schemeClr val="accent1"/>
+          </a:lnRef>
+          <a:fillRef idx="3">
+            <a:schemeClr val="accent1"/>
+          </a:fillRef>
+          <a:effectRef idx="2">
+            <a:schemeClr val="accent1"/>
+          </a:effectRef>
+          <a:fontRef idx="minor">
+            <a:schemeClr val="lt1"/>
+          </a:fontRef>
+        </p:style>
+        <p:txBody>
+          <a:bodyPr rtlCol="0" anchor="ctr"/>
+          <a:lstStyle/>
+          <a:p>
+            <a:pPr algn="ctr"/>
+          </a:p>
+        </p:txBody>
+      </p:sp>
+      <p:sp>
+        <p:nvSpPr>
+          <p:cNvPr id="12" name="TextBox 11"/>
+          <p:cNvSpPr txBox="1"/>
+          <p:nvPr/>
+        </p:nvSpPr>
+        <p:spPr>
+          <a:xfrm>
+            <a:off x="8089900" y="3708400"/>
+            <a:ext cx="3536950" cy="215900"/>
           </a:xfrm>
           <a:prstGeom prst="rect">
             <a:avLst/>
@@ -6250,7 +6746,7 @@
       </p:sp>
       <p:pic>
         <p:nvPicPr>
-          <p:cNvPr id="10" name="Picture 9" descr="CAM_23_Sample_Room.jpg"/>
+          <p:cNvPr id="13" name="Picture 12" descr="CAM_23_Sample_Room.jpg"/>
           <p:cNvPicPr>
             <a:picLocks noChangeAspect="1"/>
           </p:cNvPicPr>
@@ -6275,14 +6771,59 @@
       </p:pic>
       <p:sp>
         <p:nvSpPr>
-          <p:cNvPr id="11" name="TextBox 10"/>
-          <p:cNvSpPr txBox="1"/>
-          <p:nvPr/>
-        </p:nvSpPr>
-        <p:spPr>
-          <a:xfrm>
-            <a:off x="571500" y="6032500"/>
-            <a:ext cx="3511550" cy="190500"/>
+          <p:cNvPr id="14" name="Rectangle 13"/>
+          <p:cNvSpPr/>
+          <p:nvPr/>
+        </p:nvSpPr>
+        <p:spPr>
+          <a:xfrm>
+            <a:off x="508000" y="5994400"/>
+            <a:ext cx="2590800" cy="254000"/>
+          </a:xfrm>
+          <a:prstGeom prst="rect">
+            <a:avLst/>
+          </a:prstGeom>
+          <a:solidFill>
+            <a:srgbClr val="141412">
+              <a:alpha val="62000"/>
+            </a:srgbClr>
+          </a:solidFill>
+          <a:ln>
+            <a:noFill/>
+          </a:ln>
+        </p:spPr>
+        <p:style>
+          <a:lnRef idx="1">
+            <a:schemeClr val="accent1"/>
+          </a:lnRef>
+          <a:fillRef idx="3">
+            <a:schemeClr val="accent1"/>
+          </a:fillRef>
+          <a:effectRef idx="2">
+            <a:schemeClr val="accent1"/>
+          </a:effectRef>
+          <a:fontRef idx="minor">
+            <a:schemeClr val="lt1"/>
+          </a:fontRef>
+        </p:style>
+        <p:txBody>
+          <a:bodyPr rtlCol="0" anchor="ctr"/>
+          <a:lstStyle/>
+          <a:p>
+            <a:pPr algn="ctr"/>
+          </a:p>
+        </p:txBody>
+      </p:sp>
+      <p:sp>
+        <p:nvSpPr>
+          <p:cNvPr id="15" name="TextBox 14"/>
+          <p:cNvSpPr txBox="1"/>
+          <p:nvPr/>
+        </p:nvSpPr>
+        <p:spPr>
+          <a:xfrm>
+            <a:off x="558800" y="6007100"/>
+            <a:ext cx="3536950" cy="215900"/>
           </a:xfrm>
           <a:prstGeom prst="rect">
             <a:avLst/>
@@ -6309,7 +6850,7 @@
       </p:sp>
       <p:pic>
         <p:nvPicPr>
-          <p:cNvPr id="12" name="Picture 11" descr="CAM_25_Fabric_Library.jpg"/>
+          <p:cNvPr id="16" name="Picture 15" descr="CAM_25_Fabric_Library.jpg"/>
           <p:cNvPicPr>
             <a:picLocks noChangeAspect="1"/>
           </p:cNvPicPr>
@@ -6334,14 +6875,59 @@
       </p:pic>
       <p:sp>
         <p:nvSpPr>
-          <p:cNvPr id="13" name="TextBox 12"/>
-          <p:cNvSpPr txBox="1"/>
-          <p:nvPr/>
-        </p:nvSpPr>
-        <p:spPr>
-          <a:xfrm>
-            <a:off x="4337050" y="6032500"/>
-            <a:ext cx="3511550" cy="190500"/>
+          <p:cNvPr id="17" name="Rectangle 16"/>
+          <p:cNvSpPr/>
+          <p:nvPr/>
+        </p:nvSpPr>
+        <p:spPr>
+          <a:xfrm>
+            <a:off x="4273550" y="5994400"/>
+            <a:ext cx="2794000" cy="254000"/>
+          </a:xfrm>
+          <a:prstGeom prst="rect">
+            <a:avLst/>
+          </a:prstGeom>
+          <a:solidFill>
+            <a:srgbClr val="141412">
+              <a:alpha val="62000"/>
+            </a:srgbClr>
+          </a:solidFill>
+          <a:ln>
+            <a:noFill/>
+          </a:ln>
+        </p:spPr>
+        <p:style>
+          <a:lnRef idx="1">
+            <a:schemeClr val="accent1"/>
+          </a:lnRef>
+          <a:fillRef idx="3">
+            <a:schemeClr val="accent1"/>
+          </a:fillRef>
+          <a:effectRef idx="2">
+            <a:schemeClr val="accent1"/>
+          </a:effectRef>
+          <a:fontRef idx="minor">
+            <a:schemeClr val="lt1"/>
+          </a:fontRef>
+        </p:style>
+        <p:txBody>
+          <a:bodyPr rtlCol="0" anchor="ctr"/>
+          <a:lstStyle/>
+          <a:p>
+            <a:pPr algn="ctr"/>
+          </a:p>
+        </p:txBody>
+      </p:sp>
+      <p:sp>
+        <p:nvSpPr>
+          <p:cNvPr id="18" name="TextBox 17"/>
+          <p:cNvSpPr txBox="1"/>
+          <p:nvPr/>
+        </p:nvSpPr>
+        <p:spPr>
+          <a:xfrm>
+            <a:off x="4324350" y="6007100"/>
+            <a:ext cx="3536950" cy="215900"/>
           </a:xfrm>
           <a:prstGeom prst="rect">
             <a:avLst/>
@@ -6368,7 +6954,7 @@
       </p:sp>
       <p:pic>
         <p:nvPicPr>
-          <p:cNvPr id="14" name="Picture 13" descr="CAM_28_Washroom_Male.jpg"/>
+          <p:cNvPr id="19" name="Picture 18" descr="CAM_28_Washroom_Male.jpg"/>
           <p:cNvPicPr>
             <a:picLocks noChangeAspect="1"/>
           </p:cNvPicPr>
@@ -6393,14 +6979,59 @@
       </p:pic>
       <p:sp>
         <p:nvSpPr>
-          <p:cNvPr id="15" name="TextBox 14"/>
-          <p:cNvSpPr txBox="1"/>
-          <p:nvPr/>
-        </p:nvSpPr>
-        <p:spPr>
-          <a:xfrm>
-            <a:off x="8102600" y="6032500"/>
-            <a:ext cx="3511550" cy="190500"/>
+          <p:cNvPr id="20" name="Rectangle 19"/>
+          <p:cNvSpPr/>
+          <p:nvPr/>
+        </p:nvSpPr>
+        <p:spPr>
+          <a:xfrm>
+            <a:off x="8039100" y="5994400"/>
+            <a:ext cx="2311400" cy="254000"/>
+          </a:xfrm>
+          <a:prstGeom prst="rect">
+            <a:avLst/>
+          </a:prstGeom>
+          <a:solidFill>
+            <a:srgbClr val="141412">
+              <a:alpha val="62000"/>
+            </a:srgbClr>
+          </a:solidFill>
+          <a:ln>
+            <a:noFill/>
+          </a:ln>
+        </p:spPr>
+        <p:style>
+          <a:lnRef idx="1">
+            <a:schemeClr val="accent1"/>
+          </a:lnRef>
+          <a:fillRef idx="3">
+            <a:schemeClr val="accent1"/>
+          </a:fillRef>
+          <a:effectRef idx="2">
+            <a:schemeClr val="accent1"/>
+          </a:effectRef>
+          <a:fontRef idx="minor">
+            <a:schemeClr val="lt1"/>
+          </a:fontRef>
+        </p:style>
+        <p:txBody>
+          <a:bodyPr rtlCol="0" anchor="ctr"/>
+          <a:lstStyle/>
+          <a:p>
+            <a:pPr algn="ctr"/>
+          </a:p>
+        </p:txBody>
+      </p:sp>
+      <p:sp>
+        <p:nvSpPr>
+          <p:cNvPr id="21" name="TextBox 20"/>
+          <p:cNvSpPr txBox="1"/>
+          <p:nvPr/>
+        </p:nvSpPr>
+        <p:spPr>
+          <a:xfrm>
+            <a:off x="8089900" y="6007100"/>
+            <a:ext cx="3536950" cy="215900"/>
           </a:xfrm>
           <a:prstGeom prst="rect">
             <a:avLst/>
@@ -6427,7 +7058,7 @@
       </p:sp>
       <p:sp>
         <p:nvSpPr>
-          <p:cNvPr id="16" name="TextBox 15"/>
+          <p:cNvPr id="22" name="TextBox 21"/>
           <p:cNvSpPr txBox="1"/>
           <p:nvPr/>
         </p:nvSpPr>
@@ -6461,7 +7092,7 @@
       </p:sp>
       <p:sp>
         <p:nvSpPr>
-          <p:cNvPr id="17" name="TextBox 16"/>
+          <p:cNvPr id="23" name="TextBox 22"/>
           <p:cNvSpPr txBox="1"/>
           <p:nvPr/>
         </p:nvSpPr>
@@ -7287,14 +7918,59 @@
       </p:pic>
       <p:sp>
         <p:nvSpPr>
-          <p:cNvPr id="7" name="TextBox 6"/>
-          <p:cNvSpPr txBox="1"/>
-          <p:nvPr/>
-        </p:nvSpPr>
-        <p:spPr>
-          <a:xfrm>
-            <a:off x="4889500" y="6134100"/>
-            <a:ext cx="6731000" cy="190500"/>
+          <p:cNvPr id="7" name="Rectangle 6"/>
+          <p:cNvSpPr/>
+          <p:nvPr/>
+        </p:nvSpPr>
+        <p:spPr>
+          <a:xfrm>
+            <a:off x="4826000" y="6096000"/>
+            <a:ext cx="4851400" cy="254000"/>
+          </a:xfrm>
+          <a:prstGeom prst="rect">
+            <a:avLst/>
+          </a:prstGeom>
+          <a:solidFill>
+            <a:srgbClr val="141412">
+              <a:alpha val="62000"/>
+            </a:srgbClr>
+          </a:solidFill>
+          <a:ln>
+            <a:noFill/>
+          </a:ln>
+        </p:spPr>
+        <p:style>
+          <a:lnRef idx="1">
+            <a:schemeClr val="accent1"/>
+          </a:lnRef>
+          <a:fillRef idx="3">
+            <a:schemeClr val="accent1"/>
+          </a:fillRef>
+          <a:effectRef idx="2">
+            <a:schemeClr val="accent1"/>
+          </a:effectRef>
+          <a:fontRef idx="minor">
+            <a:schemeClr val="lt1"/>
+          </a:fontRef>
+        </p:style>
+        <p:txBody>
+          <a:bodyPr rtlCol="0" anchor="ctr"/>
+          <a:lstStyle/>
+          <a:p>
+            <a:pPr algn="ctr"/>
+          </a:p>
+        </p:txBody>
+      </p:sp>
+      <p:sp>
+        <p:nvSpPr>
+          <p:cNvPr id="8" name="TextBox 7"/>
+          <p:cNvSpPr txBox="1"/>
+          <p:nvPr/>
+        </p:nvSpPr>
+        <p:spPr>
+          <a:xfrm>
+            <a:off x="4876800" y="6108700"/>
+            <a:ext cx="6756400" cy="215900"/>
           </a:xfrm>
           <a:prstGeom prst="rect">
             <a:avLst/>
@@ -7321,7 +7997,7 @@
       </p:sp>
       <p:sp>
         <p:nvSpPr>
-          <p:cNvPr id="8" name="TextBox 7"/>
+          <p:cNvPr id="9" name="TextBox 8"/>
           <p:cNvSpPr txBox="1"/>
           <p:nvPr/>
         </p:nvSpPr>
@@ -7355,7 +8031,7 @@
       </p:sp>
       <p:sp>
         <p:nvSpPr>
-          <p:cNvPr id="9" name="TextBox 8"/>
+          <p:cNvPr id="10" name="TextBox 9"/>
           <p:cNvSpPr txBox="1"/>
           <p:nvPr/>
         </p:nvSpPr>
@@ -7622,14 +8298,59 @@
       </p:pic>
       <p:sp>
         <p:nvSpPr>
-          <p:cNvPr id="7" name="TextBox 6"/>
-          <p:cNvSpPr txBox="1"/>
-          <p:nvPr/>
-        </p:nvSpPr>
-        <p:spPr>
-          <a:xfrm>
-            <a:off x="5334000" y="6134100"/>
-            <a:ext cx="6286500" cy="190500"/>
+          <p:cNvPr id="7" name="Rectangle 6"/>
+          <p:cNvSpPr/>
+          <p:nvPr/>
+        </p:nvSpPr>
+        <p:spPr>
+          <a:xfrm>
+            <a:off x="5270500" y="6096000"/>
+            <a:ext cx="2933700" cy="254000"/>
+          </a:xfrm>
+          <a:prstGeom prst="rect">
+            <a:avLst/>
+          </a:prstGeom>
+          <a:solidFill>
+            <a:srgbClr val="141412">
+              <a:alpha val="62000"/>
+            </a:srgbClr>
+          </a:solidFill>
+          <a:ln>
+            <a:noFill/>
+          </a:ln>
+        </p:spPr>
+        <p:style>
+          <a:lnRef idx="1">
+            <a:schemeClr val="accent1"/>
+          </a:lnRef>
+          <a:fillRef idx="3">
+            <a:schemeClr val="accent1"/>
+          </a:fillRef>
+          <a:effectRef idx="2">
+            <a:schemeClr val="accent1"/>
+          </a:effectRef>
+          <a:fontRef idx="minor">
+            <a:schemeClr val="lt1"/>
+          </a:fontRef>
+        </p:style>
+        <p:txBody>
+          <a:bodyPr rtlCol="0" anchor="ctr"/>
+          <a:lstStyle/>
+          <a:p>
+            <a:pPr algn="ctr"/>
+          </a:p>
+        </p:txBody>
+      </p:sp>
+      <p:sp>
+        <p:nvSpPr>
+          <p:cNvPr id="8" name="TextBox 7"/>
+          <p:cNvSpPr txBox="1"/>
+          <p:nvPr/>
+        </p:nvSpPr>
+        <p:spPr>
+          <a:xfrm>
+            <a:off x="5321300" y="6108700"/>
+            <a:ext cx="6311900" cy="215900"/>
           </a:xfrm>
           <a:prstGeom prst="rect">
             <a:avLst/>
@@ -7656,7 +8377,7 @@
       </p:sp>
       <p:sp>
         <p:nvSpPr>
-          <p:cNvPr id="8" name="TextBox 7"/>
+          <p:cNvPr id="9" name="TextBox 8"/>
           <p:cNvSpPr txBox="1"/>
           <p:nvPr/>
         </p:nvSpPr>
@@ -7690,7 +8411,7 @@
       </p:sp>
       <p:sp>
         <p:nvSpPr>
-          <p:cNvPr id="9" name="TextBox 8"/>
+          <p:cNvPr id="10" name="TextBox 9"/>
           <p:cNvSpPr txBox="1"/>
           <p:nvPr/>
         </p:nvSpPr>
@@ -8398,14 +9119,59 @@
       </p:pic>
       <p:sp>
         <p:nvSpPr>
-          <p:cNvPr id="20" name="TextBox 19"/>
-          <p:cNvSpPr txBox="1"/>
-          <p:nvPr/>
-        </p:nvSpPr>
-        <p:spPr>
-          <a:xfrm>
-            <a:off x="8191500" y="5435600"/>
-            <a:ext cx="3429000" cy="190500"/>
+          <p:cNvPr id="20" name="Rectangle 19"/>
+          <p:cNvSpPr/>
+          <p:nvPr/>
+        </p:nvSpPr>
+        <p:spPr>
+          <a:xfrm>
+            <a:off x="8128000" y="5397500"/>
+            <a:ext cx="1562100" cy="254000"/>
+          </a:xfrm>
+          <a:prstGeom prst="rect">
+            <a:avLst/>
+          </a:prstGeom>
+          <a:solidFill>
+            <a:srgbClr val="141412">
+              <a:alpha val="62000"/>
+            </a:srgbClr>
+          </a:solidFill>
+          <a:ln>
+            <a:noFill/>
+          </a:ln>
+        </p:spPr>
+        <p:style>
+          <a:lnRef idx="1">
+            <a:schemeClr val="accent1"/>
+          </a:lnRef>
+          <a:fillRef idx="3">
+            <a:schemeClr val="accent1"/>
+          </a:fillRef>
+          <a:effectRef idx="2">
+            <a:schemeClr val="accent1"/>
+          </a:effectRef>
+          <a:fontRef idx="minor">
+            <a:schemeClr val="lt1"/>
+          </a:fontRef>
+        </p:style>
+        <p:txBody>
+          <a:bodyPr rtlCol="0" anchor="ctr"/>
+          <a:lstStyle/>
+          <a:p>
+            <a:pPr algn="ctr"/>
+          </a:p>
+        </p:txBody>
+      </p:sp>
+      <p:sp>
+        <p:nvSpPr>
+          <p:cNvPr id="21" name="TextBox 20"/>
+          <p:cNvSpPr txBox="1"/>
+          <p:nvPr/>
+        </p:nvSpPr>
+        <p:spPr>
+          <a:xfrm>
+            <a:off x="8178800" y="5410200"/>
+            <a:ext cx="3454400" cy="215900"/>
           </a:xfrm>
           <a:prstGeom prst="rect">
             <a:avLst/>
@@ -8425,14 +9191,14 @@
                 </a:solidFill>
                 <a:latin typeface="Inter"/>
               </a:rPr>
-              <a:t>Global Design Studio (preview render)</a:t>
-            </a:r>
-          </a:p>
-        </p:txBody>
-      </p:sp>
-      <p:sp>
-        <p:nvSpPr>
-          <p:cNvPr id="21" name="TextBox 20"/>
+              <a:t>Global Design Studio</a:t>
+            </a:r>
+          </a:p>
+        </p:txBody>
+      </p:sp>
+      <p:sp>
+        <p:nvSpPr>
+          <p:cNvPr id="22" name="TextBox 21"/>
           <p:cNvSpPr txBox="1"/>
           <p:nvPr/>
         </p:nvSpPr>
@@ -8466,7 +9232,7 @@
       </p:sp>
       <p:sp>
         <p:nvSpPr>
-          <p:cNvPr id="22" name="TextBox 21"/>
+          <p:cNvPr id="23" name="TextBox 22"/>
           <p:cNvSpPr txBox="1"/>
           <p:nvPr/>
         </p:nvSpPr>
@@ -8601,8 +9367,8 @@
           <p:nvPr/>
         </p:nvGraphicFramePr>
         <p:xfrm>
-          <a:off x="508000" y="1841500"/>
-          <a:ext cx="11176000" cy="2222500"/>
+          <a:off x="508000" y="1651000"/>
+          <a:ext cx="11176000" cy="2044700"/>
         </p:xfrm>
         <a:graphic>
           <a:graphicData uri="http://schemas.openxmlformats.org/drawingml/2006/table">
@@ -8611,17 +9377,17 @@
                 <a:tableStyleId>{5C22544A-7EE6-4342-B048-85BDC9FD1C3A}</a:tableStyleId>
               </a:tblPr>
               <a:tblGrid>
-                <a:gridCol w="5588000"/>
-                <a:gridCol w="5588000"/>
+                <a:gridCol w="2159000"/>
+                <a:gridCol w="9017000"/>
               </a:tblGrid>
-              <a:tr h="317500">
+              <a:tr h="292100">
                 <a:tc>
                   <a:txBody>
                     <a:bodyPr/>
                     <a:lstStyle/>
                     <a:p>
                       <a:r>
-                        <a:rPr sz="1100" b="1">
+                        <a:rPr sz="1000" b="1">
                           <a:solidFill>
                             <a:srgbClr val="26673D"/>
                           </a:solidFill>
@@ -8643,7 +9409,7 @@
                     <a:lstStyle/>
                     <a:p>
                       <a:r>
-                        <a:rPr sz="1100" b="1">
+                        <a:rPr sz="1000" b="1">
                           <a:solidFill>
                             <a:srgbClr val="26673D"/>
                           </a:solidFill>
@@ -8660,14 +9426,14 @@
                   </a:tcPr>
                 </a:tc>
               </a:tr>
-              <a:tr h="317500">
+              <a:tr h="292100">
                 <a:tc>
                   <a:txBody>
                     <a:bodyPr/>
                     <a:lstStyle/>
                     <a:p>
                       <a:r>
-                        <a:rPr sz="1300" b="1">
+                        <a:rPr sz="1200" b="1">
                           <a:solidFill>
                             <a:srgbClr val="26673D"/>
                           </a:solidFill>
@@ -8689,7 +9455,7 @@
                     <a:lstStyle/>
                     <a:p>
                       <a:r>
-                        <a:rPr sz="1300" b="0">
+                        <a:rPr sz="1200" b="0">
                           <a:solidFill>
                             <a:srgbClr val="1E1E1C"/>
                           </a:solidFill>
@@ -8706,14 +9472,14 @@
                   </a:tcPr>
                 </a:tc>
               </a:tr>
-              <a:tr h="317500">
+              <a:tr h="292100">
                 <a:tc>
                   <a:txBody>
                     <a:bodyPr/>
                     <a:lstStyle/>
                     <a:p>
                       <a:r>
-                        <a:rPr sz="1300" b="1">
+                        <a:rPr sz="1200" b="1">
                           <a:solidFill>
                             <a:srgbClr val="26673D"/>
                           </a:solidFill>
@@ -8735,7 +9501,7 @@
                     <a:lstStyle/>
                     <a:p>
                       <a:r>
-                        <a:rPr sz="1300" b="0">
+                        <a:rPr sz="1200" b="0">
                           <a:solidFill>
                             <a:srgbClr val="1E1E1C"/>
                           </a:solidFill>
@@ -8752,14 +9518,14 @@
                   </a:tcPr>
                 </a:tc>
               </a:tr>
-              <a:tr h="317500">
+              <a:tr h="292100">
                 <a:tc>
                   <a:txBody>
                     <a:bodyPr/>
                     <a:lstStyle/>
                     <a:p>
                       <a:r>
-                        <a:rPr sz="1300" b="1">
+                        <a:rPr sz="1200" b="1">
                           <a:solidFill>
                             <a:srgbClr val="26673D"/>
                           </a:solidFill>
@@ -8781,7 +9547,7 @@
                     <a:lstStyle/>
                     <a:p>
                       <a:r>
-                        <a:rPr sz="1300" b="0">
+                        <a:rPr sz="1200" b="0">
                           <a:solidFill>
                             <a:srgbClr val="1E1E1C"/>
                           </a:solidFill>
@@ -8798,14 +9564,14 @@
                   </a:tcPr>
                 </a:tc>
               </a:tr>
-              <a:tr h="317500">
+              <a:tr h="292100">
                 <a:tc>
                   <a:txBody>
                     <a:bodyPr/>
                     <a:lstStyle/>
                     <a:p>
                       <a:r>
-                        <a:rPr sz="1300" b="1">
+                        <a:rPr sz="1200" b="1">
                           <a:solidFill>
                             <a:srgbClr val="26673D"/>
                           </a:solidFill>
@@ -8827,7 +9593,7 @@
                     <a:lstStyle/>
                     <a:p>
                       <a:r>
-                        <a:rPr sz="1300" b="0">
+                        <a:rPr sz="1200" b="0">
                           <a:solidFill>
                             <a:srgbClr val="1E1E1C"/>
                           </a:solidFill>
@@ -8844,14 +9610,14 @@
                   </a:tcPr>
                 </a:tc>
               </a:tr>
-              <a:tr h="317500">
+              <a:tr h="292100">
                 <a:tc>
                   <a:txBody>
                     <a:bodyPr/>
                     <a:lstStyle/>
                     <a:p>
                       <a:r>
-                        <a:rPr sz="1300" b="1">
+                        <a:rPr sz="1200" b="1">
                           <a:solidFill>
                             <a:srgbClr val="26673D"/>
                           </a:solidFill>
@@ -8873,7 +9639,7 @@
                     <a:lstStyle/>
                     <a:p>
                       <a:r>
-                        <a:rPr sz="1300" b="0">
+                        <a:rPr sz="1200" b="0">
                           <a:solidFill>
                             <a:srgbClr val="1E1E1C"/>
                           </a:solidFill>
@@ -8890,14 +9656,14 @@
                   </a:tcPr>
                 </a:tc>
               </a:tr>
-              <a:tr h="317500">
+              <a:tr h="292100">
                 <a:tc>
                   <a:txBody>
                     <a:bodyPr/>
                     <a:lstStyle/>
                     <a:p>
                       <a:r>
-                        <a:rPr sz="1300" b="1">
+                        <a:rPr sz="1200" b="1">
                           <a:solidFill>
                             <a:srgbClr val="26673D"/>
                           </a:solidFill>
@@ -8919,7 +9685,7 @@
                     <a:lstStyle/>
                     <a:p>
                       <a:r>
-                        <a:rPr sz="1300" b="0">
+                        <a:rPr sz="1200" b="0">
                           <a:solidFill>
                             <a:srgbClr val="1E1E1C"/>
                           </a:solidFill>
@@ -8948,8 +9714,8 @@
         </p:nvSpPr>
         <p:spPr>
           <a:xfrm>
-            <a:off x="508000" y="6032500"/>
-            <a:ext cx="11176000" cy="381000"/>
+            <a:off x="508000" y="3873500"/>
+            <a:ext cx="11176000" cy="254000"/>
           </a:xfrm>
           <a:prstGeom prst="rect">
             <a:avLst/>
@@ -8977,6 +9743,620 @@
       <p:sp>
         <p:nvSpPr>
           <p:cNvPr id="6" name="TextBox 5"/>
+          <p:cNvSpPr txBox="1"/>
+          <p:nvPr/>
+        </p:nvSpPr>
+        <p:spPr>
+          <a:xfrm>
+            <a:off x="508000" y="4445000"/>
+            <a:ext cx="6350000" cy="190500"/>
+          </a:xfrm>
+          <a:prstGeom prst="rect">
+            <a:avLst/>
+          </a:prstGeom>
+          <a:noFill/>
+        </p:spPr>
+        <p:txBody>
+          <a:bodyPr wrap="square">
+            <a:spAutoFit/>
+          </a:bodyPr>
+          <a:lstStyle/>
+          <a:p>
+            <a:r>
+              <a:rPr sz="1100" b="1">
+                <a:solidFill>
+                  <a:srgbClr val="26673D"/>
+                </a:solidFill>
+                <a:latin typeface="Inter"/>
+              </a:rPr>
+              <a:t>RECOMMENDED NEXT STEPS</a:t>
+            </a:r>
+          </a:p>
+        </p:txBody>
+      </p:sp>
+      <p:sp>
+        <p:nvSpPr>
+          <p:cNvPr id="7" name="Rectangle 6"/>
+          <p:cNvSpPr/>
+          <p:nvPr/>
+        </p:nvSpPr>
+        <p:spPr>
+          <a:xfrm>
+            <a:off x="508000" y="4699000"/>
+            <a:ext cx="2667000" cy="1587500"/>
+          </a:xfrm>
+          <a:prstGeom prst="rect">
+            <a:avLst/>
+          </a:prstGeom>
+          <a:solidFill>
+            <a:srgbClr val="FFFFFF"/>
+          </a:solidFill>
+          <a:ln>
+            <a:noFill/>
+          </a:ln>
+        </p:spPr>
+        <p:style>
+          <a:lnRef idx="1">
+            <a:schemeClr val="accent1"/>
+          </a:lnRef>
+          <a:fillRef idx="3">
+            <a:schemeClr val="accent1"/>
+          </a:fillRef>
+          <a:effectRef idx="2">
+            <a:schemeClr val="accent1"/>
+          </a:effectRef>
+          <a:fontRef idx="minor">
+            <a:schemeClr val="lt1"/>
+          </a:fontRef>
+        </p:style>
+        <p:txBody>
+          <a:bodyPr rtlCol="0" anchor="ctr"/>
+          <a:lstStyle/>
+          <a:p>
+            <a:pPr algn="ctr"/>
+          </a:p>
+        </p:txBody>
+      </p:sp>
+      <p:sp>
+        <p:nvSpPr>
+          <p:cNvPr id="8" name="TextBox 7"/>
+          <p:cNvSpPr txBox="1"/>
+          <p:nvPr/>
+        </p:nvSpPr>
+        <p:spPr>
+          <a:xfrm>
+            <a:off x="647700" y="4800600"/>
+            <a:ext cx="2413000" cy="279400"/>
+          </a:xfrm>
+          <a:prstGeom prst="rect">
+            <a:avLst/>
+          </a:prstGeom>
+          <a:noFill/>
+        </p:spPr>
+        <p:txBody>
+          <a:bodyPr wrap="square">
+            <a:spAutoFit/>
+          </a:bodyPr>
+          <a:lstStyle/>
+          <a:p>
+            <a:r>
+              <a:rPr sz="2000" b="1">
+                <a:solidFill>
+                  <a:srgbClr val="26673D"/>
+                </a:solidFill>
+                <a:latin typeface="Inter"/>
+              </a:rPr>
+              <a:t>01</a:t>
+            </a:r>
+          </a:p>
+        </p:txBody>
+      </p:sp>
+      <p:sp>
+        <p:nvSpPr>
+          <p:cNvPr id="9" name="TextBox 8"/>
+          <p:cNvSpPr txBox="1"/>
+          <p:nvPr/>
+        </p:nvSpPr>
+        <p:spPr>
+          <a:xfrm>
+            <a:off x="647700" y="5143500"/>
+            <a:ext cx="2413000" cy="254000"/>
+          </a:xfrm>
+          <a:prstGeom prst="rect">
+            <a:avLst/>
+          </a:prstGeom>
+          <a:noFill/>
+        </p:spPr>
+        <p:txBody>
+          <a:bodyPr wrap="square">
+            <a:spAutoFit/>
+          </a:bodyPr>
+          <a:lstStyle/>
+          <a:p>
+            <a:r>
+              <a:rPr sz="1400" b="1">
+                <a:solidFill>
+                  <a:srgbClr val="1E1E1C"/>
+                </a:solidFill>
+                <a:latin typeface="Inter"/>
+              </a:rPr>
+              <a:t>Site measurement</a:t>
+            </a:r>
+          </a:p>
+        </p:txBody>
+      </p:sp>
+      <p:sp>
+        <p:nvSpPr>
+          <p:cNvPr id="10" name="TextBox 9"/>
+          <p:cNvSpPr txBox="1"/>
+          <p:nvPr/>
+        </p:nvSpPr>
+        <p:spPr>
+          <a:xfrm>
+            <a:off x="647700" y="5435600"/>
+            <a:ext cx="2413000" cy="762000"/>
+          </a:xfrm>
+          <a:prstGeom prst="rect">
+            <a:avLst/>
+          </a:prstGeom>
+          <a:noFill/>
+        </p:spPr>
+        <p:txBody>
+          <a:bodyPr wrap="square">
+            <a:spAutoFit/>
+          </a:bodyPr>
+          <a:lstStyle/>
+          <a:p>
+            <a:r>
+              <a:rPr sz="1100" b="0">
+                <a:solidFill>
+                  <a:srgbClr val="5A5750"/>
+                </a:solidFill>
+                <a:latin typeface="Inter"/>
+              </a:rPr>
+              <a:t>Floor-to-deck height, room 8 width, columns and beams; then update the survey data, rebuild and re-verify the model.</a:t>
+            </a:r>
+          </a:p>
+        </p:txBody>
+      </p:sp>
+      <p:sp>
+        <p:nvSpPr>
+          <p:cNvPr id="11" name="Rectangle 10"/>
+          <p:cNvSpPr/>
+          <p:nvPr/>
+        </p:nvSpPr>
+        <p:spPr>
+          <a:xfrm>
+            <a:off x="3333750" y="4699000"/>
+            <a:ext cx="2667000" cy="1587500"/>
+          </a:xfrm>
+          <a:prstGeom prst="rect">
+            <a:avLst/>
+          </a:prstGeom>
+          <a:solidFill>
+            <a:srgbClr val="FFFFFF"/>
+          </a:solidFill>
+          <a:ln>
+            <a:noFill/>
+          </a:ln>
+        </p:spPr>
+        <p:style>
+          <a:lnRef idx="1">
+            <a:schemeClr val="accent1"/>
+          </a:lnRef>
+          <a:fillRef idx="3">
+            <a:schemeClr val="accent1"/>
+          </a:fillRef>
+          <a:effectRef idx="2">
+            <a:schemeClr val="accent1"/>
+          </a:effectRef>
+          <a:fontRef idx="minor">
+            <a:schemeClr val="lt1"/>
+          </a:fontRef>
+        </p:style>
+        <p:txBody>
+          <a:bodyPr rtlCol="0" anchor="ctr"/>
+          <a:lstStyle/>
+          <a:p>
+            <a:pPr algn="ctr"/>
+          </a:p>
+        </p:txBody>
+      </p:sp>
+      <p:sp>
+        <p:nvSpPr>
+          <p:cNvPr id="12" name="TextBox 11"/>
+          <p:cNvSpPr txBox="1"/>
+          <p:nvPr/>
+        </p:nvSpPr>
+        <p:spPr>
+          <a:xfrm>
+            <a:off x="3473450" y="4800600"/>
+            <a:ext cx="2413000" cy="279400"/>
+          </a:xfrm>
+          <a:prstGeom prst="rect">
+            <a:avLst/>
+          </a:prstGeom>
+          <a:noFill/>
+        </p:spPr>
+        <p:txBody>
+          <a:bodyPr wrap="square">
+            <a:spAutoFit/>
+          </a:bodyPr>
+          <a:lstStyle/>
+          <a:p>
+            <a:r>
+              <a:rPr sz="2000" b="1">
+                <a:solidFill>
+                  <a:srgbClr val="26673D"/>
+                </a:solidFill>
+                <a:latin typeface="Inter"/>
+              </a:rPr>
+              <a:t>02</a:t>
+            </a:r>
+          </a:p>
+        </p:txBody>
+      </p:sp>
+      <p:sp>
+        <p:nvSpPr>
+          <p:cNvPr id="13" name="TextBox 12"/>
+          <p:cNvSpPr txBox="1"/>
+          <p:nvPr/>
+        </p:nvSpPr>
+        <p:spPr>
+          <a:xfrm>
+            <a:off x="3473450" y="5143500"/>
+            <a:ext cx="2413000" cy="254000"/>
+          </a:xfrm>
+          <a:prstGeom prst="rect">
+            <a:avLst/>
+          </a:prstGeom>
+          <a:noFill/>
+        </p:spPr>
+        <p:txBody>
+          <a:bodyPr wrap="square">
+            <a:spAutoFit/>
+          </a:bodyPr>
+          <a:lstStyle/>
+          <a:p>
+            <a:r>
+              <a:rPr sz="1400" b="1">
+                <a:solidFill>
+                  <a:srgbClr val="1E1E1C"/>
+                </a:solidFill>
+                <a:latin typeface="Inter"/>
+              </a:rPr>
+              <a:t>Engineering reviews</a:t>
+            </a:r>
+          </a:p>
+        </p:txBody>
+      </p:sp>
+      <p:sp>
+        <p:nvSpPr>
+          <p:cNvPr id="14" name="TextBox 13"/>
+          <p:cNvSpPr txBox="1"/>
+          <p:nvPr/>
+        </p:nvSpPr>
+        <p:spPr>
+          <a:xfrm>
+            <a:off x="3473450" y="5435600"/>
+            <a:ext cx="2413000" cy="762000"/>
+          </a:xfrm>
+          <a:prstGeom prst="rect">
+            <a:avLst/>
+          </a:prstGeom>
+          <a:noFill/>
+        </p:spPr>
+        <p:txBody>
+          <a:bodyPr wrap="square">
+            <a:spAutoFit/>
+          </a:bodyPr>
+          <a:lstStyle/>
+          <a:p>
+            <a:r>
+              <a:rPr sz="1100" b="0">
+                <a:solidFill>
+                  <a:srgbClr val="5A5750"/>
+                </a:solidFill>
+                <a:latin typeface="Inter"/>
+              </a:rPr>
+              <a:t>Structural check of the new openings, fire strategy and exits, HVAC, power and data design.</a:t>
+            </a:r>
+          </a:p>
+        </p:txBody>
+      </p:sp>
+      <p:sp>
+        <p:nvSpPr>
+          <p:cNvPr id="15" name="Rectangle 14"/>
+          <p:cNvSpPr/>
+          <p:nvPr/>
+        </p:nvSpPr>
+        <p:spPr>
+          <a:xfrm>
+            <a:off x="6159500" y="4699000"/>
+            <a:ext cx="2667000" cy="1587500"/>
+          </a:xfrm>
+          <a:prstGeom prst="rect">
+            <a:avLst/>
+          </a:prstGeom>
+          <a:solidFill>
+            <a:srgbClr val="FFFFFF"/>
+          </a:solidFill>
+          <a:ln>
+            <a:noFill/>
+          </a:ln>
+        </p:spPr>
+        <p:style>
+          <a:lnRef idx="1">
+            <a:schemeClr val="accent1"/>
+          </a:lnRef>
+          <a:fillRef idx="3">
+            <a:schemeClr val="accent1"/>
+          </a:fillRef>
+          <a:effectRef idx="2">
+            <a:schemeClr val="accent1"/>
+          </a:effectRef>
+          <a:fontRef idx="minor">
+            <a:schemeClr val="lt1"/>
+          </a:fontRef>
+        </p:style>
+        <p:txBody>
+          <a:bodyPr rtlCol="0" anchor="ctr"/>
+          <a:lstStyle/>
+          <a:p>
+            <a:pPr algn="ctr"/>
+          </a:p>
+        </p:txBody>
+      </p:sp>
+      <p:sp>
+        <p:nvSpPr>
+          <p:cNvPr id="16" name="TextBox 15"/>
+          <p:cNvSpPr txBox="1"/>
+          <p:nvPr/>
+        </p:nvSpPr>
+        <p:spPr>
+          <a:xfrm>
+            <a:off x="6299200" y="4800600"/>
+            <a:ext cx="2413000" cy="279400"/>
+          </a:xfrm>
+          <a:prstGeom prst="rect">
+            <a:avLst/>
+          </a:prstGeom>
+          <a:noFill/>
+        </p:spPr>
+        <p:txBody>
+          <a:bodyPr wrap="square">
+            <a:spAutoFit/>
+          </a:bodyPr>
+          <a:lstStyle/>
+          <a:p>
+            <a:r>
+              <a:rPr sz="2000" b="1">
+                <a:solidFill>
+                  <a:srgbClr val="26673D"/>
+                </a:solidFill>
+                <a:latin typeface="Inter"/>
+              </a:rPr>
+              <a:t>03</a:t>
+            </a:r>
+          </a:p>
+        </p:txBody>
+      </p:sp>
+      <p:sp>
+        <p:nvSpPr>
+          <p:cNvPr id="17" name="TextBox 16"/>
+          <p:cNvSpPr txBox="1"/>
+          <p:nvPr/>
+        </p:nvSpPr>
+        <p:spPr>
+          <a:xfrm>
+            <a:off x="6299200" y="5143500"/>
+            <a:ext cx="2413000" cy="254000"/>
+          </a:xfrm>
+          <a:prstGeom prst="rect">
+            <a:avLst/>
+          </a:prstGeom>
+          <a:noFill/>
+        </p:spPr>
+        <p:txBody>
+          <a:bodyPr wrap="square">
+            <a:spAutoFit/>
+          </a:bodyPr>
+          <a:lstStyle/>
+          <a:p>
+            <a:r>
+              <a:rPr sz="1400" b="1">
+                <a:solidFill>
+                  <a:srgbClr val="1E1E1C"/>
+                </a:solidFill>
+                <a:latin typeface="Inter"/>
+              </a:rPr>
+              <a:t>Client decisions</a:t>
+            </a:r>
+          </a:p>
+        </p:txBody>
+      </p:sp>
+      <p:sp>
+        <p:nvSpPr>
+          <p:cNvPr id="18" name="TextBox 17"/>
+          <p:cNvSpPr txBox="1"/>
+          <p:nvPr/>
+        </p:nvSpPr>
+        <p:spPr>
+          <a:xfrm>
+            <a:off x="6299200" y="5435600"/>
+            <a:ext cx="2413000" cy="762000"/>
+          </a:xfrm>
+          <a:prstGeom prst="rect">
+            <a:avLst/>
+          </a:prstGeom>
+          <a:noFill/>
+        </p:spPr>
+        <p:txBody>
+          <a:bodyPr wrap="square">
+            <a:spAutoFit/>
+          </a:bodyPr>
+          <a:lstStyle/>
+          <a:p>
+            <a:r>
+              <a:rPr sz="1100" b="0">
+                <a:solidFill>
+                  <a:srgbClr val="5A5750"/>
+                </a:solidFill>
+                <a:latin typeface="Inter"/>
+              </a:rPr>
+              <a:t>Head count per department, interior budget, experience-centre content and approval of this layout.</a:t>
+            </a:r>
+          </a:p>
+        </p:txBody>
+      </p:sp>
+      <p:sp>
+        <p:nvSpPr>
+          <p:cNvPr id="19" name="Rectangle 18"/>
+          <p:cNvSpPr/>
+          <p:nvPr/>
+        </p:nvSpPr>
+        <p:spPr>
+          <a:xfrm>
+            <a:off x="8985250" y="4699000"/>
+            <a:ext cx="2667000" cy="1587500"/>
+          </a:xfrm>
+          <a:prstGeom prst="rect">
+            <a:avLst/>
+          </a:prstGeom>
+          <a:solidFill>
+            <a:srgbClr val="FFFFFF"/>
+          </a:solidFill>
+          <a:ln>
+            <a:noFill/>
+          </a:ln>
+        </p:spPr>
+        <p:style>
+          <a:lnRef idx="1">
+            <a:schemeClr val="accent1"/>
+          </a:lnRef>
+          <a:fillRef idx="3">
+            <a:schemeClr val="accent1"/>
+          </a:fillRef>
+          <a:effectRef idx="2">
+            <a:schemeClr val="accent1"/>
+          </a:effectRef>
+          <a:fontRef idx="minor">
+            <a:schemeClr val="lt1"/>
+          </a:fontRef>
+        </p:style>
+        <p:txBody>
+          <a:bodyPr rtlCol="0" anchor="ctr"/>
+          <a:lstStyle/>
+          <a:p>
+            <a:pPr algn="ctr"/>
+          </a:p>
+        </p:txBody>
+      </p:sp>
+      <p:sp>
+        <p:nvSpPr>
+          <p:cNvPr id="20" name="TextBox 19"/>
+          <p:cNvSpPr txBox="1"/>
+          <p:nvPr/>
+        </p:nvSpPr>
+        <p:spPr>
+          <a:xfrm>
+            <a:off x="9124950" y="4800600"/>
+            <a:ext cx="2413000" cy="279400"/>
+          </a:xfrm>
+          <a:prstGeom prst="rect">
+            <a:avLst/>
+          </a:prstGeom>
+          <a:noFill/>
+        </p:spPr>
+        <p:txBody>
+          <a:bodyPr wrap="square">
+            <a:spAutoFit/>
+          </a:bodyPr>
+          <a:lstStyle/>
+          <a:p>
+            <a:r>
+              <a:rPr sz="2000" b="1">
+                <a:solidFill>
+                  <a:srgbClr val="26673D"/>
+                </a:solidFill>
+                <a:latin typeface="Inter"/>
+              </a:rPr>
+              <a:t>04</a:t>
+            </a:r>
+          </a:p>
+        </p:txBody>
+      </p:sp>
+      <p:sp>
+        <p:nvSpPr>
+          <p:cNvPr id="21" name="TextBox 20"/>
+          <p:cNvSpPr txBox="1"/>
+          <p:nvPr/>
+        </p:nvSpPr>
+        <p:spPr>
+          <a:xfrm>
+            <a:off x="9124950" y="5143500"/>
+            <a:ext cx="2413000" cy="254000"/>
+          </a:xfrm>
+          <a:prstGeom prst="rect">
+            <a:avLst/>
+          </a:prstGeom>
+          <a:noFill/>
+        </p:spPr>
+        <p:txBody>
+          <a:bodyPr wrap="square">
+            <a:spAutoFit/>
+          </a:bodyPr>
+          <a:lstStyle/>
+          <a:p>
+            <a:r>
+              <a:rPr sz="1400" b="1">
+                <a:solidFill>
+                  <a:srgbClr val="1E1E1C"/>
+                </a:solidFill>
+                <a:latin typeface="Inter"/>
+              </a:rPr>
+              <a:t>Detailed design</a:t>
+            </a:r>
+          </a:p>
+        </p:txBody>
+      </p:sp>
+      <p:sp>
+        <p:nvSpPr>
+          <p:cNvPr id="22" name="TextBox 21"/>
+          <p:cNvSpPr txBox="1"/>
+          <p:nvPr/>
+        </p:nvSpPr>
+        <p:spPr>
+          <a:xfrm>
+            <a:off x="9124950" y="5435600"/>
+            <a:ext cx="2413000" cy="762000"/>
+          </a:xfrm>
+          <a:prstGeom prst="rect">
+            <a:avLst/>
+          </a:prstGeom>
+          <a:noFill/>
+        </p:spPr>
+        <p:txBody>
+          <a:bodyPr wrap="square">
+            <a:spAutoFit/>
+          </a:bodyPr>
+          <a:lstStyle/>
+          <a:p>
+            <a:r>
+              <a:rPr sz="1100" b="0">
+                <a:solidFill>
+                  <a:srgbClr val="5A5750"/>
+                </a:solidFill>
+                <a:latin typeface="Inter"/>
+              </a:rPr>
+              <a:t>Construction drawings, finish samples, furniture selection and bill of quantities after approval.</a:t>
+            </a:r>
+          </a:p>
+        </p:txBody>
+      </p:sp>
+      <p:sp>
+        <p:nvSpPr>
+          <p:cNvPr id="23" name="TextBox 22"/>
           <p:cNvSpPr txBox="1"/>
           <p:nvPr/>
         </p:nvSpPr>
@@ -9010,7 +10390,7 @@
       </p:sp>
       <p:sp>
         <p:nvSpPr>
-          <p:cNvPr id="7" name="TextBox 6"/>
+          <p:cNvPr id="24" name="TextBox 23"/>
           <p:cNvSpPr txBox="1"/>
           <p:nvPr/>
         </p:nvSpPr>
@@ -9095,41 +10475,7 @@
       </p:pic>
       <p:sp>
         <p:nvSpPr>
-          <p:cNvPr id="3" name="TextBox 2"/>
-          <p:cNvSpPr txBox="1"/>
-          <p:nvPr/>
-        </p:nvSpPr>
-        <p:spPr>
-          <a:xfrm>
-            <a:off x="63500" y="6642100"/>
-            <a:ext cx="12065000" cy="190500"/>
-          </a:xfrm>
-          <a:prstGeom prst="rect">
-            <a:avLst/>
-          </a:prstGeom>
-          <a:noFill/>
-        </p:spPr>
-        <p:txBody>
-          <a:bodyPr wrap="square">
-            <a:spAutoFit/>
-          </a:bodyPr>
-          <a:lstStyle/>
-          <a:p>
-            <a:r>
-              <a:rPr sz="1100" b="0">
-                <a:solidFill>
-                  <a:srgbClr val="FFFFFF"/>
-                </a:solidFill>
-                <a:latin typeface="Inter"/>
-              </a:rPr>
-              <a:t>Experience centre towards the brand-story wall - Blender Cycles render (preview render)</a:t>
-            </a:r>
-          </a:p>
-        </p:txBody>
-      </p:sp>
-      <p:sp>
-        <p:nvSpPr>
-          <p:cNvPr id="4" name="Rectangle 3"/>
+          <p:cNvPr id="3" name="Rectangle 2"/>
           <p:cNvSpPr/>
           <p:nvPr/>
         </p:nvSpPr>
@@ -9172,7 +10518,7 @@
       </p:sp>
       <p:sp>
         <p:nvSpPr>
-          <p:cNvPr id="5" name="TextBox 4"/>
+          <p:cNvPr id="4" name="TextBox 3"/>
           <p:cNvSpPr txBox="1"/>
           <p:nvPr/>
         </p:nvSpPr>
@@ -9206,7 +10552,7 @@
       </p:sp>
       <p:sp>
         <p:nvSpPr>
-          <p:cNvPr id="6" name="TextBox 5"/>
+          <p:cNvPr id="5" name="TextBox 4"/>
           <p:cNvSpPr txBox="1"/>
           <p:nvPr/>
         </p:nvSpPr>
@@ -9240,7 +10586,7 @@
       </p:sp>
       <p:sp>
         <p:nvSpPr>
-          <p:cNvPr id="7" name="TextBox 6"/>
+          <p:cNvPr id="6" name="TextBox 5"/>
           <p:cNvSpPr txBox="1"/>
           <p:nvPr/>
         </p:nvSpPr>
@@ -9274,6 +10620,41 @@
       </p:sp>
       <p:sp>
         <p:nvSpPr>
+          <p:cNvPr id="7" name="TextBox 6"/>
+          <p:cNvSpPr txBox="1"/>
+          <p:nvPr/>
+        </p:nvSpPr>
+        <p:spPr>
+          <a:xfrm>
+            <a:off x="5715000" y="6248400"/>
+            <a:ext cx="5969000" cy="190500"/>
+          </a:xfrm>
+          <a:prstGeom prst="rect">
+            <a:avLst/>
+          </a:prstGeom>
+          <a:noFill/>
+        </p:spPr>
+        <p:txBody>
+          <a:bodyPr wrap="square">
+            <a:spAutoFit/>
+          </a:bodyPr>
+          <a:lstStyle/>
+          <a:p>
+            <a:pPr algn="r"/>
+            <a:r>
+              <a:rPr sz="900" b="0">
+                <a:solidFill>
+                  <a:srgbClr val="C9D3CC"/>
+                </a:solidFill>
+                <a:latin typeface="Inter"/>
+              </a:rPr>
+              <a:t>Experience centre towards the brand-story wall - Blender Cycles render</a:t>
+            </a:r>
+          </a:p>
+        </p:txBody>
+      </p:sp>
+      <p:sp>
+        <p:nvSpPr>
           <p:cNvPr id="8" name="TextBox 7"/>
           <p:cNvSpPr txBox="1"/>
           <p:nvPr/>
@@ -9297,7 +10678,7 @@
             <a:r>
               <a:rPr sz="900" b="0">
                 <a:solidFill>
-                  <a:srgbClr val="5A5750"/>
+                  <a:srgbClr val="A7B3AB"/>
                 </a:solidFill>
                 <a:latin typeface="Inter"/>
               </a:rPr>
@@ -9331,7 +10712,7 @@
             <a:r>
               <a:rPr sz="900" b="0">
                 <a:solidFill>
-                  <a:srgbClr val="5A5750"/>
+                  <a:srgbClr val="A7B3AB"/>
                 </a:solidFill>
                 <a:latin typeface="Inter"/>
               </a:rPr>
@@ -9794,7 +11175,7 @@
         </p:nvPicPr>
         <p:blipFill>
           <a:blip r:embed="rId2"/>
-          <a:srcRect l="14216" r="14216"/>
+          <a:srcRect l="22746" r="5686"/>
           <a:stretch>
             <a:fillRect/>
           </a:stretch>
@@ -9811,14 +11192,59 @@
       </p:pic>
       <p:sp>
         <p:nvSpPr>
-          <p:cNvPr id="14" name="TextBox 13"/>
-          <p:cNvSpPr txBox="1"/>
-          <p:nvPr/>
-        </p:nvSpPr>
-        <p:spPr>
-          <a:xfrm>
-            <a:off x="4508500" y="6134100"/>
-            <a:ext cx="7112000" cy="190500"/>
+          <p:cNvPr id="14" name="Rectangle 13"/>
+          <p:cNvSpPr/>
+          <p:nvPr/>
+        </p:nvSpPr>
+        <p:spPr>
+          <a:xfrm>
+            <a:off x="4445000" y="6096000"/>
+            <a:ext cx="2108200" cy="254000"/>
+          </a:xfrm>
+          <a:prstGeom prst="rect">
+            <a:avLst/>
+          </a:prstGeom>
+          <a:solidFill>
+            <a:srgbClr val="141412">
+              <a:alpha val="62000"/>
+            </a:srgbClr>
+          </a:solidFill>
+          <a:ln>
+            <a:noFill/>
+          </a:ln>
+        </p:spPr>
+        <p:style>
+          <a:lnRef idx="1">
+            <a:schemeClr val="accent1"/>
+          </a:lnRef>
+          <a:fillRef idx="3">
+            <a:schemeClr val="accent1"/>
+          </a:fillRef>
+          <a:effectRef idx="2">
+            <a:schemeClr val="accent1"/>
+          </a:effectRef>
+          <a:fontRef idx="minor">
+            <a:schemeClr val="lt1"/>
+          </a:fontRef>
+        </p:style>
+        <p:txBody>
+          <a:bodyPr rtlCol="0" anchor="ctr"/>
+          <a:lstStyle/>
+          <a:p>
+            <a:pPr algn="ctr"/>
+          </a:p>
+        </p:txBody>
+      </p:sp>
+      <p:sp>
+        <p:nvSpPr>
+          <p:cNvPr id="15" name="TextBox 14"/>
+          <p:cNvSpPr txBox="1"/>
+          <p:nvPr/>
+        </p:nvSpPr>
+        <p:spPr>
+          <a:xfrm>
+            <a:off x="4495800" y="6108700"/>
+            <a:ext cx="7137400" cy="215900"/>
           </a:xfrm>
           <a:prstGeom prst="rect">
             <a:avLst/>
@@ -9838,14 +11264,14 @@
                 </a:solidFill>
                 <a:latin typeface="Inter"/>
               </a:rPr>
-              <a:t>Reception and visitor waiting (preview render)</a:t>
-            </a:r>
-          </a:p>
-        </p:txBody>
-      </p:sp>
-      <p:sp>
-        <p:nvSpPr>
-          <p:cNvPr id="15" name="TextBox 14"/>
+              <a:t>Reception desk and logo wall</a:t>
+            </a:r>
+          </a:p>
+        </p:txBody>
+      </p:sp>
+      <p:sp>
+        <p:nvSpPr>
+          <p:cNvPr id="16" name="TextBox 15"/>
           <p:cNvSpPr txBox="1"/>
           <p:nvPr/>
         </p:nvSpPr>
@@ -9879,7 +11305,7 @@
       </p:sp>
       <p:sp>
         <p:nvSpPr>
-          <p:cNvPr id="16" name="TextBox 15"/>
+          <p:cNvPr id="17" name="TextBox 16"/>
           <p:cNvSpPr txBox="1"/>
           <p:nvPr/>
         </p:nvSpPr>
@@ -12310,54 +13736,22 @@
       </p:pic>
       <p:sp>
         <p:nvSpPr>
-          <p:cNvPr id="3" name="TextBox 2"/>
-          <p:cNvSpPr txBox="1"/>
-          <p:nvPr/>
-        </p:nvSpPr>
-        <p:spPr>
-          <a:xfrm>
-            <a:off x="63500" y="6642100"/>
-            <a:ext cx="12065000" cy="190500"/>
-          </a:xfrm>
-          <a:prstGeom prst="rect">
-            <a:avLst/>
-          </a:prstGeom>
-          <a:noFill/>
-        </p:spPr>
-        <p:txBody>
-          <a:bodyPr wrap="square">
-            <a:spAutoFit/>
-          </a:bodyPr>
-          <a:lstStyle/>
-          <a:p>
-            <a:r>
-              <a:rPr sz="1100" b="0">
-                <a:solidFill>
-                  <a:srgbClr val="FFFFFF"/>
-                </a:solidFill>
-                <a:latin typeface="Inter"/>
-              </a:rPr>
-              <a:t>Overall isometric cut-away of the furnished floor - Blender Cycles render</a:t>
-            </a:r>
-          </a:p>
-        </p:txBody>
-      </p:sp>
-      <p:sp>
-        <p:nvSpPr>
-          <p:cNvPr id="4" name="Rectangle 3"/>
+          <p:cNvPr id="3" name="Rectangle 2"/>
           <p:cNvSpPr/>
           <p:nvPr/>
         </p:nvSpPr>
         <p:spPr>
           <a:xfrm>
-            <a:off x="317500" y="317500"/>
-            <a:ext cx="4572000" cy="2095500"/>
+            <a:off x="0" y="6096000"/>
+            <a:ext cx="12192000" cy="762000"/>
           </a:xfrm>
           <a:prstGeom prst="rect">
             <a:avLst/>
           </a:prstGeom>
           <a:solidFill>
-            <a:srgbClr val="F6F3EE"/>
+            <a:srgbClr val="080C0E">
+              <a:alpha val="80000"/>
+            </a:srgbClr>
           </a:solidFill>
           <a:ln>
             <a:noFill/>
@@ -12387,6 +13781,49 @@
       </p:sp>
       <p:sp>
         <p:nvSpPr>
+          <p:cNvPr id="4" name="Rectangle 3"/>
+          <p:cNvSpPr/>
+          <p:nvPr/>
+        </p:nvSpPr>
+        <p:spPr>
+          <a:xfrm>
+            <a:off x="317500" y="317500"/>
+            <a:ext cx="4572000" cy="2095500"/>
+          </a:xfrm>
+          <a:prstGeom prst="rect">
+            <a:avLst/>
+          </a:prstGeom>
+          <a:solidFill>
+            <a:srgbClr val="F6F3EE"/>
+          </a:solidFill>
+          <a:ln>
+            <a:noFill/>
+          </a:ln>
+        </p:spPr>
+        <p:style>
+          <a:lnRef idx="1">
+            <a:schemeClr val="accent1"/>
+          </a:lnRef>
+          <a:fillRef idx="3">
+            <a:schemeClr val="accent1"/>
+          </a:fillRef>
+          <a:effectRef idx="2">
+            <a:schemeClr val="accent1"/>
+          </a:effectRef>
+          <a:fontRef idx="minor">
+            <a:schemeClr val="lt1"/>
+          </a:fontRef>
+        </p:style>
+        <p:txBody>
+          <a:bodyPr rtlCol="0" anchor="ctr"/>
+          <a:lstStyle/>
+          <a:p>
+            <a:pPr algn="ctr"/>
+          </a:p>
+        </p:txBody>
+      </p:sp>
+      <p:sp>
+        <p:nvSpPr>
           <p:cNvPr id="5" name="TextBox 4"/>
           <p:cNvSpPr txBox="1"/>
           <p:nvPr/>
@@ -12495,6 +13932,41 @@
         </p:nvSpPr>
         <p:spPr>
           <a:xfrm>
+            <a:off x="5715000" y="6248400"/>
+            <a:ext cx="5969000" cy="190500"/>
+          </a:xfrm>
+          <a:prstGeom prst="rect">
+            <a:avLst/>
+          </a:prstGeom>
+          <a:noFill/>
+        </p:spPr>
+        <p:txBody>
+          <a:bodyPr wrap="square">
+            <a:spAutoFit/>
+          </a:bodyPr>
+          <a:lstStyle/>
+          <a:p>
+            <a:pPr algn="r"/>
+            <a:r>
+              <a:rPr sz="900" b="0">
+                <a:solidFill>
+                  <a:srgbClr val="C9D3CC"/>
+                </a:solidFill>
+                <a:latin typeface="Inter"/>
+              </a:rPr>
+              <a:t>Overall isometric cut-away of the furnished floor - Blender Cycles render</a:t>
+            </a:r>
+          </a:p>
+        </p:txBody>
+      </p:sp>
+      <p:sp>
+        <p:nvSpPr>
+          <p:cNvPr id="9" name="TextBox 8"/>
+          <p:cNvSpPr txBox="1"/>
+          <p:nvPr/>
+        </p:nvSpPr>
+        <p:spPr>
+          <a:xfrm>
             <a:off x="508000" y="6578600"/>
             <a:ext cx="8255000" cy="190500"/>
           </a:xfrm>
@@ -12512,7 +13984,7 @@
             <a:r>
               <a:rPr sz="900" b="0">
                 <a:solidFill>
-                  <a:srgbClr val="5A5750"/>
+                  <a:srgbClr val="A7B3AB"/>
                 </a:solidFill>
                 <a:latin typeface="Inter"/>
               </a:rPr>
@@ -12523,7 +13995,7 @@
       </p:sp>
       <p:sp>
         <p:nvSpPr>
-          <p:cNvPr id="9" name="TextBox 8"/>
+          <p:cNvPr id="10" name="TextBox 9"/>
           <p:cNvSpPr txBox="1"/>
           <p:nvPr/>
         </p:nvSpPr>
@@ -12546,7 +14018,7 @@
             <a:r>
               <a:rPr sz="900" b="0">
                 <a:solidFill>
-                  <a:srgbClr val="5A5750"/>
+                  <a:srgbClr val="A7B3AB"/>
                 </a:solidFill>
                 <a:latin typeface="Inter"/>
               </a:rPr>
@@ -12624,7 +14096,7 @@
         <p:spPr>
           <a:xfrm>
             <a:off x="508000" y="863600"/>
-            <a:ext cx="3683000" cy="1524000"/>
+            <a:ext cx="3683000" cy="952500"/>
           </a:xfrm>
           <a:prstGeom prst="rect">
             <a:avLst/>
@@ -12657,22 +14129,22 @@
         </p:nvSpPr>
         <p:spPr>
           <a:xfrm>
-            <a:off x="508000" y="2540000"/>
-            <a:ext cx="3683000" cy="2349500"/>
-          </a:xfrm>
-          <a:prstGeom prst="rect">
-            <a:avLst/>
-          </a:prstGeom>
-          <a:noFill/>
-        </p:spPr>
-        <p:txBody>
-          <a:bodyPr wrap="square">
-            <a:spAutoFit/>
-          </a:bodyPr>
-          <a:lstStyle/>
-          <a:p>
-            <a:r>
-              <a:rPr sz="1400" b="0">
+            <a:off x="508000" y="1841500"/>
+            <a:ext cx="3683000" cy="3048000"/>
+          </a:xfrm>
+          <a:prstGeom prst="rect">
+            <a:avLst/>
+          </a:prstGeom>
+          <a:noFill/>
+        </p:spPr>
+        <p:txBody>
+          <a:bodyPr wrap="square">
+            <a:spAutoFit/>
+          </a:bodyPr>
+          <a:lstStyle/>
+          <a:p>
+            <a:r>
+              <a:rPr sz="1300" b="0">
                 <a:solidFill>
                   <a:srgbClr val="5A5750"/>
                 </a:solidFill>
@@ -12683,7 +14155,7 @@
           </a:p>
           <a:p>
             <a:r>
-              <a:rPr sz="1400" b="0">
+              <a:rPr sz="1300" b="0">
                 <a:solidFill>
                   <a:srgbClr val="5A5750"/>
                 </a:solidFill>
@@ -12694,7 +14166,7 @@
           </a:p>
           <a:p>
             <a:r>
-              <a:rPr sz="1400" b="0">
+              <a:rPr sz="1300" b="0">
                 <a:solidFill>
                   <a:srgbClr val="5A5750"/>
                 </a:solidFill>
@@ -12705,7 +14177,7 @@
           </a:p>
           <a:p>
             <a:r>
-              <a:rPr sz="1400" b="0">
+              <a:rPr sz="1300" b="0">
                 <a:solidFill>
                   <a:srgbClr val="5A5750"/>
                 </a:solidFill>
@@ -12716,7 +14188,7 @@
           </a:p>
           <a:p>
             <a:r>
-              <a:rPr sz="1400" b="0">
+              <a:rPr sz="1300" b="0">
                 <a:solidFill>
                   <a:srgbClr val="5A5750"/>
                 </a:solidFill>
@@ -12727,7 +14199,7 @@
           </a:p>
           <a:p>
             <a:r>
-              <a:rPr sz="1400" b="0">
+              <a:rPr sz="1300" b="0">
                 <a:solidFill>
                   <a:srgbClr val="5A5750"/>
                 </a:solidFill>
@@ -13167,14 +14639,59 @@
       </p:pic>
       <p:sp>
         <p:nvSpPr>
-          <p:cNvPr id="19" name="TextBox 18"/>
-          <p:cNvSpPr txBox="1"/>
-          <p:nvPr/>
-        </p:nvSpPr>
-        <p:spPr>
-          <a:xfrm>
-            <a:off x="4508500" y="4000500"/>
-            <a:ext cx="7112000" cy="190500"/>
+          <p:cNvPr id="19" name="Rectangle 18"/>
+          <p:cNvSpPr/>
+          <p:nvPr/>
+        </p:nvSpPr>
+        <p:spPr>
+          <a:xfrm>
+            <a:off x="4445000" y="3962400"/>
+            <a:ext cx="2108200" cy="254000"/>
+          </a:xfrm>
+          <a:prstGeom prst="rect">
+            <a:avLst/>
+          </a:prstGeom>
+          <a:solidFill>
+            <a:srgbClr val="141412">
+              <a:alpha val="62000"/>
+            </a:srgbClr>
+          </a:solidFill>
+          <a:ln>
+            <a:noFill/>
+          </a:ln>
+        </p:spPr>
+        <p:style>
+          <a:lnRef idx="1">
+            <a:schemeClr val="accent1"/>
+          </a:lnRef>
+          <a:fillRef idx="3">
+            <a:schemeClr val="accent1"/>
+          </a:fillRef>
+          <a:effectRef idx="2">
+            <a:schemeClr val="accent1"/>
+          </a:effectRef>
+          <a:fontRef idx="minor">
+            <a:schemeClr val="lt1"/>
+          </a:fontRef>
+        </p:style>
+        <p:txBody>
+          <a:bodyPr rtlCol="0" anchor="ctr"/>
+          <a:lstStyle/>
+          <a:p>
+            <a:pPr algn="ctr"/>
+          </a:p>
+        </p:txBody>
+      </p:sp>
+      <p:sp>
+        <p:nvSpPr>
+          <p:cNvPr id="20" name="TextBox 19"/>
+          <p:cNvSpPr txBox="1"/>
+          <p:nvPr/>
+        </p:nvSpPr>
+        <p:spPr>
+          <a:xfrm>
+            <a:off x="4495800" y="3975100"/>
+            <a:ext cx="7137400" cy="215900"/>
           </a:xfrm>
           <a:prstGeom prst="rect">
             <a:avLst/>
@@ -13194,14 +14711,14 @@
                 </a:solidFill>
                 <a:latin typeface="Inter"/>
               </a:rPr>
-              <a:t>Reception</a:t>
+              <a:t>Reception and visitor lounge</a:t>
             </a:r>
           </a:p>
         </p:txBody>
       </p:sp>
       <p:pic>
         <p:nvPicPr>
-          <p:cNvPr id="20" name="Picture 19" descr="CAM_02_Reception_B.jpg"/>
+          <p:cNvPr id="21" name="Picture 20" descr="CAM_02_Reception_B.jpg"/>
           <p:cNvPicPr>
             <a:picLocks noChangeAspect="1"/>
           </p:cNvPicPr>
@@ -13226,14 +14743,59 @@
       </p:pic>
       <p:sp>
         <p:nvSpPr>
-          <p:cNvPr id="21" name="TextBox 20"/>
-          <p:cNvSpPr txBox="1"/>
-          <p:nvPr/>
-        </p:nvSpPr>
-        <p:spPr>
-          <a:xfrm>
-            <a:off x="4508500" y="6134100"/>
-            <a:ext cx="3441700" cy="190500"/>
+          <p:cNvPr id="22" name="Rectangle 21"/>
+          <p:cNvSpPr/>
+          <p:nvPr/>
+        </p:nvSpPr>
+        <p:spPr>
+          <a:xfrm>
+            <a:off x="4445000" y="6096000"/>
+            <a:ext cx="2108200" cy="254000"/>
+          </a:xfrm>
+          <a:prstGeom prst="rect">
+            <a:avLst/>
+          </a:prstGeom>
+          <a:solidFill>
+            <a:srgbClr val="141412">
+              <a:alpha val="62000"/>
+            </a:srgbClr>
+          </a:solidFill>
+          <a:ln>
+            <a:noFill/>
+          </a:ln>
+        </p:spPr>
+        <p:style>
+          <a:lnRef idx="1">
+            <a:schemeClr val="accent1"/>
+          </a:lnRef>
+          <a:fillRef idx="3">
+            <a:schemeClr val="accent1"/>
+          </a:fillRef>
+          <a:effectRef idx="2">
+            <a:schemeClr val="accent1"/>
+          </a:effectRef>
+          <a:fontRef idx="minor">
+            <a:schemeClr val="lt1"/>
+          </a:fontRef>
+        </p:style>
+        <p:txBody>
+          <a:bodyPr rtlCol="0" anchor="ctr"/>
+          <a:lstStyle/>
+          <a:p>
+            <a:pPr algn="ctr"/>
+          </a:p>
+        </p:txBody>
+      </p:sp>
+      <p:sp>
+        <p:nvSpPr>
+          <p:cNvPr id="23" name="TextBox 22"/>
+          <p:cNvSpPr txBox="1"/>
+          <p:nvPr/>
+        </p:nvSpPr>
+        <p:spPr>
+          <a:xfrm>
+            <a:off x="4495800" y="6108700"/>
+            <a:ext cx="3467100" cy="215900"/>
           </a:xfrm>
           <a:prstGeom prst="rect">
             <a:avLst/>
@@ -13253,14 +14815,14 @@
                 </a:solidFill>
                 <a:latin typeface="Inter"/>
               </a:rPr>
-              <a:t>Reception - waiting (preview render)</a:t>
+              <a:t>Reception desk and logo wall</a:t>
             </a:r>
           </a:p>
         </p:txBody>
       </p:sp>
       <p:pic>
         <p:nvPicPr>
-          <p:cNvPr id="22" name="Picture 21" descr="CAM_03_Entrance_Lobby.jpg"/>
+          <p:cNvPr id="24" name="Picture 23" descr="CAM_03_Entrance_Lobby.jpg"/>
           <p:cNvPicPr>
             <a:picLocks noChangeAspect="1"/>
           </p:cNvPicPr>
@@ -13285,14 +14847,59 @@
       </p:pic>
       <p:sp>
         <p:nvSpPr>
-          <p:cNvPr id="23" name="TextBox 22"/>
-          <p:cNvSpPr txBox="1"/>
-          <p:nvPr/>
-        </p:nvSpPr>
-        <p:spPr>
-          <a:xfrm>
-            <a:off x="8178800" y="6134100"/>
-            <a:ext cx="3441700" cy="190500"/>
+          <p:cNvPr id="25" name="Rectangle 24"/>
+          <p:cNvSpPr/>
+          <p:nvPr/>
+        </p:nvSpPr>
+        <p:spPr>
+          <a:xfrm>
+            <a:off x="8115300" y="6096000"/>
+            <a:ext cx="3206750" cy="254000"/>
+          </a:xfrm>
+          <a:prstGeom prst="rect">
+            <a:avLst/>
+          </a:prstGeom>
+          <a:solidFill>
+            <a:srgbClr val="141412">
+              <a:alpha val="62000"/>
+            </a:srgbClr>
+          </a:solidFill>
+          <a:ln>
+            <a:noFill/>
+          </a:ln>
+        </p:spPr>
+        <p:style>
+          <a:lnRef idx="1">
+            <a:schemeClr val="accent1"/>
+          </a:lnRef>
+          <a:fillRef idx="3">
+            <a:schemeClr val="accent1"/>
+          </a:fillRef>
+          <a:effectRef idx="2">
+            <a:schemeClr val="accent1"/>
+          </a:effectRef>
+          <a:fontRef idx="minor">
+            <a:schemeClr val="lt1"/>
+          </a:fontRef>
+        </p:style>
+        <p:txBody>
+          <a:bodyPr rtlCol="0" anchor="ctr"/>
+          <a:lstStyle/>
+          <a:p>
+            <a:pPr algn="ctr"/>
+          </a:p>
+        </p:txBody>
+      </p:sp>
+      <p:sp>
+        <p:nvSpPr>
+          <p:cNvPr id="26" name="TextBox 25"/>
+          <p:cNvSpPr txBox="1"/>
+          <p:nvPr/>
+        </p:nvSpPr>
+        <p:spPr>
+          <a:xfrm>
+            <a:off x="8166100" y="6108700"/>
+            <a:ext cx="3467100" cy="215900"/>
           </a:xfrm>
           <a:prstGeom prst="rect">
             <a:avLst/>
@@ -13319,7 +14926,7 @@
       </p:sp>
       <p:sp>
         <p:nvSpPr>
-          <p:cNvPr id="24" name="TextBox 23"/>
+          <p:cNvPr id="27" name="TextBox 26"/>
           <p:cNvSpPr txBox="1"/>
           <p:nvPr/>
         </p:nvSpPr>
@@ -13353,7 +14960,7 @@
       </p:sp>
       <p:sp>
         <p:nvSpPr>
-          <p:cNvPr id="25" name="TextBox 24"/>
+          <p:cNvPr id="28" name="TextBox 27"/>
           <p:cNvSpPr txBox="1"/>
           <p:nvPr/>
         </p:nvSpPr>
@@ -13454,7 +15061,7 @@
         <p:spPr>
           <a:xfrm>
             <a:off x="508000" y="863600"/>
-            <a:ext cx="3683000" cy="1524000"/>
+            <a:ext cx="3683000" cy="952500"/>
           </a:xfrm>
           <a:prstGeom prst="rect">
             <a:avLst/>
@@ -13487,22 +15094,22 @@
         </p:nvSpPr>
         <p:spPr>
           <a:xfrm>
-            <a:off x="508000" y="2540000"/>
-            <a:ext cx="3683000" cy="2349500"/>
-          </a:xfrm>
-          <a:prstGeom prst="rect">
-            <a:avLst/>
-          </a:prstGeom>
-          <a:noFill/>
-        </p:spPr>
-        <p:txBody>
-          <a:bodyPr wrap="square">
-            <a:spAutoFit/>
-          </a:bodyPr>
-          <a:lstStyle/>
-          <a:p>
-            <a:r>
-              <a:rPr sz="1400" b="0">
+            <a:off x="508000" y="1841500"/>
+            <a:ext cx="3683000" cy="3048000"/>
+          </a:xfrm>
+          <a:prstGeom prst="rect">
+            <a:avLst/>
+          </a:prstGeom>
+          <a:noFill/>
+        </p:spPr>
+        <p:txBody>
+          <a:bodyPr wrap="square">
+            <a:spAutoFit/>
+          </a:bodyPr>
+          <a:lstStyle/>
+          <a:p>
+            <a:r>
+              <a:rPr sz="1300" b="0">
                 <a:solidFill>
                   <a:srgbClr val="5A5750"/>
                 </a:solidFill>
@@ -13513,7 +15120,7 @@
           </a:p>
           <a:p>
             <a:r>
-              <a:rPr sz="1400" b="0">
+              <a:rPr sz="1300" b="0">
                 <a:solidFill>
                   <a:srgbClr val="5A5750"/>
                 </a:solidFill>
@@ -13524,7 +15131,7 @@
           </a:p>
           <a:p>
             <a:r>
-              <a:rPr sz="1400" b="0">
+              <a:rPr sz="1300" b="0">
                 <a:solidFill>
                   <a:srgbClr val="5A5750"/>
                 </a:solidFill>
@@ -13535,7 +15142,7 @@
           </a:p>
           <a:p>
             <a:r>
-              <a:rPr sz="1400" b="0">
+              <a:rPr sz="1300" b="0">
                 <a:solidFill>
                   <a:srgbClr val="5A5750"/>
                 </a:solidFill>
@@ -13546,7 +15153,7 @@
           </a:p>
           <a:p>
             <a:r>
-              <a:rPr sz="1400" b="0">
+              <a:rPr sz="1300" b="0">
                 <a:solidFill>
                   <a:srgbClr val="5A5750"/>
                 </a:solidFill>
@@ -13557,7 +15164,7 @@
           </a:p>
           <a:p>
             <a:r>
-              <a:rPr sz="1400" b="0">
+              <a:rPr sz="1300" b="0">
                 <a:solidFill>
                   <a:srgbClr val="5A5750"/>
                 </a:solidFill>
@@ -13568,7 +15175,7 @@
           </a:p>
           <a:p>
             <a:r>
-              <a:rPr sz="1400" b="0">
+              <a:rPr sz="1300" b="0">
                 <a:solidFill>
                   <a:srgbClr val="5A5750"/>
                 </a:solidFill>
@@ -14008,14 +15615,59 @@
       </p:pic>
       <p:sp>
         <p:nvSpPr>
-          <p:cNvPr id="19" name="TextBox 18"/>
-          <p:cNvSpPr txBox="1"/>
-          <p:nvPr/>
-        </p:nvSpPr>
-        <p:spPr>
-          <a:xfrm>
-            <a:off x="4508500" y="4000500"/>
-            <a:ext cx="7112000" cy="190500"/>
+          <p:cNvPr id="19" name="Rectangle 18"/>
+          <p:cNvSpPr/>
+          <p:nvPr/>
+        </p:nvSpPr>
+        <p:spPr>
+          <a:xfrm>
+            <a:off x="4445000" y="3962400"/>
+            <a:ext cx="1352550" cy="254000"/>
+          </a:xfrm>
+          <a:prstGeom prst="rect">
+            <a:avLst/>
+          </a:prstGeom>
+          <a:solidFill>
+            <a:srgbClr val="141412">
+              <a:alpha val="62000"/>
+            </a:srgbClr>
+          </a:solidFill>
+          <a:ln>
+            <a:noFill/>
+          </a:ln>
+        </p:spPr>
+        <p:style>
+          <a:lnRef idx="1">
+            <a:schemeClr val="accent1"/>
+          </a:lnRef>
+          <a:fillRef idx="3">
+            <a:schemeClr val="accent1"/>
+          </a:fillRef>
+          <a:effectRef idx="2">
+            <a:schemeClr val="accent1"/>
+          </a:effectRef>
+          <a:fontRef idx="minor">
+            <a:schemeClr val="lt1"/>
+          </a:fontRef>
+        </p:style>
+        <p:txBody>
+          <a:bodyPr rtlCol="0" anchor="ctr"/>
+          <a:lstStyle/>
+          <a:p>
+            <a:pPr algn="ctr"/>
+          </a:p>
+        </p:txBody>
+      </p:sp>
+      <p:sp>
+        <p:nvSpPr>
+          <p:cNvPr id="20" name="TextBox 19"/>
+          <p:cNvSpPr txBox="1"/>
+          <p:nvPr/>
+        </p:nvSpPr>
+        <p:spPr>
+          <a:xfrm>
+            <a:off x="4495800" y="3975100"/>
+            <a:ext cx="7137400" cy="215900"/>
           </a:xfrm>
           <a:prstGeom prst="rect">
             <a:avLst/>
@@ -14042,7 +15694,7 @@
       </p:sp>
       <p:pic>
         <p:nvPicPr>
-          <p:cNvPr id="20" name="Picture 19" descr="CAM_05_Experience_Centre_B.jpg"/>
+          <p:cNvPr id="21" name="Picture 20" descr="CAM_05_Experience_Centre_B.jpg"/>
           <p:cNvPicPr>
             <a:picLocks noChangeAspect="1"/>
           </p:cNvPicPr>
@@ -14067,14 +15719,59 @@
       </p:pic>
       <p:sp>
         <p:nvSpPr>
-          <p:cNvPr id="21" name="TextBox 20"/>
-          <p:cNvSpPr txBox="1"/>
-          <p:nvPr/>
-        </p:nvSpPr>
-        <p:spPr>
-          <a:xfrm>
-            <a:off x="4508500" y="6134100"/>
-            <a:ext cx="3441700" cy="190500"/>
+          <p:cNvPr id="22" name="Rectangle 21"/>
+          <p:cNvSpPr/>
+          <p:nvPr/>
+        </p:nvSpPr>
+        <p:spPr>
+          <a:xfrm>
+            <a:off x="4445000" y="6096000"/>
+            <a:ext cx="2247900" cy="254000"/>
+          </a:xfrm>
+          <a:prstGeom prst="rect">
+            <a:avLst/>
+          </a:prstGeom>
+          <a:solidFill>
+            <a:srgbClr val="141412">
+              <a:alpha val="62000"/>
+            </a:srgbClr>
+          </a:solidFill>
+          <a:ln>
+            <a:noFill/>
+          </a:ln>
+        </p:spPr>
+        <p:style>
+          <a:lnRef idx="1">
+            <a:schemeClr val="accent1"/>
+          </a:lnRef>
+          <a:fillRef idx="3">
+            <a:schemeClr val="accent1"/>
+          </a:fillRef>
+          <a:effectRef idx="2">
+            <a:schemeClr val="accent1"/>
+          </a:effectRef>
+          <a:fontRef idx="minor">
+            <a:schemeClr val="lt1"/>
+          </a:fontRef>
+        </p:style>
+        <p:txBody>
+          <a:bodyPr rtlCol="0" anchor="ctr"/>
+          <a:lstStyle/>
+          <a:p>
+            <a:pPr algn="ctr"/>
+          </a:p>
+        </p:txBody>
+      </p:sp>
+      <p:sp>
+        <p:nvSpPr>
+          <p:cNvPr id="23" name="TextBox 22"/>
+          <p:cNvSpPr txBox="1"/>
+          <p:nvPr/>
+        </p:nvSpPr>
+        <p:spPr>
+          <a:xfrm>
+            <a:off x="4495800" y="6108700"/>
+            <a:ext cx="3467100" cy="215900"/>
           </a:xfrm>
           <a:prstGeom prst="rect">
             <a:avLst/>
@@ -14094,14 +15791,14 @@
                 </a:solidFill>
                 <a:latin typeface="Inter"/>
               </a:rPr>
-              <a:t>Experience centre - story wall (preview render)</a:t>
+              <a:t>Experience centre - story wall</a:t>
             </a:r>
           </a:p>
         </p:txBody>
       </p:sp>
       <p:pic>
         <p:nvPicPr>
-          <p:cNvPr id="22" name="Picture 21" descr="CAM_06_Experience_Centre_Detail.jpg"/>
+          <p:cNvPr id="24" name="Picture 23" descr="CAM_06_Experience_Centre_Detail.jpg"/>
           <p:cNvPicPr>
             <a:picLocks noChangeAspect="1"/>
           </p:cNvPicPr>
@@ -14126,14 +15823,59 @@
       </p:pic>
       <p:sp>
         <p:nvSpPr>
-          <p:cNvPr id="23" name="TextBox 22"/>
-          <p:cNvSpPr txBox="1"/>
-          <p:nvPr/>
-        </p:nvSpPr>
-        <p:spPr>
-          <a:xfrm>
-            <a:off x="8178800" y="6134100"/>
-            <a:ext cx="3441700" cy="190500"/>
+          <p:cNvPr id="25" name="Rectangle 24"/>
+          <p:cNvSpPr/>
+          <p:nvPr/>
+        </p:nvSpPr>
+        <p:spPr>
+          <a:xfrm>
+            <a:off x="8115300" y="6096000"/>
+            <a:ext cx="2311400" cy="254000"/>
+          </a:xfrm>
+          <a:prstGeom prst="rect">
+            <a:avLst/>
+          </a:prstGeom>
+          <a:solidFill>
+            <a:srgbClr val="141412">
+              <a:alpha val="62000"/>
+            </a:srgbClr>
+          </a:solidFill>
+          <a:ln>
+            <a:noFill/>
+          </a:ln>
+        </p:spPr>
+        <p:style>
+          <a:lnRef idx="1">
+            <a:schemeClr val="accent1"/>
+          </a:lnRef>
+          <a:fillRef idx="3">
+            <a:schemeClr val="accent1"/>
+          </a:fillRef>
+          <a:effectRef idx="2">
+            <a:schemeClr val="accent1"/>
+          </a:effectRef>
+          <a:fontRef idx="minor">
+            <a:schemeClr val="lt1"/>
+          </a:fontRef>
+        </p:style>
+        <p:txBody>
+          <a:bodyPr rtlCol="0" anchor="ctr"/>
+          <a:lstStyle/>
+          <a:p>
+            <a:pPr algn="ctr"/>
+          </a:p>
+        </p:txBody>
+      </p:sp>
+      <p:sp>
+        <p:nvSpPr>
+          <p:cNvPr id="26" name="TextBox 25"/>
+          <p:cNvSpPr txBox="1"/>
+          <p:nvPr/>
+        </p:nvSpPr>
+        <p:spPr>
+          <a:xfrm>
+            <a:off x="8166100" y="6108700"/>
+            <a:ext cx="3467100" cy="215900"/>
           </a:xfrm>
           <a:prstGeom prst="rect">
             <a:avLst/>
@@ -14160,7 +15902,7 @@
       </p:sp>
       <p:sp>
         <p:nvSpPr>
-          <p:cNvPr id="24" name="TextBox 23"/>
+          <p:cNvPr id="27" name="TextBox 26"/>
           <p:cNvSpPr txBox="1"/>
           <p:nvPr/>
         </p:nvSpPr>
@@ -14194,7 +15936,7 @@
       </p:sp>
       <p:sp>
         <p:nvSpPr>
-          <p:cNvPr id="25" name="TextBox 24"/>
+          <p:cNvPr id="28" name="TextBox 27"/>
           <p:cNvSpPr txBox="1"/>
           <p:nvPr/>
         </p:nvSpPr>
@@ -14295,7 +16037,7 @@
         <p:spPr>
           <a:xfrm>
             <a:off x="508000" y="863600"/>
-            <a:ext cx="3683000" cy="1524000"/>
+            <a:ext cx="3683000" cy="952500"/>
           </a:xfrm>
           <a:prstGeom prst="rect">
             <a:avLst/>
@@ -14328,22 +16070,22 @@
         </p:nvSpPr>
         <p:spPr>
           <a:xfrm>
-            <a:off x="508000" y="2540000"/>
-            <a:ext cx="3683000" cy="2349500"/>
-          </a:xfrm>
-          <a:prstGeom prst="rect">
-            <a:avLst/>
-          </a:prstGeom>
-          <a:noFill/>
-        </p:spPr>
-        <p:txBody>
-          <a:bodyPr wrap="square">
-            <a:spAutoFit/>
-          </a:bodyPr>
-          <a:lstStyle/>
-          <a:p>
-            <a:r>
-              <a:rPr sz="1400" b="0">
+            <a:off x="508000" y="1841500"/>
+            <a:ext cx="3683000" cy="3048000"/>
+          </a:xfrm>
+          <a:prstGeom prst="rect">
+            <a:avLst/>
+          </a:prstGeom>
+          <a:noFill/>
+        </p:spPr>
+        <p:txBody>
+          <a:bodyPr wrap="square">
+            <a:spAutoFit/>
+          </a:bodyPr>
+          <a:lstStyle/>
+          <a:p>
+            <a:r>
+              <a:rPr sz="1300" b="0">
                 <a:solidFill>
                   <a:srgbClr val="5A5750"/>
                 </a:solidFill>
@@ -14354,7 +16096,7 @@
           </a:p>
           <a:p>
             <a:r>
-              <a:rPr sz="1400" b="0">
+              <a:rPr sz="1300" b="0">
                 <a:solidFill>
                   <a:srgbClr val="5A5750"/>
                 </a:solidFill>
@@ -14365,7 +16107,7 @@
           </a:p>
           <a:p>
             <a:r>
-              <a:rPr sz="1400" b="0">
+              <a:rPr sz="1300" b="0">
                 <a:solidFill>
                   <a:srgbClr val="5A5750"/>
                 </a:solidFill>
@@ -14376,7 +16118,7 @@
           </a:p>
           <a:p>
             <a:r>
-              <a:rPr sz="1400" b="0">
+              <a:rPr sz="1300" b="0">
                 <a:solidFill>
                   <a:srgbClr val="5A5750"/>
                 </a:solidFill>
@@ -14387,7 +16129,7 @@
           </a:p>
           <a:p>
             <a:r>
-              <a:rPr sz="1400" b="0">
+              <a:rPr sz="1300" b="0">
                 <a:solidFill>
                   <a:srgbClr val="5A5750"/>
                 </a:solidFill>
@@ -14398,7 +16140,7 @@
           </a:p>
           <a:p>
             <a:r>
-              <a:rPr sz="1400" b="0">
+              <a:rPr sz="1300" b="0">
                 <a:solidFill>
                   <a:srgbClr val="5A5750"/>
                 </a:solidFill>
@@ -14409,7 +16151,7 @@
           </a:p>
           <a:p>
             <a:r>
-              <a:rPr sz="1400" b="0">
+              <a:rPr sz="1300" b="0">
                 <a:solidFill>
                   <a:srgbClr val="5A5750"/>
                 </a:solidFill>
@@ -14849,14 +16591,59 @@
       </p:pic>
       <p:sp>
         <p:nvSpPr>
-          <p:cNvPr id="19" name="TextBox 18"/>
-          <p:cNvSpPr txBox="1"/>
-          <p:nvPr/>
-        </p:nvSpPr>
-        <p:spPr>
-          <a:xfrm>
-            <a:off x="4508500" y="4000500"/>
-            <a:ext cx="7112000" cy="190500"/>
+          <p:cNvPr id="19" name="Rectangle 18"/>
+          <p:cNvSpPr/>
+          <p:nvPr/>
+        </p:nvSpPr>
+        <p:spPr>
+          <a:xfrm>
+            <a:off x="4445000" y="3962400"/>
+            <a:ext cx="806450" cy="254000"/>
+          </a:xfrm>
+          <a:prstGeom prst="rect">
+            <a:avLst/>
+          </a:prstGeom>
+          <a:solidFill>
+            <a:srgbClr val="141412">
+              <a:alpha val="62000"/>
+            </a:srgbClr>
+          </a:solidFill>
+          <a:ln>
+            <a:noFill/>
+          </a:ln>
+        </p:spPr>
+        <p:style>
+          <a:lnRef idx="1">
+            <a:schemeClr val="accent1"/>
+          </a:lnRef>
+          <a:fillRef idx="3">
+            <a:schemeClr val="accent1"/>
+          </a:fillRef>
+          <a:effectRef idx="2">
+            <a:schemeClr val="accent1"/>
+          </a:effectRef>
+          <a:fontRef idx="minor">
+            <a:schemeClr val="lt1"/>
+          </a:fontRef>
+        </p:style>
+        <p:txBody>
+          <a:bodyPr rtlCol="0" anchor="ctr"/>
+          <a:lstStyle/>
+          <a:p>
+            <a:pPr algn="ctr"/>
+          </a:p>
+        </p:txBody>
+      </p:sp>
+      <p:sp>
+        <p:nvSpPr>
+          <p:cNvPr id="20" name="TextBox 19"/>
+          <p:cNvSpPr txBox="1"/>
+          <p:nvPr/>
+        </p:nvSpPr>
+        <p:spPr>
+          <a:xfrm>
+            <a:off x="4495800" y="3975100"/>
+            <a:ext cx="7137400" cy="215900"/>
           </a:xfrm>
           <a:prstGeom prst="rect">
             <a:avLst/>
@@ -14883,7 +16670,7 @@
       </p:sp>
       <p:pic>
         <p:nvPicPr>
-          <p:cNvPr id="20" name="Picture 19" descr="CAM_08_MD_Office_B.jpg"/>
+          <p:cNvPr id="21" name="Picture 20" descr="CAM_08_MD_Office_B.jpg"/>
           <p:cNvPicPr>
             <a:picLocks noChangeAspect="1"/>
           </p:cNvPicPr>
@@ -14908,14 +16695,59 @@
       </p:pic>
       <p:sp>
         <p:nvSpPr>
-          <p:cNvPr id="21" name="TextBox 20"/>
-          <p:cNvSpPr txBox="1"/>
-          <p:nvPr/>
-        </p:nvSpPr>
-        <p:spPr>
-          <a:xfrm>
-            <a:off x="4508500" y="6134100"/>
-            <a:ext cx="3441700" cy="190500"/>
+          <p:cNvPr id="22" name="Rectangle 21"/>
+          <p:cNvSpPr/>
+          <p:nvPr/>
+        </p:nvSpPr>
+        <p:spPr>
+          <a:xfrm>
+            <a:off x="4445000" y="6096000"/>
+            <a:ext cx="3067050" cy="254000"/>
+          </a:xfrm>
+          <a:prstGeom prst="rect">
+            <a:avLst/>
+          </a:prstGeom>
+          <a:solidFill>
+            <a:srgbClr val="141412">
+              <a:alpha val="62000"/>
+            </a:srgbClr>
+          </a:solidFill>
+          <a:ln>
+            <a:noFill/>
+          </a:ln>
+        </p:spPr>
+        <p:style>
+          <a:lnRef idx="1">
+            <a:schemeClr val="accent1"/>
+          </a:lnRef>
+          <a:fillRef idx="3">
+            <a:schemeClr val="accent1"/>
+          </a:fillRef>
+          <a:effectRef idx="2">
+            <a:schemeClr val="accent1"/>
+          </a:effectRef>
+          <a:fontRef idx="minor">
+            <a:schemeClr val="lt1"/>
+          </a:fontRef>
+        </p:style>
+        <p:txBody>
+          <a:bodyPr rtlCol="0" anchor="ctr"/>
+          <a:lstStyle/>
+          <a:p>
+            <a:pPr algn="ctr"/>
+          </a:p>
+        </p:txBody>
+      </p:sp>
+      <p:sp>
+        <p:nvSpPr>
+          <p:cNvPr id="23" name="TextBox 22"/>
+          <p:cNvSpPr txBox="1"/>
+          <p:nvPr/>
+        </p:nvSpPr>
+        <p:spPr>
+          <a:xfrm>
+            <a:off x="4495800" y="6108700"/>
+            <a:ext cx="3467100" cy="215900"/>
           </a:xfrm>
           <a:prstGeom prst="rect">
             <a:avLst/>
@@ -14942,7 +16774,7 @@
       </p:sp>
       <p:pic>
         <p:nvPicPr>
-          <p:cNvPr id="22" name="Picture 21" descr="CAM_17_Executive_Reception.jpg"/>
+          <p:cNvPr id="24" name="Picture 23" descr="CAM_17_Executive_Reception.jpg"/>
           <p:cNvPicPr>
             <a:picLocks noChangeAspect="1"/>
           </p:cNvPicPr>
@@ -14967,14 +16799,59 @@
       </p:pic>
       <p:sp>
         <p:nvSpPr>
-          <p:cNvPr id="23" name="TextBox 22"/>
-          <p:cNvSpPr txBox="1"/>
-          <p:nvPr/>
-        </p:nvSpPr>
-        <p:spPr>
-          <a:xfrm>
-            <a:off x="8178800" y="6134100"/>
-            <a:ext cx="3441700" cy="190500"/>
+          <p:cNvPr id="25" name="Rectangle 24"/>
+          <p:cNvSpPr/>
+          <p:nvPr/>
+        </p:nvSpPr>
+        <p:spPr>
+          <a:xfrm>
+            <a:off x="8115300" y="6096000"/>
+            <a:ext cx="2997200" cy="254000"/>
+          </a:xfrm>
+          <a:prstGeom prst="rect">
+            <a:avLst/>
+          </a:prstGeom>
+          <a:solidFill>
+            <a:srgbClr val="141412">
+              <a:alpha val="62000"/>
+            </a:srgbClr>
+          </a:solidFill>
+          <a:ln>
+            <a:noFill/>
+          </a:ln>
+        </p:spPr>
+        <p:style>
+          <a:lnRef idx="1">
+            <a:schemeClr val="accent1"/>
+          </a:lnRef>
+          <a:fillRef idx="3">
+            <a:schemeClr val="accent1"/>
+          </a:fillRef>
+          <a:effectRef idx="2">
+            <a:schemeClr val="accent1"/>
+          </a:effectRef>
+          <a:fontRef idx="minor">
+            <a:schemeClr val="lt1"/>
+          </a:fontRef>
+        </p:style>
+        <p:txBody>
+          <a:bodyPr rtlCol="0" anchor="ctr"/>
+          <a:lstStyle/>
+          <a:p>
+            <a:pPr algn="ctr"/>
+          </a:p>
+        </p:txBody>
+      </p:sp>
+      <p:sp>
+        <p:nvSpPr>
+          <p:cNvPr id="26" name="TextBox 25"/>
+          <p:cNvSpPr txBox="1"/>
+          <p:nvPr/>
+        </p:nvSpPr>
+        <p:spPr>
+          <a:xfrm>
+            <a:off x="8166100" y="6108700"/>
+            <a:ext cx="3467100" cy="215900"/>
           </a:xfrm>
           <a:prstGeom prst="rect">
             <a:avLst/>
@@ -15001,7 +16878,7 @@
       </p:sp>
       <p:sp>
         <p:nvSpPr>
-          <p:cNvPr id="24" name="TextBox 23"/>
+          <p:cNvPr id="27" name="TextBox 26"/>
           <p:cNvSpPr txBox="1"/>
           <p:nvPr/>
         </p:nvSpPr>
@@ -15035,7 +16912,7 @@
       </p:sp>
       <p:sp>
         <p:nvSpPr>
-          <p:cNvPr id="25" name="TextBox 24"/>
+          <p:cNvPr id="28" name="TextBox 27"/>
           <p:cNvSpPr txBox="1"/>
           <p:nvPr/>
         </p:nvSpPr>

</xml_diff>